<commit_message>
Turn Task 1 slide 7 into a conceptual ERD
Entities as rectangles with key attributes, relationships as labelled
diamonds, and 1/n cardinality on every link, plus a notation legend that
points to Task 2 for the detailed ERD. Scripts and READMEs updated to match.

Co-Authored-By: Claude Opus 5.5 <noreply@anthropic.com>
Claude-Session: https://claude.ai/code/session_01Nd7HZKgsHFz3NCndSJLPaG
</commit_message>
<xml_diff>
--- a/bai_tap_python_nhom8/task1_nguyen_phan_khanh_vy/2431540032_NguyenPhanKhanhVy.pptx
+++ b/bai_tap_python_nhom8/task1_nguyen_phan_khanh_vy/2431540032_NguyenPhanKhanhVy.pptx
@@ -116,13 +116,13 @@
   <p:extLst>
     <p:ext uri="{521415D9-36F7-43E2-AB2F-B90AF26B5E84}">
       <p14:sectionLst xmlns:p14="http://schemas.microsoft.com/office/powerpoint/2010/main">
-        <p14:section name="Mở đầu" id="{8a70ce45-7028-5d97-cca7-c12d49e739e7}">
+        <p14:section name="Mở đầu" id="{d43f8c18-b541-1d5d-9a09-bc14d5046628}">
           <p14:sldIdLst>
             <p14:sldId id="256"/>
             <p14:sldId id="257"/>
           </p14:sldIdLst>
         </p14:section>
-        <p14:section name="Phân tích &amp; ETL" id="{f9ab1483-31a3-ed71-8f7d-13a311499164}">
+        <p14:section name="Phân tích &amp; ETL" id="{229e7f99-d775-3e62-fa16-f8a769df537e}">
           <p14:sldIdLst>
             <p14:sldId id="258"/>
             <p14:sldId id="259"/>
@@ -130,13 +130,13 @@
             <p14:sldId id="261"/>
           </p14:sldIdLst>
         </p14:section>
-        <p14:section name="Kiến trúc" id="{c68ae14b-6a07-2631-48a3-5787a2e584a4}">
+        <p14:section name="Kiến trúc" id="{46db5439-34bb-13dd-239c-da25ad6eb077}">
           <p14:sldIdLst>
             <p14:sldId id="262"/>
             <p14:sldId id="263"/>
           </p14:sldIdLst>
         </p14:section>
-        <p14:section name="Kết quả &amp; tổng kết" id="{d981561e-78bf-e677-1b3c-5ce6fd08c878}">
+        <p14:section name="Kết quả &amp; tổng kết" id="{74446561-a375-5c3b-acbe-6c789a9d450e}">
           <p14:sldIdLst>
             <p14:sldId id="264"/>
             <p14:sldId id="265"/>
@@ -1498,7 +1498,7 @@
           <a:p>
             <a:r>
               <a:rPr lang="en-US" dirty="0"/>
-              <a:t>Cơ sở dữ liệu thiết kế theo hình ngôi sao: bảng Hồ sơ ứng tuyển ở giữa, nối với các bảng Ứng viên, Vị trí, Nguồn và Vòng tuyển. Nhờ vậy muốn biết bao nhiêu người qua vòng phỏng vấn hay nguồn nào tốt nhất chỉ cần một câu truy vấn đơn giản.</a:t>
+              <a:t>Đây là sơ đồ ERD mức khái niệm: hình chữ nhật là thực thể, hình thoi là mối liên kết, số 1 và chữ n là quan hệ một – nhiều. Ví dụ một ứng viên nộp nhiều hồ sơ, một vị trí nhận nhiều hồ sơ, nên Hồ sơ ứng tuyển nằm ở giữa theo hình ngôi sao và đếm số người qua từng vòng chỉ cần một câu truy vấn. ERD chi tiết với từng cột và khóa ngoại do bạn Hoàng trình bày ở Task 2.</a:t>
             </a:r>
             <a:endParaRPr lang="en-US" dirty="0"/>
           </a:p>
@@ -9376,7 +9376,7 @@
                 <a:ea typeface="Cambria" pitchFamily="34" charset="-122"/>
                 <a:cs typeface="Cambria" pitchFamily="34" charset="-120"/>
               </a:rPr>
-              <a:t>Thiết kế cơ sở dữ liệu PostgreSQL</a:t>
+              <a:t>Sơ đồ ERD của cơ sở dữ liệu (mức khái niệm)</a:t>
             </a:r>
             <a:endParaRPr lang="en-US" sz="3200" dirty="0"/>
           </a:p>
@@ -9384,14 +9384,14 @@
       </p:sp>
       <p:sp>
         <p:nvSpPr>
-          <p:cNvPr id="3" name="Relation line"/>
+          <p:cNvPr id="3" name="Relationship line nộp"/>
           <p:cNvSpPr/>
           <p:nvPr/>
         </p:nvSpPr>
         <p:spPr>
           <a:xfrm>
-            <a:off x="1623060" y="2057400"/>
-            <a:ext cx="2583180" cy="1417320"/>
+            <a:off x="2926080" y="2029968"/>
+            <a:ext cx="1828800" cy="896112"/>
           </a:xfrm>
           <a:prstGeom prst="line">
             <a:avLst/>
@@ -9407,14 +9407,147 @@
       </p:sp>
       <p:sp>
         <p:nvSpPr>
-          <p:cNvPr id="4" name="Relation line"/>
+          <p:cNvPr id="4" name="Relationship nộp"/>
           <p:cNvSpPr/>
           <p:nvPr/>
         </p:nvSpPr>
         <p:spPr>
+          <a:xfrm>
+            <a:off x="3246120" y="2194560"/>
+            <a:ext cx="1188720" cy="566928"/>
+          </a:xfrm>
+          <a:prstGeom prst="diamond">
+            <a:avLst/>
+          </a:prstGeom>
+          <a:solidFill>
+            <a:schemeClr val="bg1"/>
+          </a:solidFill>
+          <a:ln w="19050">
+            <a:solidFill>
+              <a:schemeClr val="accent1"/>
+            </a:solidFill>
+            <a:prstDash val="solid"/>
+          </a:ln>
+        </p:spPr>
+      </p:sp>
+      <p:sp>
+        <p:nvSpPr>
+          <p:cNvPr id="5" name="Relationship label nộp"/>
+          <p:cNvSpPr txBox="1"/>
+          <p:nvPr/>
+        </p:nvSpPr>
+        <p:spPr>
+          <a:xfrm>
+            <a:off x="3246120" y="2194560"/>
+            <a:ext cx="1188720" cy="566928"/>
+          </a:xfrm>
+          <a:prstGeom prst="rect">
+            <a:avLst/>
+          </a:prstGeom>
+          <a:noFill/>
+          <a:ln/>
+        </p:spPr>
+        <p:txBody>
+          <a:bodyPr wrap="square" lIns="0" tIns="0" rIns="0" bIns="0" rtlCol="0" anchor="ctr"/>
+          <a:lstStyle/>
+          <a:p>
+            <a:pPr algn="ctr" indent="0" marL="0">
+              <a:buNone/>
+            </a:pPr>
+            <a:r>
+              <a:rPr lang="en-US" sz="1400" b="1" i="1" dirty="0">
+                <a:solidFill>
+                  <a:schemeClr val="tx2"/>
+                </a:solidFill>
+              </a:rPr>
+              <a:t>nộp</a:t>
+            </a:r>
+            <a:endParaRPr lang="en-US" sz="1400" dirty="0"/>
+          </a:p>
+        </p:txBody>
+      </p:sp>
+      <p:sp>
+        <p:nvSpPr>
+          <p:cNvPr id="6" name="Cardinality 1"/>
+          <p:cNvSpPr txBox="1"/>
+          <p:nvPr/>
+        </p:nvSpPr>
+        <p:spPr>
+          <a:xfrm>
+            <a:off x="2971800" y="1783080"/>
+            <a:ext cx="201168" cy="201168"/>
+          </a:xfrm>
+          <a:prstGeom prst="rect">
+            <a:avLst/>
+          </a:prstGeom>
+          <a:noFill/>
+          <a:ln/>
+        </p:spPr>
+        <p:txBody>
+          <a:bodyPr wrap="square" lIns="0" tIns="0" rIns="0" bIns="0" rtlCol="0" anchor="ctr"/>
+          <a:lstStyle/>
+          <a:p>
+            <a:pPr algn="ctr" indent="0" marL="0">
+              <a:buNone/>
+            </a:pPr>
+            <a:r>
+              <a:rPr lang="en-US" sz="1400" b="1" dirty="0">
+                <a:solidFill>
+                  <a:schemeClr val="tx2"/>
+                </a:solidFill>
+              </a:rPr>
+              <a:t>1</a:t>
+            </a:r>
+            <a:endParaRPr lang="en-US" sz="1400" dirty="0"/>
+          </a:p>
+        </p:txBody>
+      </p:sp>
+      <p:sp>
+        <p:nvSpPr>
+          <p:cNvPr id="7" name="Cardinality n"/>
+          <p:cNvSpPr txBox="1"/>
+          <p:nvPr/>
+        </p:nvSpPr>
+        <p:spPr>
+          <a:xfrm>
+            <a:off x="4526280" y="2578608"/>
+            <a:ext cx="201168" cy="201168"/>
+          </a:xfrm>
+          <a:prstGeom prst="rect">
+            <a:avLst/>
+          </a:prstGeom>
+          <a:noFill/>
+          <a:ln/>
+        </p:spPr>
+        <p:txBody>
+          <a:bodyPr wrap="square" lIns="0" tIns="0" rIns="0" bIns="0" rtlCol="0" anchor="ctr"/>
+          <a:lstStyle/>
+          <a:p>
+            <a:pPr algn="ctr" indent="0" marL="0">
+              <a:buNone/>
+            </a:pPr>
+            <a:r>
+              <a:rPr lang="en-US" sz="1400" b="1" dirty="0">
+                <a:solidFill>
+                  <a:schemeClr val="tx2"/>
+                </a:solidFill>
+              </a:rPr>
+              <a:t>n</a:t>
+            </a:r>
+            <a:endParaRPr lang="en-US" sz="1400" dirty="0"/>
+          </a:p>
+        </p:txBody>
+      </p:sp>
+      <p:sp>
+        <p:nvSpPr>
+          <p:cNvPr id="8" name="Relationship line mang về"/>
+          <p:cNvSpPr/>
+          <p:nvPr/>
+        </p:nvSpPr>
+        <p:spPr>
           <a:xfrm flipV="1">
-            <a:off x="4206240" y="2057400"/>
-            <a:ext cx="2583180" cy="1417320"/>
+            <a:off x="2926080" y="3383280"/>
+            <a:ext cx="1828800" cy="1024128"/>
           </a:xfrm>
           <a:prstGeom prst="line">
             <a:avLst/>
@@ -9430,14 +9563,147 @@
       </p:sp>
       <p:sp>
         <p:nvSpPr>
-          <p:cNvPr id="5" name="Relation line"/>
+          <p:cNvPr id="9" name="Relationship mang về"/>
           <p:cNvSpPr/>
           <p:nvPr/>
         </p:nvSpPr>
         <p:spPr>
+          <a:xfrm>
+            <a:off x="3246120" y="3611880"/>
+            <a:ext cx="1188720" cy="566928"/>
+          </a:xfrm>
+          <a:prstGeom prst="diamond">
+            <a:avLst/>
+          </a:prstGeom>
+          <a:solidFill>
+            <a:schemeClr val="bg1"/>
+          </a:solidFill>
+          <a:ln w="19050">
+            <a:solidFill>
+              <a:schemeClr val="accent1"/>
+            </a:solidFill>
+            <a:prstDash val="solid"/>
+          </a:ln>
+        </p:spPr>
+      </p:sp>
+      <p:sp>
+        <p:nvSpPr>
+          <p:cNvPr id="10" name="Relationship label mang về"/>
+          <p:cNvSpPr txBox="1"/>
+          <p:nvPr/>
+        </p:nvSpPr>
+        <p:spPr>
+          <a:xfrm>
+            <a:off x="3246120" y="3611880"/>
+            <a:ext cx="1188720" cy="566928"/>
+          </a:xfrm>
+          <a:prstGeom prst="rect">
+            <a:avLst/>
+          </a:prstGeom>
+          <a:noFill/>
+          <a:ln/>
+        </p:spPr>
+        <p:txBody>
+          <a:bodyPr wrap="square" lIns="0" tIns="0" rIns="0" bIns="0" rtlCol="0" anchor="ctr"/>
+          <a:lstStyle/>
+          <a:p>
+            <a:pPr algn="ctr" indent="0" marL="0">
+              <a:buNone/>
+            </a:pPr>
+            <a:r>
+              <a:rPr lang="en-US" sz="1400" b="1" i="1" dirty="0">
+                <a:solidFill>
+                  <a:schemeClr val="tx2"/>
+                </a:solidFill>
+              </a:rPr>
+              <a:t>mang về</a:t>
+            </a:r>
+            <a:endParaRPr lang="en-US" sz="1400" dirty="0"/>
+          </a:p>
+        </p:txBody>
+      </p:sp>
+      <p:sp>
+        <p:nvSpPr>
+          <p:cNvPr id="11" name="Cardinality 1"/>
+          <p:cNvSpPr txBox="1"/>
+          <p:nvPr/>
+        </p:nvSpPr>
+        <p:spPr>
+          <a:xfrm>
+            <a:off x="2971800" y="4453128"/>
+            <a:ext cx="201168" cy="201168"/>
+          </a:xfrm>
+          <a:prstGeom prst="rect">
+            <a:avLst/>
+          </a:prstGeom>
+          <a:noFill/>
+          <a:ln/>
+        </p:spPr>
+        <p:txBody>
+          <a:bodyPr wrap="square" lIns="0" tIns="0" rIns="0" bIns="0" rtlCol="0" anchor="ctr"/>
+          <a:lstStyle/>
+          <a:p>
+            <a:pPr algn="ctr" indent="0" marL="0">
+              <a:buNone/>
+            </a:pPr>
+            <a:r>
+              <a:rPr lang="en-US" sz="1400" b="1" dirty="0">
+                <a:solidFill>
+                  <a:schemeClr val="tx2"/>
+                </a:solidFill>
+              </a:rPr>
+              <a:t>1</a:t>
+            </a:r>
+            <a:endParaRPr lang="en-US" sz="1400" dirty="0"/>
+          </a:p>
+        </p:txBody>
+      </p:sp>
+      <p:sp>
+        <p:nvSpPr>
+          <p:cNvPr id="12" name="Cardinality n"/>
+          <p:cNvSpPr txBox="1"/>
+          <p:nvPr/>
+        </p:nvSpPr>
+        <p:spPr>
+          <a:xfrm>
+            <a:off x="4526280" y="3547872"/>
+            <a:ext cx="201168" cy="201168"/>
+          </a:xfrm>
+          <a:prstGeom prst="rect">
+            <a:avLst/>
+          </a:prstGeom>
+          <a:noFill/>
+          <a:ln/>
+        </p:spPr>
+        <p:txBody>
+          <a:bodyPr wrap="square" lIns="0" tIns="0" rIns="0" bIns="0" rtlCol="0" anchor="ctr"/>
+          <a:lstStyle/>
+          <a:p>
+            <a:pPr algn="ctr" indent="0" marL="0">
+              <a:buNone/>
+            </a:pPr>
+            <a:r>
+              <a:rPr lang="en-US" sz="1400" b="1" dirty="0">
+                <a:solidFill>
+                  <a:schemeClr val="tx2"/>
+                </a:solidFill>
+              </a:rPr>
+              <a:t>n</a:t>
+            </a:r>
+            <a:endParaRPr lang="en-US" sz="1400" dirty="0"/>
+          </a:p>
+        </p:txBody>
+      </p:sp>
+      <p:sp>
+        <p:nvSpPr>
+          <p:cNvPr id="13" name="Relationship line nhận"/>
+          <p:cNvSpPr/>
+          <p:nvPr/>
+        </p:nvSpPr>
+        <p:spPr>
           <a:xfrm flipV="1">
-            <a:off x="1623060" y="3474720"/>
-            <a:ext cx="2583180" cy="1783080"/>
+            <a:off x="7452360" y="2029968"/>
+            <a:ext cx="1810512" cy="896112"/>
           </a:xfrm>
           <a:prstGeom prst="line">
             <a:avLst/>
@@ -9453,14 +9719,147 @@
       </p:sp>
       <p:sp>
         <p:nvSpPr>
-          <p:cNvPr id="6" name="Relation line"/>
+          <p:cNvPr id="14" name="Relationship nhận"/>
           <p:cNvSpPr/>
           <p:nvPr/>
         </p:nvSpPr>
         <p:spPr>
           <a:xfrm>
-            <a:off x="4206240" y="3474720"/>
-            <a:ext cx="2583180" cy="1783080"/>
+            <a:off x="7763256" y="2194560"/>
+            <a:ext cx="1188720" cy="566928"/>
+          </a:xfrm>
+          <a:prstGeom prst="diamond">
+            <a:avLst/>
+          </a:prstGeom>
+          <a:solidFill>
+            <a:schemeClr val="bg1"/>
+          </a:solidFill>
+          <a:ln w="19050">
+            <a:solidFill>
+              <a:schemeClr val="accent1"/>
+            </a:solidFill>
+            <a:prstDash val="solid"/>
+          </a:ln>
+        </p:spPr>
+      </p:sp>
+      <p:sp>
+        <p:nvSpPr>
+          <p:cNvPr id="15" name="Relationship label nhận"/>
+          <p:cNvSpPr txBox="1"/>
+          <p:nvPr/>
+        </p:nvSpPr>
+        <p:spPr>
+          <a:xfrm>
+            <a:off x="7763256" y="2194560"/>
+            <a:ext cx="1188720" cy="566928"/>
+          </a:xfrm>
+          <a:prstGeom prst="rect">
+            <a:avLst/>
+          </a:prstGeom>
+          <a:noFill/>
+          <a:ln/>
+        </p:spPr>
+        <p:txBody>
+          <a:bodyPr wrap="square" lIns="0" tIns="0" rIns="0" bIns="0" rtlCol="0" anchor="ctr"/>
+          <a:lstStyle/>
+          <a:p>
+            <a:pPr algn="ctr" indent="0" marL="0">
+              <a:buNone/>
+            </a:pPr>
+            <a:r>
+              <a:rPr lang="en-US" sz="1400" b="1" i="1" dirty="0">
+                <a:solidFill>
+                  <a:schemeClr val="tx2"/>
+                </a:solidFill>
+              </a:rPr>
+              <a:t>nhận</a:t>
+            </a:r>
+            <a:endParaRPr lang="en-US" sz="1400" dirty="0"/>
+          </a:p>
+        </p:txBody>
+      </p:sp>
+      <p:sp>
+        <p:nvSpPr>
+          <p:cNvPr id="16" name="Cardinality 1"/>
+          <p:cNvSpPr txBox="1"/>
+          <p:nvPr/>
+        </p:nvSpPr>
+        <p:spPr>
+          <a:xfrm>
+            <a:off x="9034272" y="1810512"/>
+            <a:ext cx="201168" cy="201168"/>
+          </a:xfrm>
+          <a:prstGeom prst="rect">
+            <a:avLst/>
+          </a:prstGeom>
+          <a:noFill/>
+          <a:ln/>
+        </p:spPr>
+        <p:txBody>
+          <a:bodyPr wrap="square" lIns="0" tIns="0" rIns="0" bIns="0" rtlCol="0" anchor="ctr"/>
+          <a:lstStyle/>
+          <a:p>
+            <a:pPr algn="ctr" indent="0" marL="0">
+              <a:buNone/>
+            </a:pPr>
+            <a:r>
+              <a:rPr lang="en-US" sz="1400" b="1" dirty="0">
+                <a:solidFill>
+                  <a:schemeClr val="tx2"/>
+                </a:solidFill>
+              </a:rPr>
+              <a:t>1</a:t>
+            </a:r>
+            <a:endParaRPr lang="en-US" sz="1400" dirty="0"/>
+          </a:p>
+        </p:txBody>
+      </p:sp>
+      <p:sp>
+        <p:nvSpPr>
+          <p:cNvPr id="17" name="Cardinality n"/>
+          <p:cNvSpPr txBox="1"/>
+          <p:nvPr/>
+        </p:nvSpPr>
+        <p:spPr>
+          <a:xfrm>
+            <a:off x="7479792" y="2578608"/>
+            <a:ext cx="201168" cy="201168"/>
+          </a:xfrm>
+          <a:prstGeom prst="rect">
+            <a:avLst/>
+          </a:prstGeom>
+          <a:noFill/>
+          <a:ln/>
+        </p:spPr>
+        <p:txBody>
+          <a:bodyPr wrap="square" lIns="0" tIns="0" rIns="0" bIns="0" rtlCol="0" anchor="ctr"/>
+          <a:lstStyle/>
+          <a:p>
+            <a:pPr algn="ctr" indent="0" marL="0">
+              <a:buNone/>
+            </a:pPr>
+            <a:r>
+              <a:rPr lang="en-US" sz="1400" b="1" dirty="0">
+                <a:solidFill>
+                  <a:schemeClr val="tx2"/>
+                </a:solidFill>
+              </a:rPr>
+              <a:t>n</a:t>
+            </a:r>
+            <a:endParaRPr lang="en-US" sz="1400" dirty="0"/>
+          </a:p>
+        </p:txBody>
+      </p:sp>
+      <p:sp>
+        <p:nvSpPr>
+          <p:cNvPr id="18" name="Relationship line có"/>
+          <p:cNvSpPr/>
+          <p:nvPr/>
+        </p:nvSpPr>
+        <p:spPr>
+          <a:xfrm>
+            <a:off x="7452360" y="3383280"/>
+            <a:ext cx="1810512" cy="1161288"/>
           </a:xfrm>
           <a:prstGeom prst="line">
             <a:avLst/>
@@ -9476,19 +9875,150 @@
       </p:sp>
       <p:sp>
         <p:nvSpPr>
-          <p:cNvPr id="7" name="Ứng viên box"/>
+          <p:cNvPr id="19" name="Relationship có"/>
           <p:cNvSpPr/>
           <p:nvPr/>
         </p:nvSpPr>
         <p:spPr>
           <a:xfrm>
+            <a:off x="7763256" y="3680460"/>
+            <a:ext cx="1188720" cy="566928"/>
+          </a:xfrm>
+          <a:prstGeom prst="diamond">
+            <a:avLst/>
+          </a:prstGeom>
+          <a:solidFill>
+            <a:schemeClr val="bg1"/>
+          </a:solidFill>
+          <a:ln w="19050">
+            <a:solidFill>
+              <a:schemeClr val="accent1"/>
+            </a:solidFill>
+            <a:prstDash val="solid"/>
+          </a:ln>
+        </p:spPr>
+      </p:sp>
+      <p:sp>
+        <p:nvSpPr>
+          <p:cNvPr id="20" name="Relationship label có"/>
+          <p:cNvSpPr txBox="1"/>
+          <p:nvPr/>
+        </p:nvSpPr>
+        <p:spPr>
+          <a:xfrm>
+            <a:off x="7763256" y="3680460"/>
+            <a:ext cx="1188720" cy="566928"/>
+          </a:xfrm>
+          <a:prstGeom prst="rect">
+            <a:avLst/>
+          </a:prstGeom>
+          <a:noFill/>
+          <a:ln/>
+        </p:spPr>
+        <p:txBody>
+          <a:bodyPr wrap="square" lIns="0" tIns="0" rIns="0" bIns="0" rtlCol="0" anchor="ctr"/>
+          <a:lstStyle/>
+          <a:p>
+            <a:pPr algn="ctr" indent="0" marL="0">
+              <a:buNone/>
+            </a:pPr>
+            <a:r>
+              <a:rPr lang="en-US" sz="1400" b="1" i="1" dirty="0">
+                <a:solidFill>
+                  <a:schemeClr val="tx2"/>
+                </a:solidFill>
+              </a:rPr>
+              <a:t>có</a:t>
+            </a:r>
+            <a:endParaRPr lang="en-US" sz="1400" dirty="0"/>
+          </a:p>
+        </p:txBody>
+      </p:sp>
+      <p:sp>
+        <p:nvSpPr>
+          <p:cNvPr id="21" name="Cardinality 1"/>
+          <p:cNvSpPr txBox="1"/>
+          <p:nvPr/>
+        </p:nvSpPr>
+        <p:spPr>
+          <a:xfrm>
+            <a:off x="9034272" y="4169664"/>
+            <a:ext cx="201168" cy="201168"/>
+          </a:xfrm>
+          <a:prstGeom prst="rect">
+            <a:avLst/>
+          </a:prstGeom>
+          <a:noFill/>
+          <a:ln/>
+        </p:spPr>
+        <p:txBody>
+          <a:bodyPr wrap="square" lIns="0" tIns="0" rIns="0" bIns="0" rtlCol="0" anchor="ctr"/>
+          <a:lstStyle/>
+          <a:p>
+            <a:pPr algn="ctr" indent="0" marL="0">
+              <a:buNone/>
+            </a:pPr>
+            <a:r>
+              <a:rPr lang="en-US" sz="1400" b="1" dirty="0">
+                <a:solidFill>
+                  <a:schemeClr val="tx2"/>
+                </a:solidFill>
+              </a:rPr>
+              <a:t>1</a:t>
+            </a:r>
+            <a:endParaRPr lang="en-US" sz="1400" dirty="0"/>
+          </a:p>
+        </p:txBody>
+      </p:sp>
+      <p:sp>
+        <p:nvSpPr>
+          <p:cNvPr id="22" name="Cardinality n"/>
+          <p:cNvSpPr txBox="1"/>
+          <p:nvPr/>
+        </p:nvSpPr>
+        <p:spPr>
+          <a:xfrm>
+            <a:off x="7479792" y="3154680"/>
+            <a:ext cx="201168" cy="201168"/>
+          </a:xfrm>
+          <a:prstGeom prst="rect">
+            <a:avLst/>
+          </a:prstGeom>
+          <a:noFill/>
+          <a:ln/>
+        </p:spPr>
+        <p:txBody>
+          <a:bodyPr wrap="square" lIns="0" tIns="0" rIns="0" bIns="0" rtlCol="0" anchor="ctr"/>
+          <a:lstStyle/>
+          <a:p>
+            <a:pPr algn="ctr" indent="0" marL="0">
+              <a:buNone/>
+            </a:pPr>
+            <a:r>
+              <a:rPr lang="en-US" sz="1400" b="1" dirty="0">
+                <a:solidFill>
+                  <a:schemeClr val="tx2"/>
+                </a:solidFill>
+              </a:rPr>
+              <a:t>n</a:t>
+            </a:r>
+            <a:endParaRPr lang="en-US" sz="1400" dirty="0"/>
+          </a:p>
+        </p:txBody>
+      </p:sp>
+      <p:sp>
+        <p:nvSpPr>
+          <p:cNvPr id="23" name="Ứng viên entity"/>
+          <p:cNvSpPr/>
+          <p:nvPr/>
+        </p:nvSpPr>
+        <p:spPr>
+          <a:xfrm>
             <a:off x="548640" y="1371600"/>
-            <a:ext cx="2148840" cy="1371600"/>
-          </a:xfrm>
-          <a:prstGeom prst="roundRect">
-            <a:avLst>
-              <a:gd name="adj" fmla="val 6667"/>
-            </a:avLst>
+            <a:ext cx="2377440" cy="1316736"/>
+          </a:xfrm>
+          <a:prstGeom prst="rect">
+            <a:avLst/>
           </a:prstGeom>
           <a:solidFill>
             <a:schemeClr val="bg2"/>
@@ -9503,63 +10033,52 @@
       </p:sp>
       <p:sp>
         <p:nvSpPr>
-          <p:cNvPr id="8" name="Ứng viên circle"/>
-          <p:cNvSpPr/>
-          <p:nvPr/>
-        </p:nvSpPr>
-        <p:spPr>
-          <a:xfrm>
-            <a:off x="685800" y="1508760"/>
-            <a:ext cx="457200" cy="457200"/>
-          </a:xfrm>
-          <a:prstGeom prst="ellipse">
+          <p:cNvPr id="24" name="Ứng viên header"/>
+          <p:cNvSpPr txBox="1"/>
+          <p:nvPr/>
+        </p:nvSpPr>
+        <p:spPr>
+          <a:xfrm>
+            <a:off x="548640" y="1371600"/>
+            <a:ext cx="2377440" cy="384048"/>
+          </a:xfrm>
+          <a:prstGeom prst="rect">
             <a:avLst/>
           </a:prstGeom>
           <a:solidFill>
             <a:schemeClr val="accent1"/>
           </a:solidFill>
-          <a:ln w="12700">
-            <a:solidFill>
-              <a:schemeClr val="accent1"/>
-            </a:solidFill>
-            <a:prstDash val="solid"/>
-          </a:ln>
-        </p:spPr>
-      </p:sp>
-      <p:pic>
-        <p:nvPicPr>
-          <p:cNvPr id="9" name="Ứng viên icon" descr="Ứng viên">    </p:cNvPr>
-          <p:cNvPicPr>
-            <a:picLocks noChangeAspect="1"/>
-          </p:cNvPicPr>
-          <p:nvPr/>
-        </p:nvPicPr>
-        <p:blipFill>
-          <a:blip r:embed="rId1"/>
-          <a:stretch>
-            <a:fillRect/>
-          </a:stretch>
-        </p:blipFill>
-        <p:spPr>
-          <a:xfrm>
-            <a:off x="800100" y="1623060"/>
-            <a:ext cx="228600" cy="228600"/>
-          </a:xfrm>
-          <a:prstGeom prst="rect">
-            <a:avLst/>
-          </a:prstGeom>
-        </p:spPr>
-      </p:pic>
-      <p:sp>
-        <p:nvSpPr>
-          <p:cNvPr id="10" name="Ứng viên name"/>
+          <a:ln/>
+        </p:spPr>
+        <p:txBody>
+          <a:bodyPr wrap="square" lIns="0" tIns="0" rIns="0" bIns="0" rtlCol="0" anchor="ctr"/>
+          <a:lstStyle/>
+          <a:p>
+            <a:pPr algn="ctr" indent="0" marL="0">
+              <a:buNone/>
+            </a:pPr>
+            <a:r>
+              <a:rPr lang="en-US" sz="1500" b="1" dirty="0">
+                <a:solidFill>
+                  <a:schemeClr val="bg1"/>
+                </a:solidFill>
+              </a:rPr>
+              <a:t>Ứng viên</a:t>
+            </a:r>
+            <a:endParaRPr lang="en-US" sz="1500" dirty="0"/>
+          </a:p>
+        </p:txBody>
+      </p:sp>
+      <p:sp>
+        <p:nvSpPr>
+          <p:cNvPr id="25" name="Ứng viên attr 1"/>
           <p:cNvSpPr txBox="1"/>
           <p:nvPr/>
         </p:nvSpPr>
         <p:spPr>
           <a:xfrm>
-            <a:off x="1234440" y="1508760"/>
-            <a:ext cx="1371600" cy="457200"/>
+            <a:off x="685800" y="1810512"/>
+            <a:ext cx="2103120" cy="274320"/>
           </a:xfrm>
           <a:prstGeom prst="rect">
             <a:avLst/>
@@ -9575,27 +10094,35 @@
               <a:buNone/>
             </a:pPr>
             <a:r>
-              <a:rPr lang="en-US" sz="1600" b="1" dirty="0">
-                <a:solidFill>
-                  <a:schemeClr val="tx2"/>
-                </a:solidFill>
-              </a:rPr>
-              <a:t>Ứng viên</a:t>
-            </a:r>
-            <a:endParaRPr lang="en-US" sz="1600" dirty="0"/>
-          </a:p>
-        </p:txBody>
-      </p:sp>
-      <p:sp>
-        <p:nvSpPr>
-          <p:cNvPr id="11" name="Ứng viên fields"/>
+              <a:rPr lang="en-US" sz="1300" b="1" dirty="0">
+                <a:solidFill>
+                  <a:schemeClr val="accent3"/>
+                </a:solidFill>
+              </a:rPr>
+              <a:t>PK  </a:t>
+            </a:r>
+            <a:r>
+              <a:rPr lang="en-US" sz="1300" b="1" dirty="0">
+                <a:solidFill>
+                  <a:schemeClr val="tx1"/>
+                </a:solidFill>
+              </a:rPr>
+              <a:t>Mã ứng viên</a:t>
+            </a:r>
+            <a:endParaRPr lang="en-US" sz="1300" dirty="0"/>
+          </a:p>
+        </p:txBody>
+      </p:sp>
+      <p:sp>
+        <p:nvSpPr>
+          <p:cNvPr id="26" name="Ứng viên attr 2"/>
           <p:cNvSpPr txBox="1"/>
           <p:nvPr/>
         </p:nvSpPr>
         <p:spPr>
           <a:xfrm>
-            <a:off x="685800" y="2057400"/>
-            <a:ext cx="1874520" cy="594360"/>
+            <a:off x="685800" y="2084832"/>
+            <a:ext cx="2103120" cy="274320"/>
           </a:xfrm>
           <a:prstGeom prst="rect">
             <a:avLst/>
@@ -9616,7 +10143,7 @@
                   <a:schemeClr val="tx1"/>
                 </a:solidFill>
               </a:rPr>
-              <a:t>Họ tên · Email · SĐT</a:t>
+              <a:t>Họ tên</a:t>
             </a:r>
             <a:endParaRPr lang="en-US" sz="1300" dirty="0"/>
           </a:p>
@@ -9624,19 +10151,53 @@
       </p:sp>
       <p:sp>
         <p:nvSpPr>
-          <p:cNvPr id="12" name="Vị trí tuyển box"/>
+          <p:cNvPr id="27" name="Ứng viên attr 3"/>
+          <p:cNvSpPr txBox="1"/>
+          <p:nvPr/>
+        </p:nvSpPr>
+        <p:spPr>
+          <a:xfrm>
+            <a:off x="685800" y="2359152"/>
+            <a:ext cx="2103120" cy="274320"/>
+          </a:xfrm>
+          <a:prstGeom prst="rect">
+            <a:avLst/>
+          </a:prstGeom>
+          <a:noFill/>
+          <a:ln/>
+        </p:spPr>
+        <p:txBody>
+          <a:bodyPr wrap="square" lIns="0" tIns="0" rIns="0" bIns="0" rtlCol="0" anchor="ctr"/>
+          <a:lstStyle/>
+          <a:p>
+            <a:pPr indent="0" marL="0">
+              <a:buNone/>
+            </a:pPr>
+            <a:r>
+              <a:rPr lang="en-US" sz="1300" dirty="0">
+                <a:solidFill>
+                  <a:schemeClr val="tx1"/>
+                </a:solidFill>
+              </a:rPr>
+              <a:t>Email, SĐT</a:t>
+            </a:r>
+            <a:endParaRPr lang="en-US" sz="1300" dirty="0"/>
+          </a:p>
+        </p:txBody>
+      </p:sp>
+      <p:sp>
+        <p:nvSpPr>
+          <p:cNvPr id="28" name="Nguồn hồ sơ entity"/>
           <p:cNvSpPr/>
           <p:nvPr/>
         </p:nvSpPr>
         <p:spPr>
           <a:xfrm>
-            <a:off x="5715000" y="1371600"/>
-            <a:ext cx="2148840" cy="1371600"/>
-          </a:xfrm>
-          <a:prstGeom prst="roundRect">
-            <a:avLst>
-              <a:gd name="adj" fmla="val 6667"/>
-            </a:avLst>
+            <a:off x="548640" y="3886200"/>
+            <a:ext cx="2377440" cy="1042416"/>
+          </a:xfrm>
+          <a:prstGeom prst="rect">
+            <a:avLst/>
           </a:prstGeom>
           <a:solidFill>
             <a:schemeClr val="bg2"/>
@@ -9651,63 +10212,52 @@
       </p:sp>
       <p:sp>
         <p:nvSpPr>
-          <p:cNvPr id="13" name="Vị trí tuyển circle"/>
-          <p:cNvSpPr/>
-          <p:nvPr/>
-        </p:nvSpPr>
-        <p:spPr>
-          <a:xfrm>
-            <a:off x="5852160" y="1508760"/>
-            <a:ext cx="457200" cy="457200"/>
-          </a:xfrm>
-          <a:prstGeom prst="ellipse">
+          <p:cNvPr id="29" name="Nguồn hồ sơ header"/>
+          <p:cNvSpPr txBox="1"/>
+          <p:nvPr/>
+        </p:nvSpPr>
+        <p:spPr>
+          <a:xfrm>
+            <a:off x="548640" y="3886200"/>
+            <a:ext cx="2377440" cy="384048"/>
+          </a:xfrm>
+          <a:prstGeom prst="rect">
             <a:avLst/>
           </a:prstGeom>
           <a:solidFill>
             <a:schemeClr val="accent1"/>
           </a:solidFill>
-          <a:ln w="12700">
-            <a:solidFill>
-              <a:schemeClr val="accent1"/>
-            </a:solidFill>
-            <a:prstDash val="solid"/>
-          </a:ln>
-        </p:spPr>
-      </p:sp>
-      <p:pic>
-        <p:nvPicPr>
-          <p:cNvPr id="14" name="Vị trí tuyển icon" descr="Vị trí tuyển">    </p:cNvPr>
-          <p:cNvPicPr>
-            <a:picLocks noChangeAspect="1"/>
-          </p:cNvPicPr>
-          <p:nvPr/>
-        </p:nvPicPr>
-        <p:blipFill>
-          <a:blip r:embed="rId2"/>
-          <a:stretch>
-            <a:fillRect/>
-          </a:stretch>
-        </p:blipFill>
-        <p:spPr>
-          <a:xfrm>
-            <a:off x="5966460" y="1623060"/>
-            <a:ext cx="228600" cy="228600"/>
-          </a:xfrm>
-          <a:prstGeom prst="rect">
-            <a:avLst/>
-          </a:prstGeom>
-        </p:spPr>
-      </p:pic>
-      <p:sp>
-        <p:nvSpPr>
-          <p:cNvPr id="15" name="Vị trí tuyển name"/>
+          <a:ln/>
+        </p:spPr>
+        <p:txBody>
+          <a:bodyPr wrap="square" lIns="0" tIns="0" rIns="0" bIns="0" rtlCol="0" anchor="ctr"/>
+          <a:lstStyle/>
+          <a:p>
+            <a:pPr algn="ctr" indent="0" marL="0">
+              <a:buNone/>
+            </a:pPr>
+            <a:r>
+              <a:rPr lang="en-US" sz="1500" b="1" dirty="0">
+                <a:solidFill>
+                  <a:schemeClr val="bg1"/>
+                </a:solidFill>
+              </a:rPr>
+              <a:t>Nguồn hồ sơ</a:t>
+            </a:r>
+            <a:endParaRPr lang="en-US" sz="1500" dirty="0"/>
+          </a:p>
+        </p:txBody>
+      </p:sp>
+      <p:sp>
+        <p:nvSpPr>
+          <p:cNvPr id="30" name="Nguồn hồ sơ attr 1"/>
           <p:cNvSpPr txBox="1"/>
           <p:nvPr/>
         </p:nvSpPr>
         <p:spPr>
           <a:xfrm>
-            <a:off x="6400800" y="1508760"/>
-            <a:ext cx="1371600" cy="457200"/>
+            <a:off x="685800" y="4325112"/>
+            <a:ext cx="2103120" cy="274320"/>
           </a:xfrm>
           <a:prstGeom prst="rect">
             <a:avLst/>
@@ -9723,27 +10273,35 @@
               <a:buNone/>
             </a:pPr>
             <a:r>
-              <a:rPr lang="en-US" sz="1600" b="1" dirty="0">
-                <a:solidFill>
-                  <a:schemeClr val="tx2"/>
-                </a:solidFill>
-              </a:rPr>
-              <a:t>Vị trí tuyển</a:t>
-            </a:r>
-            <a:endParaRPr lang="en-US" sz="1600" dirty="0"/>
-          </a:p>
-        </p:txBody>
-      </p:sp>
-      <p:sp>
-        <p:nvSpPr>
-          <p:cNvPr id="16" name="Vị trí tuyển fields"/>
+              <a:rPr lang="en-US" sz="1300" b="1" dirty="0">
+                <a:solidFill>
+                  <a:schemeClr val="accent3"/>
+                </a:solidFill>
+              </a:rPr>
+              <a:t>PK  </a:t>
+            </a:r>
+            <a:r>
+              <a:rPr lang="en-US" sz="1300" b="1" dirty="0">
+                <a:solidFill>
+                  <a:schemeClr val="tx1"/>
+                </a:solidFill>
+              </a:rPr>
+              <a:t>Mã nguồn</a:t>
+            </a:r>
+            <a:endParaRPr lang="en-US" sz="1300" dirty="0"/>
+          </a:p>
+        </p:txBody>
+      </p:sp>
+      <p:sp>
+        <p:nvSpPr>
+          <p:cNvPr id="31" name="Nguồn hồ sơ attr 2"/>
           <p:cNvSpPr txBox="1"/>
           <p:nvPr/>
         </p:nvSpPr>
         <p:spPr>
           <a:xfrm>
-            <a:off x="5852160" y="2057400"/>
-            <a:ext cx="1874520" cy="594360"/>
+            <a:off x="685800" y="4599432"/>
+            <a:ext cx="2103120" cy="274320"/>
           </a:xfrm>
           <a:prstGeom prst="rect">
             <a:avLst/>
@@ -9764,7 +10322,7 @@
                   <a:schemeClr val="tx1"/>
                 </a:solidFill>
               </a:rPr>
-              <a:t>Tên vị trí · Phòng ban</a:t>
+              <a:t>Tên nguồn</a:t>
             </a:r>
             <a:endParaRPr lang="en-US" sz="1300" dirty="0"/>
           </a:p>
@@ -9772,19 +10330,17 @@
       </p:sp>
       <p:sp>
         <p:nvSpPr>
-          <p:cNvPr id="17" name="Nguồn hồ sơ box"/>
+          <p:cNvPr id="32" name="Vị trí tuyển entity"/>
           <p:cNvSpPr/>
           <p:nvPr/>
         </p:nvSpPr>
         <p:spPr>
           <a:xfrm>
-            <a:off x="548640" y="4572000"/>
-            <a:ext cx="2148840" cy="1371600"/>
-          </a:xfrm>
-          <a:prstGeom prst="roundRect">
-            <a:avLst>
-              <a:gd name="adj" fmla="val 6667"/>
-            </a:avLst>
+            <a:off x="9262872" y="1371600"/>
+            <a:ext cx="2377440" cy="1316736"/>
+          </a:xfrm>
+          <a:prstGeom prst="rect">
+            <a:avLst/>
           </a:prstGeom>
           <a:solidFill>
             <a:schemeClr val="bg2"/>
@@ -9799,63 +10355,52 @@
       </p:sp>
       <p:sp>
         <p:nvSpPr>
-          <p:cNvPr id="18" name="Nguồn hồ sơ circle"/>
-          <p:cNvSpPr/>
-          <p:nvPr/>
-        </p:nvSpPr>
-        <p:spPr>
-          <a:xfrm>
-            <a:off x="685800" y="4709160"/>
-            <a:ext cx="457200" cy="457200"/>
-          </a:xfrm>
-          <a:prstGeom prst="ellipse">
+          <p:cNvPr id="33" name="Vị trí tuyển header"/>
+          <p:cNvSpPr txBox="1"/>
+          <p:nvPr/>
+        </p:nvSpPr>
+        <p:spPr>
+          <a:xfrm>
+            <a:off x="9262872" y="1371600"/>
+            <a:ext cx="2377440" cy="384048"/>
+          </a:xfrm>
+          <a:prstGeom prst="rect">
             <a:avLst/>
           </a:prstGeom>
           <a:solidFill>
             <a:schemeClr val="accent1"/>
           </a:solidFill>
-          <a:ln w="12700">
-            <a:solidFill>
-              <a:schemeClr val="accent1"/>
-            </a:solidFill>
-            <a:prstDash val="solid"/>
-          </a:ln>
-        </p:spPr>
-      </p:sp>
-      <p:pic>
-        <p:nvPicPr>
-          <p:cNvPr id="19" name="Nguồn hồ sơ icon" descr="Nguồn hồ sơ">    </p:cNvPr>
-          <p:cNvPicPr>
-            <a:picLocks noChangeAspect="1"/>
-          </p:cNvPicPr>
-          <p:nvPr/>
-        </p:nvPicPr>
-        <p:blipFill>
-          <a:blip r:embed="rId3"/>
-          <a:stretch>
-            <a:fillRect/>
-          </a:stretch>
-        </p:blipFill>
-        <p:spPr>
-          <a:xfrm>
-            <a:off x="800100" y="4823460"/>
-            <a:ext cx="228600" cy="228600"/>
-          </a:xfrm>
-          <a:prstGeom prst="rect">
-            <a:avLst/>
-          </a:prstGeom>
-        </p:spPr>
-      </p:pic>
-      <p:sp>
-        <p:nvSpPr>
-          <p:cNvPr id="20" name="Nguồn hồ sơ name"/>
+          <a:ln/>
+        </p:spPr>
+        <p:txBody>
+          <a:bodyPr wrap="square" lIns="0" tIns="0" rIns="0" bIns="0" rtlCol="0" anchor="ctr"/>
+          <a:lstStyle/>
+          <a:p>
+            <a:pPr algn="ctr" indent="0" marL="0">
+              <a:buNone/>
+            </a:pPr>
+            <a:r>
+              <a:rPr lang="en-US" sz="1500" b="1" dirty="0">
+                <a:solidFill>
+                  <a:schemeClr val="bg1"/>
+                </a:solidFill>
+              </a:rPr>
+              <a:t>Vị trí tuyển</a:t>
+            </a:r>
+            <a:endParaRPr lang="en-US" sz="1500" dirty="0"/>
+          </a:p>
+        </p:txBody>
+      </p:sp>
+      <p:sp>
+        <p:nvSpPr>
+          <p:cNvPr id="34" name="Vị trí tuyển attr 1"/>
           <p:cNvSpPr txBox="1"/>
           <p:nvPr/>
         </p:nvSpPr>
         <p:spPr>
           <a:xfrm>
-            <a:off x="1234440" y="4709160"/>
-            <a:ext cx="1371600" cy="457200"/>
+            <a:off x="9400032" y="1810512"/>
+            <a:ext cx="2103120" cy="274320"/>
           </a:xfrm>
           <a:prstGeom prst="rect">
             <a:avLst/>
@@ -9871,27 +10416,35 @@
               <a:buNone/>
             </a:pPr>
             <a:r>
-              <a:rPr lang="en-US" sz="1600" b="1" dirty="0">
-                <a:solidFill>
-                  <a:schemeClr val="tx2"/>
-                </a:solidFill>
-              </a:rPr>
-              <a:t>Nguồn hồ sơ</a:t>
-            </a:r>
-            <a:endParaRPr lang="en-US" sz="1600" dirty="0"/>
-          </a:p>
-        </p:txBody>
-      </p:sp>
-      <p:sp>
-        <p:nvSpPr>
-          <p:cNvPr id="21" name="Nguồn hồ sơ fields"/>
+              <a:rPr lang="en-US" sz="1300" b="1" dirty="0">
+                <a:solidFill>
+                  <a:schemeClr val="accent3"/>
+                </a:solidFill>
+              </a:rPr>
+              <a:t>PK  </a:t>
+            </a:r>
+            <a:r>
+              <a:rPr lang="en-US" sz="1300" b="1" dirty="0">
+                <a:solidFill>
+                  <a:schemeClr val="tx1"/>
+                </a:solidFill>
+              </a:rPr>
+              <a:t>Mã vị trí</a:t>
+            </a:r>
+            <a:endParaRPr lang="en-US" sz="1300" dirty="0"/>
+          </a:p>
+        </p:txBody>
+      </p:sp>
+      <p:sp>
+        <p:nvSpPr>
+          <p:cNvPr id="35" name="Vị trí tuyển attr 2"/>
           <p:cNvSpPr txBox="1"/>
           <p:nvPr/>
         </p:nvSpPr>
         <p:spPr>
           <a:xfrm>
-            <a:off x="685800" y="5257800"/>
-            <a:ext cx="1874520" cy="594360"/>
+            <a:off x="9400032" y="2084832"/>
+            <a:ext cx="2103120" cy="274320"/>
           </a:xfrm>
           <a:prstGeom prst="rect">
             <a:avLst/>
@@ -9912,7 +10465,7 @@
                   <a:schemeClr val="tx1"/>
                 </a:solidFill>
               </a:rPr>
-              <a:t>File HR · Web · Google Form</a:t>
+              <a:t>Tên vị trí</a:t>
             </a:r>
             <a:endParaRPr lang="en-US" sz="1300" dirty="0"/>
           </a:p>
@@ -9920,19 +10473,53 @@
       </p:sp>
       <p:sp>
         <p:nvSpPr>
-          <p:cNvPr id="22" name="Vòng tuyển box"/>
+          <p:cNvPr id="36" name="Vị trí tuyển attr 3"/>
+          <p:cNvSpPr txBox="1"/>
+          <p:nvPr/>
+        </p:nvSpPr>
+        <p:spPr>
+          <a:xfrm>
+            <a:off x="9400032" y="2359152"/>
+            <a:ext cx="2103120" cy="274320"/>
+          </a:xfrm>
+          <a:prstGeom prst="rect">
+            <a:avLst/>
+          </a:prstGeom>
+          <a:noFill/>
+          <a:ln/>
+        </p:spPr>
+        <p:txBody>
+          <a:bodyPr wrap="square" lIns="0" tIns="0" rIns="0" bIns="0" rtlCol="0" anchor="ctr"/>
+          <a:lstStyle/>
+          <a:p>
+            <a:pPr indent="0" marL="0">
+              <a:buNone/>
+            </a:pPr>
+            <a:r>
+              <a:rPr lang="en-US" sz="1300" dirty="0">
+                <a:solidFill>
+                  <a:schemeClr val="tx1"/>
+                </a:solidFill>
+              </a:rPr>
+              <a:t>Phòng ban</a:t>
+            </a:r>
+            <a:endParaRPr lang="en-US" sz="1300" dirty="0"/>
+          </a:p>
+        </p:txBody>
+      </p:sp>
+      <p:sp>
+        <p:nvSpPr>
+          <p:cNvPr id="37" name="Vòng tuyển entity"/>
           <p:cNvSpPr/>
           <p:nvPr/>
         </p:nvSpPr>
         <p:spPr>
           <a:xfrm>
-            <a:off x="5715000" y="4572000"/>
-            <a:ext cx="2148840" cy="1371600"/>
-          </a:xfrm>
-          <a:prstGeom prst="roundRect">
-            <a:avLst>
-              <a:gd name="adj" fmla="val 6667"/>
-            </a:avLst>
+            <a:off x="9262872" y="3886200"/>
+            <a:ext cx="2377440" cy="1316736"/>
+          </a:xfrm>
+          <a:prstGeom prst="rect">
+            <a:avLst/>
           </a:prstGeom>
           <a:solidFill>
             <a:schemeClr val="bg2"/>
@@ -9947,63 +10534,52 @@
       </p:sp>
       <p:sp>
         <p:nvSpPr>
-          <p:cNvPr id="23" name="Vòng tuyển circle"/>
-          <p:cNvSpPr/>
-          <p:nvPr/>
-        </p:nvSpPr>
-        <p:spPr>
-          <a:xfrm>
-            <a:off x="5852160" y="4709160"/>
-            <a:ext cx="457200" cy="457200"/>
-          </a:xfrm>
-          <a:prstGeom prst="ellipse">
+          <p:cNvPr id="38" name="Vòng tuyển header"/>
+          <p:cNvSpPr txBox="1"/>
+          <p:nvPr/>
+        </p:nvSpPr>
+        <p:spPr>
+          <a:xfrm>
+            <a:off x="9262872" y="3886200"/>
+            <a:ext cx="2377440" cy="384048"/>
+          </a:xfrm>
+          <a:prstGeom prst="rect">
             <a:avLst/>
           </a:prstGeom>
           <a:solidFill>
             <a:schemeClr val="accent1"/>
           </a:solidFill>
-          <a:ln w="12700">
-            <a:solidFill>
-              <a:schemeClr val="accent1"/>
-            </a:solidFill>
-            <a:prstDash val="solid"/>
-          </a:ln>
-        </p:spPr>
-      </p:sp>
-      <p:pic>
-        <p:nvPicPr>
-          <p:cNvPr id="24" name="Vòng tuyển icon" descr="Vòng tuyển">    </p:cNvPr>
-          <p:cNvPicPr>
-            <a:picLocks noChangeAspect="1"/>
-          </p:cNvPicPr>
-          <p:nvPr/>
-        </p:nvPicPr>
-        <p:blipFill>
-          <a:blip r:embed="rId4"/>
-          <a:stretch>
-            <a:fillRect/>
-          </a:stretch>
-        </p:blipFill>
-        <p:spPr>
-          <a:xfrm>
-            <a:off x="5966460" y="4823460"/>
-            <a:ext cx="228600" cy="228600"/>
-          </a:xfrm>
-          <a:prstGeom prst="rect">
-            <a:avLst/>
-          </a:prstGeom>
-        </p:spPr>
-      </p:pic>
-      <p:sp>
-        <p:nvSpPr>
-          <p:cNvPr id="25" name="Vòng tuyển name"/>
+          <a:ln/>
+        </p:spPr>
+        <p:txBody>
+          <a:bodyPr wrap="square" lIns="0" tIns="0" rIns="0" bIns="0" rtlCol="0" anchor="ctr"/>
+          <a:lstStyle/>
+          <a:p>
+            <a:pPr algn="ctr" indent="0" marL="0">
+              <a:buNone/>
+            </a:pPr>
+            <a:r>
+              <a:rPr lang="en-US" sz="1500" b="1" dirty="0">
+                <a:solidFill>
+                  <a:schemeClr val="bg1"/>
+                </a:solidFill>
+              </a:rPr>
+              <a:t>Vòng tuyển</a:t>
+            </a:r>
+            <a:endParaRPr lang="en-US" sz="1500" dirty="0"/>
+          </a:p>
+        </p:txBody>
+      </p:sp>
+      <p:sp>
+        <p:nvSpPr>
+          <p:cNvPr id="39" name="Vòng tuyển attr 1"/>
           <p:cNvSpPr txBox="1"/>
           <p:nvPr/>
         </p:nvSpPr>
         <p:spPr>
           <a:xfrm>
-            <a:off x="6400800" y="4709160"/>
-            <a:ext cx="1371600" cy="457200"/>
+            <a:off x="9400032" y="4325112"/>
+            <a:ext cx="2103120" cy="274320"/>
           </a:xfrm>
           <a:prstGeom prst="rect">
             <a:avLst/>
@@ -10019,27 +10595,35 @@
               <a:buNone/>
             </a:pPr>
             <a:r>
-              <a:rPr lang="en-US" sz="1600" b="1" dirty="0">
-                <a:solidFill>
-                  <a:schemeClr val="tx2"/>
-                </a:solidFill>
-              </a:rPr>
-              <a:t>Vòng tuyển</a:t>
-            </a:r>
-            <a:endParaRPr lang="en-US" sz="1600" dirty="0"/>
-          </a:p>
-        </p:txBody>
-      </p:sp>
-      <p:sp>
-        <p:nvSpPr>
-          <p:cNvPr id="26" name="Vòng tuyển fields"/>
+              <a:rPr lang="en-US" sz="1300" b="1" dirty="0">
+                <a:solidFill>
+                  <a:schemeClr val="accent3"/>
+                </a:solidFill>
+              </a:rPr>
+              <a:t>PK  </a:t>
+            </a:r>
+            <a:r>
+              <a:rPr lang="en-US" sz="1300" b="1" dirty="0">
+                <a:solidFill>
+                  <a:schemeClr val="tx1"/>
+                </a:solidFill>
+              </a:rPr>
+              <a:t>Mã vòng</a:t>
+            </a:r>
+            <a:endParaRPr lang="en-US" sz="1300" dirty="0"/>
+          </a:p>
+        </p:txBody>
+      </p:sp>
+      <p:sp>
+        <p:nvSpPr>
+          <p:cNvPr id="40" name="Vòng tuyển attr 2"/>
           <p:cNvSpPr txBox="1"/>
           <p:nvPr/>
         </p:nvSpPr>
         <p:spPr>
           <a:xfrm>
-            <a:off x="5852160" y="5257800"/>
-            <a:ext cx="1874520" cy="594360"/>
+            <a:off x="9400032" y="4599432"/>
+            <a:ext cx="2103120" cy="274320"/>
           </a:xfrm>
           <a:prstGeom prst="rect">
             <a:avLst/>
@@ -10060,7 +10644,7 @@
                   <a:schemeClr val="tx1"/>
                 </a:solidFill>
               </a:rPr>
-              <a:t>Nộp hồ sơ → Nhận việc</a:t>
+              <a:t>Tên vòng</a:t>
             </a:r>
             <a:endParaRPr lang="en-US" sz="1300" dirty="0"/>
           </a:p>
@@ -10068,24 +10652,58 @@
       </p:sp>
       <p:sp>
         <p:nvSpPr>
-          <p:cNvPr id="27" name="Center table"/>
+          <p:cNvPr id="41" name="Vòng tuyển attr 3"/>
+          <p:cNvSpPr txBox="1"/>
+          <p:nvPr/>
+        </p:nvSpPr>
+        <p:spPr>
+          <a:xfrm>
+            <a:off x="9400032" y="4873752"/>
+            <a:ext cx="2103120" cy="274320"/>
+          </a:xfrm>
+          <a:prstGeom prst="rect">
+            <a:avLst/>
+          </a:prstGeom>
+          <a:noFill/>
+          <a:ln/>
+        </p:spPr>
+        <p:txBody>
+          <a:bodyPr wrap="square" lIns="0" tIns="0" rIns="0" bIns="0" rtlCol="0" anchor="ctr"/>
+          <a:lstStyle/>
+          <a:p>
+            <a:pPr indent="0" marL="0">
+              <a:buNone/>
+            </a:pPr>
+            <a:r>
+              <a:rPr lang="en-US" sz="1300" dirty="0">
+                <a:solidFill>
+                  <a:schemeClr val="tx1"/>
+                </a:solidFill>
+              </a:rPr>
+              <a:t>Thứ tự (1 → 5)</a:t>
+            </a:r>
+            <a:endParaRPr lang="en-US" sz="1300" dirty="0"/>
+          </a:p>
+        </p:txBody>
+      </p:sp>
+      <p:sp>
+        <p:nvSpPr>
+          <p:cNvPr id="42" name="Hồ sơ ứng tuyển entity"/>
           <p:cNvSpPr/>
           <p:nvPr/>
         </p:nvSpPr>
         <p:spPr>
           <a:xfrm>
-            <a:off x="2971800" y="2377440"/>
-            <a:ext cx="2468880" cy="2194560"/>
-          </a:xfrm>
-          <a:prstGeom prst="roundRect">
-            <a:avLst>
-              <a:gd name="adj" fmla="val 5000"/>
-            </a:avLst>
+            <a:off x="4754880" y="2468880"/>
+            <a:ext cx="2697480" cy="1316736"/>
+          </a:xfrm>
+          <a:prstGeom prst="rect">
+            <a:avLst/>
           </a:prstGeom>
           <a:solidFill>
-            <a:schemeClr val="accent2"/>
+            <a:schemeClr val="bg1"/>
           </a:solidFill>
-          <a:ln w="12700">
+          <a:ln w="25400">
             <a:solidFill>
               <a:schemeClr val="accent2"/>
             </a:solidFill>
@@ -10095,14 +10713,52 @@
       </p:sp>
       <p:sp>
         <p:nvSpPr>
-          <p:cNvPr id="28" name="Center table text"/>
+          <p:cNvPr id="43" name="Hồ sơ ứng tuyển header"/>
           <p:cNvSpPr txBox="1"/>
           <p:nvPr/>
         </p:nvSpPr>
         <p:spPr>
           <a:xfrm>
-            <a:off x="3108960" y="2514600"/>
-            <a:ext cx="2194560" cy="1920240"/>
+            <a:off x="4754880" y="2468880"/>
+            <a:ext cx="2697480" cy="384048"/>
+          </a:xfrm>
+          <a:prstGeom prst="rect">
+            <a:avLst/>
+          </a:prstGeom>
+          <a:solidFill>
+            <a:schemeClr val="accent2"/>
+          </a:solidFill>
+          <a:ln/>
+        </p:spPr>
+        <p:txBody>
+          <a:bodyPr wrap="square" lIns="0" tIns="0" rIns="0" bIns="0" rtlCol="0" anchor="ctr"/>
+          <a:lstStyle/>
+          <a:p>
+            <a:pPr algn="ctr" indent="0" marL="0">
+              <a:buNone/>
+            </a:pPr>
+            <a:r>
+              <a:rPr lang="en-US" sz="1500" b="1" dirty="0">
+                <a:solidFill>
+                  <a:schemeClr val="tx2"/>
+                </a:solidFill>
+              </a:rPr>
+              <a:t>Hồ sơ ứng tuyển</a:t>
+            </a:r>
+            <a:endParaRPr lang="en-US" sz="1500" dirty="0"/>
+          </a:p>
+        </p:txBody>
+      </p:sp>
+      <p:sp>
+        <p:nvSpPr>
+          <p:cNvPr id="44" name="Hồ sơ ứng tuyển attr 1"/>
+          <p:cNvSpPr txBox="1"/>
+          <p:nvPr/>
+        </p:nvSpPr>
+        <p:spPr>
+          <a:xfrm>
+            <a:off x="4892040" y="2907792"/>
+            <a:ext cx="2423160" cy="274320"/>
           </a:xfrm>
           <a:prstGeom prst="rect">
             <a:avLst/>
@@ -10114,89 +10770,115 @@
           <a:bodyPr wrap="square" lIns="0" tIns="0" rIns="0" bIns="0" rtlCol="0" anchor="ctr"/>
           <a:lstStyle/>
           <a:p>
-            <a:pPr algn="ctr" indent="0" marL="0">
-              <a:spcAft>
-                <a:spcPts val="400"/>
-              </a:spcAft>
-              <a:buNone/>
-            </a:pPr>
-            <a:r>
-              <a:rPr lang="en-US" sz="1800" b="1" dirty="0">
-                <a:solidFill>
-                  <a:schemeClr val="tx2"/>
-                </a:solidFill>
-              </a:rPr>
-              <a:t>Hồ sơ ứng tuyển</a:t>
-            </a:r>
-            <a:endParaRPr lang="en-US" sz="1800" dirty="0"/>
-          </a:p>
-          <a:p>
-            <a:pPr algn="ctr" indent="0" marL="0">
-              <a:spcAft>
-                <a:spcPts val="400"/>
-              </a:spcAft>
-              <a:buNone/>
-            </a:pPr>
-            <a:r>
-              <a:rPr lang="en-US" sz="1400" dirty="0">
-                <a:solidFill>
-                  <a:schemeClr val="tx2"/>
-                </a:solidFill>
-              </a:rPr>
-              <a:t>Mã hồ sơ · Ngày nộp</a:t>
-            </a:r>
-            <a:endParaRPr lang="en-US" sz="1800" dirty="0"/>
-          </a:p>
-          <a:p>
-            <a:pPr algn="ctr" indent="0" marL="0">
-              <a:spcAft>
-                <a:spcPts val="400"/>
-              </a:spcAft>
-              <a:buNone/>
-            </a:pPr>
-            <a:r>
-              <a:rPr lang="en-US" sz="1400" dirty="0">
-                <a:solidFill>
-                  <a:schemeClr val="tx2"/>
-                </a:solidFill>
-              </a:rPr>
-              <a:t>Vòng hiện tại</a:t>
-            </a:r>
-            <a:endParaRPr lang="en-US" sz="1800" dirty="0"/>
-          </a:p>
-          <a:p>
-            <a:pPr algn="ctr" indent="0" marL="0">
-              <a:spcAft>
-                <a:spcPts val="400"/>
-              </a:spcAft>
-              <a:buNone/>
-            </a:pPr>
-            <a:r>
-              <a:rPr lang="en-US" sz="1400" dirty="0">
-                <a:solidFill>
-                  <a:schemeClr val="tx2"/>
+            <a:pPr indent="0" marL="0">
+              <a:buNone/>
+            </a:pPr>
+            <a:r>
+              <a:rPr lang="en-US" sz="1300" b="1" dirty="0">
+                <a:solidFill>
+                  <a:schemeClr val="accent3"/>
+                </a:solidFill>
+              </a:rPr>
+              <a:t>PK  </a:t>
+            </a:r>
+            <a:r>
+              <a:rPr lang="en-US" sz="1300" b="1" dirty="0">
+                <a:solidFill>
+                  <a:schemeClr val="tx1"/>
+                </a:solidFill>
+              </a:rPr>
+              <a:t>Mã hồ sơ</a:t>
+            </a:r>
+            <a:endParaRPr lang="en-US" sz="1300" dirty="0"/>
+          </a:p>
+        </p:txBody>
+      </p:sp>
+      <p:sp>
+        <p:nvSpPr>
+          <p:cNvPr id="45" name="Hồ sơ ứng tuyển attr 2"/>
+          <p:cNvSpPr txBox="1"/>
+          <p:nvPr/>
+        </p:nvSpPr>
+        <p:spPr>
+          <a:xfrm>
+            <a:off x="4892040" y="3182112"/>
+            <a:ext cx="2423160" cy="274320"/>
+          </a:xfrm>
+          <a:prstGeom prst="rect">
+            <a:avLst/>
+          </a:prstGeom>
+          <a:noFill/>
+          <a:ln/>
+        </p:spPr>
+        <p:txBody>
+          <a:bodyPr wrap="square" lIns="0" tIns="0" rIns="0" bIns="0" rtlCol="0" anchor="ctr"/>
+          <a:lstStyle/>
+          <a:p>
+            <a:pPr indent="0" marL="0">
+              <a:buNone/>
+            </a:pPr>
+            <a:r>
+              <a:rPr lang="en-US" sz="1300" dirty="0">
+                <a:solidFill>
+                  <a:schemeClr val="tx1"/>
+                </a:solidFill>
+              </a:rPr>
+              <a:t>Ngày nộp</a:t>
+            </a:r>
+            <a:endParaRPr lang="en-US" sz="1300" dirty="0"/>
+          </a:p>
+        </p:txBody>
+      </p:sp>
+      <p:sp>
+        <p:nvSpPr>
+          <p:cNvPr id="46" name="Hồ sơ ứng tuyển attr 3"/>
+          <p:cNvSpPr txBox="1"/>
+          <p:nvPr/>
+        </p:nvSpPr>
+        <p:spPr>
+          <a:xfrm>
+            <a:off x="4892040" y="3456432"/>
+            <a:ext cx="2423160" cy="274320"/>
+          </a:xfrm>
+          <a:prstGeom prst="rect">
+            <a:avLst/>
+          </a:prstGeom>
+          <a:noFill/>
+          <a:ln/>
+        </p:spPr>
+        <p:txBody>
+          <a:bodyPr wrap="square" lIns="0" tIns="0" rIns="0" bIns="0" rtlCol="0" anchor="ctr"/>
+          <a:lstStyle/>
+          <a:p>
+            <a:pPr indent="0" marL="0">
+              <a:buNone/>
+            </a:pPr>
+            <a:r>
+              <a:rPr lang="en-US" sz="1300" dirty="0">
+                <a:solidFill>
+                  <a:schemeClr val="tx1"/>
                 </a:solidFill>
               </a:rPr>
               <a:t>Điểm AI chấm</a:t>
             </a:r>
-            <a:endParaRPr lang="en-US" sz="1800" dirty="0"/>
-          </a:p>
-        </p:txBody>
-      </p:sp>
-      <p:sp>
-        <p:nvSpPr>
-          <p:cNvPr id="29" name="Idea panel"/>
+            <a:endParaRPr lang="en-US" sz="1300" dirty="0"/>
+          </a:p>
+        </p:txBody>
+      </p:sp>
+      <p:sp>
+        <p:nvSpPr>
+          <p:cNvPr id="47" name="Legend card"/>
           <p:cNvSpPr/>
           <p:nvPr/>
         </p:nvSpPr>
         <p:spPr>
           <a:xfrm>
-            <a:off x="8229600" y="1371600"/>
-            <a:ext cx="3410712" cy="4572000"/>
+            <a:off x="548640" y="5440680"/>
+            <a:ext cx="11091672" cy="658368"/>
           </a:xfrm>
           <a:prstGeom prst="roundRect">
             <a:avLst>
-              <a:gd name="adj" fmla="val 3217"/>
+              <a:gd name="adj" fmla="val 13889"/>
             </a:avLst>
           </a:prstGeom>
           <a:solidFill>
@@ -10212,14 +10894,14 @@
       </p:sp>
       <p:sp>
         <p:nvSpPr>
-          <p:cNvPr id="30" name="Idea header"/>
+          <p:cNvPr id="48" name="Legend text"/>
           <p:cNvSpPr txBox="1"/>
           <p:nvPr/>
         </p:nvSpPr>
         <p:spPr>
           <a:xfrm>
-            <a:off x="8458200" y="1554480"/>
-            <a:ext cx="3017520" cy="457200"/>
+            <a:off x="777240" y="5440680"/>
+            <a:ext cx="10698480" cy="658368"/>
           </a:xfrm>
           <a:prstGeom prst="rect">
             <a:avLst/>
@@ -10235,142 +10917,34 @@
               <a:buNone/>
             </a:pPr>
             <a:r>
-              <a:rPr lang="en-US" sz="1900" b="1" dirty="0">
+              <a:rPr lang="en-US" sz="1400" b="1" dirty="0">
                 <a:solidFill>
                   <a:schemeClr val="tx2"/>
                 </a:solidFill>
               </a:rPr>
-              <a:t>Ý tưởng thiết kế</a:t>
-            </a:r>
-            <a:endParaRPr lang="en-US" sz="1900" dirty="0"/>
-          </a:p>
-        </p:txBody>
-      </p:sp>
-      <p:sp>
-        <p:nvSpPr>
-          <p:cNvPr id="31" name="Idea bullets"/>
-          <p:cNvSpPr txBox="1"/>
-          <p:nvPr/>
-        </p:nvSpPr>
-        <p:spPr>
-          <a:xfrm>
-            <a:off x="8458200" y="2103120"/>
-            <a:ext cx="3017520" cy="3017520"/>
-          </a:xfrm>
-          <a:prstGeom prst="rect">
-            <a:avLst/>
-          </a:prstGeom>
-          <a:noFill/>
-          <a:ln/>
-        </p:spPr>
-        <p:txBody>
-          <a:bodyPr wrap="square" lIns="0" tIns="0" rIns="0" bIns="0" rtlCol="0" anchor="t"/>
-          <a:lstStyle/>
-          <a:p>
-            <a:pPr marL="228600" indent="-228600">
-              <a:spcAft>
-                <a:spcPts val="1000"/>
-              </a:spcAft>
-              <a:buSzPct val="100000"/>
-              <a:buChar char="•"/>
-            </a:pPr>
-            <a:r>
-              <a:rPr lang="en-US" sz="1500" dirty="0">
+              <a:t>Ký hiệu: </a:t>
+            </a:r>
+            <a:r>
+              <a:rPr lang="en-US" sz="1400" dirty="0">
                 <a:solidFill>
                   <a:schemeClr val="tx1"/>
                 </a:solidFill>
               </a:rPr>
-              <a:t>Bảng giữa: mỗi lần nộp hồ sơ là một dòng</a:t>
-            </a:r>
-            <a:endParaRPr lang="en-US" sz="1500" dirty="0"/>
-          </a:p>
-          <a:p>
-            <a:pPr marL="228600" indent="-228600">
-              <a:spcAft>
-                <a:spcPts val="1000"/>
-              </a:spcAft>
-              <a:buSzPct val="100000"/>
-              <a:buChar char="•"/>
-            </a:pPr>
-            <a:r>
-              <a:rPr lang="en-US" sz="1500" dirty="0">
-                <a:solidFill>
-                  <a:schemeClr val="tx1"/>
-                </a:solidFill>
-              </a:rPr>
-              <a:t>Bảng xung quanh: thông tin chi tiết, không ghi lặp</a:t>
-            </a:r>
-            <a:endParaRPr lang="en-US" sz="1500" dirty="0"/>
-          </a:p>
-          <a:p>
-            <a:pPr marL="228600" indent="-228600">
-              <a:spcAft>
-                <a:spcPts val="1000"/>
-              </a:spcAft>
-              <a:buSzPct val="100000"/>
-              <a:buChar char="•"/>
-            </a:pPr>
-            <a:r>
-              <a:rPr lang="en-US" sz="1500" dirty="0">
-                <a:solidFill>
-                  <a:schemeClr val="tx1"/>
-                </a:solidFill>
-              </a:rPr>
-              <a:t>Dễ đếm số người qua từng vòng, theo từng nguồn</a:t>
-            </a:r>
-            <a:endParaRPr lang="en-US" sz="1500" dirty="0"/>
-          </a:p>
-          <a:p>
-            <a:pPr marL="228600" indent="-228600">
-              <a:spcAft>
-                <a:spcPts val="1000"/>
-              </a:spcAft>
-              <a:buSzPct val="100000"/>
-              <a:buChar char="•"/>
-            </a:pPr>
-            <a:r>
-              <a:rPr lang="en-US" sz="1500" dirty="0">
-                <a:solidFill>
-                  <a:schemeClr val="tx1"/>
-                </a:solidFill>
-              </a:rPr>
-              <a:t>Thêm bảng Tài khoản để đăng nhập, phân quyền</a:t>
-            </a:r>
-            <a:endParaRPr lang="en-US" sz="1500" dirty="0"/>
-          </a:p>
-        </p:txBody>
-      </p:sp>
-      <p:sp>
-        <p:nvSpPr>
-          <p:cNvPr id="32" name="Star schema note"/>
-          <p:cNvSpPr txBox="1"/>
-          <p:nvPr/>
-        </p:nvSpPr>
-        <p:spPr>
-          <a:xfrm>
-            <a:off x="8458200" y="5120640"/>
-            <a:ext cx="3017520" cy="685800"/>
-          </a:xfrm>
-          <a:prstGeom prst="rect">
-            <a:avLst/>
-          </a:prstGeom>
-          <a:noFill/>
-          <a:ln/>
-        </p:spPr>
-        <p:txBody>
-          <a:bodyPr wrap="square" lIns="0" tIns="0" rIns="0" bIns="0" rtlCol="0" anchor="t"/>
-          <a:lstStyle/>
+              <a:t>hình chữ nhật = thực thể · hình thoi = mối liên kết · 1 – n = quan hệ một – nhiều · PK = khóa chính</a:t>
+            </a:r>
+            <a:endParaRPr lang="en-US" sz="1400" dirty="0"/>
+          </a:p>
           <a:p>
             <a:pPr indent="0" marL="0">
               <a:buNone/>
             </a:pPr>
             <a:r>
-              <a:rPr lang="en-US" sz="1400" i="1" dirty="0">
+              <a:rPr lang="en-US" sz="1300" i="1" dirty="0">
                 <a:solidFill>
                   <a:schemeClr val="accent1"/>
                 </a:solidFill>
               </a:rPr>
-              <a:t>Kiểu này gọi là star schema (hình ngôi sao)</a:t>
+              <a:t>Thiết kế hình ngôi sao (star schema). ERD chi tiết với từng cột và khóa ngoại: xem Task 2 của Trần Phúc Hoàng.</a:t>
             </a:r>
             <a:endParaRPr lang="en-US" sz="1400" dirty="0"/>
           </a:p>

</xml_diff>

<commit_message>
Restyle Task 1 deck with a new visual design
Charcoal and coral palette, Arial headings, square cards and icons,
numbered slide tags and a tiled cover. Content and layout positions are
unchanged, so the presenting script still applies.

Co-Authored-By: Claude Opus 5.5 <noreply@anthropic.com>
Claude-Session: https://claude.ai/code/session_01Nd7HZKgsHFz3NCndSJLPaG
</commit_message>
<xml_diff>
--- a/bai_tap_python_nhom8/task1_nguyen_phan_khanh_vy/2431540032_NguyenPhanKhanhVy.pptx
+++ b/bai_tap_python_nhom8/task1_nguyen_phan_khanh_vy/2431540032_NguyenPhanKhanhVy.pptx
@@ -116,13 +116,13 @@
   <p:extLst>
     <p:ext uri="{521415D9-36F7-43E2-AB2F-B90AF26B5E84}">
       <p14:sectionLst xmlns:p14="http://schemas.microsoft.com/office/powerpoint/2010/main">
-        <p14:section name="Mở đầu" id="{d43f8c18-b541-1d5d-9a09-bc14d5046628}">
+        <p14:section name="Mở đầu" id="{ce215908-d277-38b8-d8f6-7b45d5182493}">
           <p14:sldIdLst>
             <p14:sldId id="256"/>
             <p14:sldId id="257"/>
           </p14:sldIdLst>
         </p14:section>
-        <p14:section name="Phân tích &amp; ETL" id="{229e7f99-d775-3e62-fa16-f8a769df537e}">
+        <p14:section name="Phân tích &amp; ETL" id="{04817550-83ad-3eff-c84c-20aa0cd6d888}">
           <p14:sldIdLst>
             <p14:sldId id="258"/>
             <p14:sldId id="259"/>
@@ -130,13 +130,13 @@
             <p14:sldId id="261"/>
           </p14:sldIdLst>
         </p14:section>
-        <p14:section name="Kiến trúc" id="{46db5439-34bb-13dd-239c-da25ad6eb077}">
+        <p14:section name="Kiến trúc" id="{941f4617-7178-8633-34b5-0372789ba5b1}">
           <p14:sldIdLst>
             <p14:sldId id="262"/>
             <p14:sldId id="263"/>
           </p14:sldIdLst>
         </p14:section>
-        <p14:section name="Kết quả &amp; tổng kết" id="{74446561-a375-5c3b-acbe-6c789a9d450e}">
+        <p14:section name="Kết quả &amp; tổng kết" id="{d39b1aa8-3e3d-a7d0-4aad-4cae531e9769}">
           <p14:sldIdLst>
             <p14:sldId id="264"/>
             <p14:sldId id="265"/>
@@ -165,7 +165,7 @@
             <a:pPr>
               <a:defRPr sz="1400" b="0" i="0" u="none" strike="noStrike">
                 <a:solidFill>
-                  <a:srgbClr val="0B3C49"/>
+                  <a:srgbClr val="2D3142"/>
                 </a:solidFill>
                 <a:latin typeface="+mn-lt"/>
               </a:defRPr>
@@ -173,7 +173,7 @@
             <a:r>
               <a:rPr sz="1400" b="0" i="0" u="none" strike="noStrike">
                 <a:solidFill>
-                  <a:srgbClr val="0B3C49"/>
+                  <a:srgbClr val="2D3142"/>
                 </a:solidFill>
                 <a:latin typeface="+mn-lt"/>
               </a:rPr>
@@ -208,7 +208,7 @@
           </c:tx>
           <c:spPr>
             <a:solidFill>
-              <a:srgbClr val="0B3C49"/>
+              <a:srgbClr val="2D3142"/>
             </a:solidFill>
             <a:effectLst/>
           </c:spPr>
@@ -222,7 +222,7 @@
                 <a:pPr>
                   <a:defRPr b="0" i="0" strike="noStrike" sz="1300" u="none">
                     <a:solidFill>
-                      <a:srgbClr val="1B2A2F"/>
+                      <a:srgbClr val="22252E"/>
                     </a:solidFill>
                     <a:latin typeface="+mn-lt"/>
                   </a:defRPr>
@@ -243,7 +243,7 @@
             <c:bubble3D val="0"/>
             <c:spPr>
               <a:solidFill>
-                <a:srgbClr val="0B3C49"/>
+                <a:srgbClr val="2D3142"/>
               </a:solidFill>
               <a:effectLst/>
             </c:spPr>
@@ -254,7 +254,7 @@
             <c:bubble3D val="0"/>
             <c:spPr>
               <a:solidFill>
-                <a:srgbClr val="1F7A7A"/>
+                <a:srgbClr val="4F5D75"/>
               </a:solidFill>
               <a:effectLst/>
             </c:spPr>
@@ -265,7 +265,7 @@
             <c:bubble3D val="0"/>
             <c:spPr>
               <a:solidFill>
-                <a:srgbClr val="1F7A7A"/>
+                <a:srgbClr val="4F5D75"/>
               </a:solidFill>
               <a:effectLst/>
             </c:spPr>
@@ -276,7 +276,7 @@
             <c:bubble3D val="0"/>
             <c:spPr>
               <a:solidFill>
-                <a:srgbClr val="1F7A7A"/>
+                <a:srgbClr val="4F5D75"/>
               </a:solidFill>
               <a:effectLst/>
             </c:spPr>
@@ -287,7 +287,7 @@
             <c:bubble3D val="0"/>
             <c:spPr>
               <a:solidFill>
-                <a:srgbClr val="F2A541"/>
+                <a:srgbClr val="EF8354"/>
               </a:solidFill>
               <a:effectLst/>
             </c:spPr>
@@ -351,7 +351,7 @@
               <a:pPr>
                 <a:defRPr b="0" i="0" strike="noStrike" sz="1300" u="none">
                   <a:solidFill>
-                    <a:srgbClr val="1B2A2F"/>
+                    <a:srgbClr val="22252E"/>
                   </a:solidFill>
                   <a:latin typeface="+mn-lt"/>
                 </a:defRPr>
@@ -399,7 +399,7 @@
             <a:pPr>
               <a:defRPr sz="1300" b="0" i="0" u="none" strike="noStrike">
                 <a:solidFill>
-                  <a:srgbClr val="5E6B70"/>
+                  <a:srgbClr val="6B7280"/>
                 </a:solidFill>
                 <a:latin typeface="+mn-lt"/>
               </a:defRPr>
@@ -451,7 +451,7 @@
             <a:pPr>
               <a:defRPr sz="1100" b="0" i="0" u="none" strike="noStrike">
                 <a:solidFill>
-                  <a:srgbClr val="5E6B70"/>
+                  <a:srgbClr val="6B7280"/>
                 </a:solidFill>
                 <a:latin typeface="+mn-lt"/>
               </a:defRPr>
@@ -1798,9 +1798,9 @@
                 <a:solidFill>
                   <a:schemeClr val="bg1"/>
                 </a:solidFill>
-                <a:latin typeface="Cambria" pitchFamily="34" charset="0"/>
-                <a:ea typeface="Cambria" pitchFamily="34" charset="-122"/>
-                <a:cs typeface="Cambria" pitchFamily="34" charset="-120"/>
+                <a:latin typeface="Arial" pitchFamily="34" charset="0"/>
+                <a:ea typeface="Arial" pitchFamily="34" charset="-122"/>
+                <a:cs typeface="Arial" pitchFamily="34" charset="-120"/>
               </a:defRPr>
             </a:lvl1pPr>
           </a:lstStyle>
@@ -1893,8 +1893,8 @@
         </p:nvSpPr>
         <p:spPr>
           <a:xfrm>
-            <a:off x="548640" y="320040"/>
-            <a:ext cx="11091672" cy="777240"/>
+            <a:off x="1417320" y="320040"/>
+            <a:ext cx="10222992" cy="777240"/>
           </a:xfrm>
           <a:prstGeom prst="rect">
             <a:avLst/>
@@ -1911,9 +1911,9 @@
                 <a:solidFill>
                   <a:schemeClr val="tx2"/>
                 </a:solidFill>
-                <a:latin typeface="Cambria" pitchFamily="34" charset="0"/>
-                <a:ea typeface="Cambria" pitchFamily="34" charset="-122"/>
-                <a:cs typeface="Cambria" pitchFamily="34" charset="-120"/>
+                <a:latin typeface="Arial" pitchFamily="34" charset="0"/>
+                <a:ea typeface="Arial" pitchFamily="34" charset="-122"/>
+                <a:cs typeface="Arial" pitchFamily="34" charset="-120"/>
               </a:defRPr>
             </a:lvl1pPr>
           </a:lstStyle>
@@ -2048,8 +2048,8 @@
         </p:nvSpPr>
         <p:spPr>
           <a:xfrm>
-            <a:off x="548640" y="320040"/>
-            <a:ext cx="11091672" cy="777240"/>
+            <a:off x="1417320" y="320040"/>
+            <a:ext cx="10222992" cy="777240"/>
           </a:xfrm>
           <a:prstGeom prst="rect">
             <a:avLst/>
@@ -2066,9 +2066,9 @@
                 <a:solidFill>
                   <a:schemeClr val="bg1"/>
                 </a:solidFill>
-                <a:latin typeface="Cambria" pitchFamily="34" charset="0"/>
-                <a:ea typeface="Cambria" pitchFamily="34" charset="-122"/>
-                <a:cs typeface="Cambria" pitchFamily="34" charset="-120"/>
+                <a:latin typeface="Arial" pitchFamily="34" charset="0"/>
+                <a:ea typeface="Arial" pitchFamily="34" charset="-122"/>
+                <a:cs typeface="Arial" pitchFamily="34" charset="-120"/>
               </a:defRPr>
             </a:lvl1pPr>
           </a:lstStyle>
@@ -2542,9 +2542,9 @@
                 <a:solidFill>
                   <a:schemeClr val="bg1"/>
                 </a:solidFill>
-                <a:latin typeface="Cambria" pitchFamily="34" charset="0"/>
-                <a:ea typeface="Cambria" pitchFamily="34" charset="-122"/>
-                <a:cs typeface="Cambria" pitchFamily="34" charset="-120"/>
+                <a:latin typeface="Arial" pitchFamily="34" charset="0"/>
+                <a:ea typeface="Arial" pitchFamily="34" charset="-122"/>
+                <a:cs typeface="Arial" pitchFamily="34" charset="-120"/>
               </a:rPr>
               <a:t>Phân tích bài toán, ETL và kiến trúc công nghệ</a:t>
             </a:r>
@@ -2601,7 +2601,7 @@
             <a:off x="640080" y="4251960"/>
             <a:ext cx="7223760" cy="1691640"/>
           </a:xfrm>
-          <a:prstGeom prst="roundRect">
+          <a:prstGeom prst="rect">
             <a:avLst>
               <a:gd name="adj" fmla="val 6486"/>
             </a:avLst>
@@ -2696,39 +2696,16 @@
       </p:sp>
       <p:sp>
         <p:nvSpPr>
-          <p:cNvPr id="7" name="Pipeline line"/>
+          <p:cNvPr id="7" name="Step tile 1"/>
           <p:cNvSpPr/>
           <p:nvPr/>
         </p:nvSpPr>
         <p:spPr>
           <a:xfrm>
-            <a:off x="9098280" y="1280160"/>
-            <a:ext cx="0" cy="4114800"/>
-          </a:xfrm>
-          <a:prstGeom prst="line">
-            <a:avLst/>
-          </a:prstGeom>
-          <a:noFill/>
-          <a:ln w="25400">
-            <a:solidFill>
-              <a:schemeClr val="accent6"/>
-            </a:solidFill>
-            <a:prstDash val="dash"/>
-          </a:ln>
-        </p:spPr>
-      </p:sp>
-      <p:sp>
-        <p:nvSpPr>
-          <p:cNvPr id="8" name="Pipeline 1 circle"/>
-          <p:cNvSpPr/>
-          <p:nvPr/>
-        </p:nvSpPr>
-        <p:spPr>
-          <a:xfrm>
-            <a:off x="8686800" y="914400"/>
-            <a:ext cx="822960" cy="822960"/>
-          </a:xfrm>
-          <a:prstGeom prst="ellipse">
+            <a:off x="7955280" y="1234440"/>
+            <a:ext cx="1783080" cy="1783080"/>
+          </a:xfrm>
+          <a:prstGeom prst="rect">
             <a:avLst/>
           </a:prstGeom>
           <a:solidFill>
@@ -2742,9 +2719,48 @@
           </a:ln>
         </p:spPr>
       </p:sp>
+      <p:sp>
+        <p:nvSpPr>
+          <p:cNvPr id="8" name="Step number 1"/>
+          <p:cNvSpPr txBox="1"/>
+          <p:nvPr/>
+        </p:nvSpPr>
+        <p:spPr>
+          <a:xfrm>
+            <a:off x="8092440" y="1344168"/>
+            <a:ext cx="822960" cy="457200"/>
+          </a:xfrm>
+          <a:prstGeom prst="rect">
+            <a:avLst/>
+          </a:prstGeom>
+          <a:noFill/>
+          <a:ln/>
+        </p:spPr>
+        <p:txBody>
+          <a:bodyPr wrap="square" lIns="0" tIns="0" rIns="0" bIns="0" rtlCol="0" anchor="ctr"/>
+          <a:lstStyle/>
+          <a:p>
+            <a:pPr indent="0" marL="0">
+              <a:buNone/>
+            </a:pPr>
+            <a:r>
+              <a:rPr lang="en-US" sz="2400" b="1" dirty="0">
+                <a:solidFill>
+                  <a:schemeClr val="accent6"/>
+                </a:solidFill>
+                <a:latin typeface="Arial" pitchFamily="34" charset="0"/>
+                <a:ea typeface="Arial" pitchFamily="34" charset="-122"/>
+                <a:cs typeface="Arial" pitchFamily="34" charset="-120"/>
+              </a:rPr>
+              <a:t>01</a:t>
+            </a:r>
+            <a:endParaRPr lang="en-US" sz="2400" dirty="0"/>
+          </a:p>
+        </p:txBody>
+      </p:sp>
       <p:pic>
         <p:nvPicPr>
-          <p:cNvPr id="9" name="Pipeline 1 icon" descr="Pipeline 1">    </p:cNvPr>
+          <p:cNvPr id="9" name="Step icon 1" descr="Dữ liệu tuyển dụng rời rạc">    </p:cNvPr>
           <p:cNvPicPr>
             <a:picLocks noChangeAspect="1"/>
           </p:cNvPicPr>
@@ -2758,8 +2774,8 @@
         </p:blipFill>
         <p:spPr>
           <a:xfrm>
-            <a:off x="8892540" y="1120140"/>
-            <a:ext cx="411480" cy="411480"/>
+            <a:off x="9189720" y="1389888"/>
+            <a:ext cx="384048" cy="384048"/>
           </a:xfrm>
           <a:prstGeom prst="rect">
             <a:avLst/>
@@ -2768,14 +2784,14 @@
       </p:pic>
       <p:sp>
         <p:nvSpPr>
-          <p:cNvPr id="10" name="Pipeline label 1"/>
+          <p:cNvPr id="10" name="Step label 1"/>
           <p:cNvSpPr txBox="1"/>
           <p:nvPr/>
         </p:nvSpPr>
         <p:spPr>
           <a:xfrm>
-            <a:off x="9692640" y="914400"/>
-            <a:ext cx="2194560" cy="822960"/>
+            <a:off x="8092440" y="1965960"/>
+            <a:ext cx="1508760" cy="914400"/>
           </a:xfrm>
           <a:prstGeom prst="rect">
             <a:avLst/>
@@ -2784,7 +2800,7 @@
           <a:ln/>
         </p:spPr>
         <p:txBody>
-          <a:bodyPr wrap="square" lIns="0" tIns="0" rIns="0" bIns="0" rtlCol="0" anchor="ctr"/>
+          <a:bodyPr wrap="square" lIns="0" tIns="0" rIns="0" bIns="0" rtlCol="0" anchor="b"/>
           <a:lstStyle/>
           <a:p>
             <a:pPr indent="0" marL="0">
@@ -2804,16 +2820,16 @@
       </p:sp>
       <p:sp>
         <p:nvSpPr>
-          <p:cNvPr id="11" name="Pipeline 2 circle"/>
+          <p:cNvPr id="11" name="Step tile 2"/>
           <p:cNvSpPr/>
           <p:nvPr/>
         </p:nvSpPr>
         <p:spPr>
           <a:xfrm>
-            <a:off x="8686800" y="2286000"/>
-            <a:ext cx="822960" cy="822960"/>
-          </a:xfrm>
-          <a:prstGeom prst="ellipse">
+            <a:off x="9875520" y="1234440"/>
+            <a:ext cx="1783080" cy="1783080"/>
+          </a:xfrm>
+          <a:prstGeom prst="rect">
             <a:avLst/>
           </a:prstGeom>
           <a:solidFill>
@@ -2827,9 +2843,48 @@
           </a:ln>
         </p:spPr>
       </p:sp>
+      <p:sp>
+        <p:nvSpPr>
+          <p:cNvPr id="12" name="Step number 2"/>
+          <p:cNvSpPr txBox="1"/>
+          <p:nvPr/>
+        </p:nvSpPr>
+        <p:spPr>
+          <a:xfrm>
+            <a:off x="10012680" y="1344168"/>
+            <a:ext cx="822960" cy="457200"/>
+          </a:xfrm>
+          <a:prstGeom prst="rect">
+            <a:avLst/>
+          </a:prstGeom>
+          <a:noFill/>
+          <a:ln/>
+        </p:spPr>
+        <p:txBody>
+          <a:bodyPr wrap="square" lIns="0" tIns="0" rIns="0" bIns="0" rtlCol="0" anchor="ctr"/>
+          <a:lstStyle/>
+          <a:p>
+            <a:pPr indent="0" marL="0">
+              <a:buNone/>
+            </a:pPr>
+            <a:r>
+              <a:rPr lang="en-US" sz="2400" b="1" dirty="0">
+                <a:solidFill>
+                  <a:schemeClr val="accent6"/>
+                </a:solidFill>
+                <a:latin typeface="Arial" pitchFamily="34" charset="0"/>
+                <a:ea typeface="Arial" pitchFamily="34" charset="-122"/>
+                <a:cs typeface="Arial" pitchFamily="34" charset="-120"/>
+              </a:rPr>
+              <a:t>02</a:t>
+            </a:r>
+            <a:endParaRPr lang="en-US" sz="2400" dirty="0"/>
+          </a:p>
+        </p:txBody>
+      </p:sp>
       <p:pic>
         <p:nvPicPr>
-          <p:cNvPr id="12" name="Pipeline 2 icon" descr="Pipeline 2">    </p:cNvPr>
+          <p:cNvPr id="13" name="Step icon 2" descr="Python gom và làm sạch">    </p:cNvPr>
           <p:cNvPicPr>
             <a:picLocks noChangeAspect="1"/>
           </p:cNvPicPr>
@@ -2843,8 +2898,8 @@
         </p:blipFill>
         <p:spPr>
           <a:xfrm>
-            <a:off x="8892540" y="2491740"/>
-            <a:ext cx="411480" cy="411480"/>
+            <a:off x="11109960" y="1389888"/>
+            <a:ext cx="384048" cy="384048"/>
           </a:xfrm>
           <a:prstGeom prst="rect">
             <a:avLst/>
@@ -2853,14 +2908,14 @@
       </p:pic>
       <p:sp>
         <p:nvSpPr>
-          <p:cNvPr id="13" name="Pipeline label 2"/>
+          <p:cNvPr id="14" name="Step label 2"/>
           <p:cNvSpPr txBox="1"/>
           <p:nvPr/>
         </p:nvSpPr>
         <p:spPr>
           <a:xfrm>
-            <a:off x="9692640" y="2286000"/>
-            <a:ext cx="2194560" cy="822960"/>
+            <a:off x="10012680" y="1965960"/>
+            <a:ext cx="1508760" cy="914400"/>
           </a:xfrm>
           <a:prstGeom prst="rect">
             <a:avLst/>
@@ -2869,7 +2924,7 @@
           <a:ln/>
         </p:spPr>
         <p:txBody>
-          <a:bodyPr wrap="square" lIns="0" tIns="0" rIns="0" bIns="0" rtlCol="0" anchor="ctr"/>
+          <a:bodyPr wrap="square" lIns="0" tIns="0" rIns="0" bIns="0" rtlCol="0" anchor="b"/>
           <a:lstStyle/>
           <a:p>
             <a:pPr indent="0" marL="0">
@@ -2889,16 +2944,16 @@
       </p:sp>
       <p:sp>
         <p:nvSpPr>
-          <p:cNvPr id="14" name="Pipeline 3 circle"/>
+          <p:cNvPr id="15" name="Step tile 3"/>
           <p:cNvSpPr/>
           <p:nvPr/>
         </p:nvSpPr>
         <p:spPr>
           <a:xfrm>
-            <a:off x="8686800" y="3657600"/>
-            <a:ext cx="822960" cy="822960"/>
-          </a:xfrm>
-          <a:prstGeom prst="ellipse">
+            <a:off x="7955280" y="3154680"/>
+            <a:ext cx="1783080" cy="1783080"/>
+          </a:xfrm>
+          <a:prstGeom prst="rect">
             <a:avLst/>
           </a:prstGeom>
           <a:solidFill>
@@ -2912,9 +2967,48 @@
           </a:ln>
         </p:spPr>
       </p:sp>
+      <p:sp>
+        <p:nvSpPr>
+          <p:cNvPr id="16" name="Step number 3"/>
+          <p:cNvSpPr txBox="1"/>
+          <p:nvPr/>
+        </p:nvSpPr>
+        <p:spPr>
+          <a:xfrm>
+            <a:off x="8092440" y="3264408"/>
+            <a:ext cx="822960" cy="457200"/>
+          </a:xfrm>
+          <a:prstGeom prst="rect">
+            <a:avLst/>
+          </a:prstGeom>
+          <a:noFill/>
+          <a:ln/>
+        </p:spPr>
+        <p:txBody>
+          <a:bodyPr wrap="square" lIns="0" tIns="0" rIns="0" bIns="0" rtlCol="0" anchor="ctr"/>
+          <a:lstStyle/>
+          <a:p>
+            <a:pPr indent="0" marL="0">
+              <a:buNone/>
+            </a:pPr>
+            <a:r>
+              <a:rPr lang="en-US" sz="2400" b="1" dirty="0">
+                <a:solidFill>
+                  <a:schemeClr val="accent6"/>
+                </a:solidFill>
+                <a:latin typeface="Arial" pitchFamily="34" charset="0"/>
+                <a:ea typeface="Arial" pitchFamily="34" charset="-122"/>
+                <a:cs typeface="Arial" pitchFamily="34" charset="-120"/>
+              </a:rPr>
+              <a:t>03</a:t>
+            </a:r>
+            <a:endParaRPr lang="en-US" sz="2400" dirty="0"/>
+          </a:p>
+        </p:txBody>
+      </p:sp>
       <p:pic>
         <p:nvPicPr>
-          <p:cNvPr id="15" name="Pipeline 3 icon" descr="Pipeline 3">    </p:cNvPr>
+          <p:cNvPr id="17" name="Step icon 3" descr="Lưu vào PostgreSQL">    </p:cNvPr>
           <p:cNvPicPr>
             <a:picLocks noChangeAspect="1"/>
           </p:cNvPicPr>
@@ -2928,8 +3022,8 @@
         </p:blipFill>
         <p:spPr>
           <a:xfrm>
-            <a:off x="8892540" y="3863340"/>
-            <a:ext cx="411480" cy="411480"/>
+            <a:off x="9189720" y="3310128"/>
+            <a:ext cx="384048" cy="384048"/>
           </a:xfrm>
           <a:prstGeom prst="rect">
             <a:avLst/>
@@ -2938,14 +3032,14 @@
       </p:pic>
       <p:sp>
         <p:nvSpPr>
-          <p:cNvPr id="16" name="Pipeline label 3"/>
+          <p:cNvPr id="18" name="Step label 3"/>
           <p:cNvSpPr txBox="1"/>
           <p:nvPr/>
         </p:nvSpPr>
         <p:spPr>
           <a:xfrm>
-            <a:off x="9692640" y="3657600"/>
-            <a:ext cx="2194560" cy="822960"/>
+            <a:off x="8092440" y="3886200"/>
+            <a:ext cx="1508760" cy="914400"/>
           </a:xfrm>
           <a:prstGeom prst="rect">
             <a:avLst/>
@@ -2954,7 +3048,7 @@
           <a:ln/>
         </p:spPr>
         <p:txBody>
-          <a:bodyPr wrap="square" lIns="0" tIns="0" rIns="0" bIns="0" rtlCol="0" anchor="ctr"/>
+          <a:bodyPr wrap="square" lIns="0" tIns="0" rIns="0" bIns="0" rtlCol="0" anchor="b"/>
           <a:lstStyle/>
           <a:p>
             <a:pPr indent="0" marL="0">
@@ -2974,16 +3068,16 @@
       </p:sp>
       <p:sp>
         <p:nvSpPr>
-          <p:cNvPr id="17" name="Pipeline 4 circle"/>
+          <p:cNvPr id="19" name="Step tile 4"/>
           <p:cNvSpPr/>
           <p:nvPr/>
         </p:nvSpPr>
         <p:spPr>
           <a:xfrm>
-            <a:off x="8686800" y="5029200"/>
-            <a:ext cx="822960" cy="822960"/>
-          </a:xfrm>
-          <a:prstGeom prst="ellipse">
+            <a:off x="9875520" y="3154680"/>
+            <a:ext cx="1783080" cy="1783080"/>
+          </a:xfrm>
+          <a:prstGeom prst="rect">
             <a:avLst/>
           </a:prstGeom>
           <a:solidFill>
@@ -2997,9 +3091,48 @@
           </a:ln>
         </p:spPr>
       </p:sp>
+      <p:sp>
+        <p:nvSpPr>
+          <p:cNvPr id="20" name="Step number 4"/>
+          <p:cNvSpPr txBox="1"/>
+          <p:nvPr/>
+        </p:nvSpPr>
+        <p:spPr>
+          <a:xfrm>
+            <a:off x="10012680" y="3264408"/>
+            <a:ext cx="822960" cy="457200"/>
+          </a:xfrm>
+          <a:prstGeom prst="rect">
+            <a:avLst/>
+          </a:prstGeom>
+          <a:noFill/>
+          <a:ln/>
+        </p:spPr>
+        <p:txBody>
+          <a:bodyPr wrap="square" lIns="0" tIns="0" rIns="0" bIns="0" rtlCol="0" anchor="ctr"/>
+          <a:lstStyle/>
+          <a:p>
+            <a:pPr indent="0" marL="0">
+              <a:buNone/>
+            </a:pPr>
+            <a:r>
+              <a:rPr lang="en-US" sz="2400" b="1" dirty="0">
+                <a:solidFill>
+                  <a:schemeClr val="tx2"/>
+                </a:solidFill>
+                <a:latin typeface="Arial" pitchFamily="34" charset="0"/>
+                <a:ea typeface="Arial" pitchFamily="34" charset="-122"/>
+                <a:cs typeface="Arial" pitchFamily="34" charset="-120"/>
+              </a:rPr>
+              <a:t>04</a:t>
+            </a:r>
+            <a:endParaRPr lang="en-US" sz="2400" dirty="0"/>
+          </a:p>
+        </p:txBody>
+      </p:sp>
       <p:pic>
         <p:nvPicPr>
-          <p:cNvPr id="18" name="Pipeline 4 icon" descr="Pipeline 4">    </p:cNvPr>
+          <p:cNvPr id="21" name="Step icon 4" descr="Báo cáo và AI phân tích">    </p:cNvPr>
           <p:cNvPicPr>
             <a:picLocks noChangeAspect="1"/>
           </p:cNvPicPr>
@@ -3013,8 +3146,8 @@
         </p:blipFill>
         <p:spPr>
           <a:xfrm>
-            <a:off x="8892540" y="5234940"/>
-            <a:ext cx="411480" cy="411480"/>
+            <a:off x="11109960" y="3310128"/>
+            <a:ext cx="384048" cy="384048"/>
           </a:xfrm>
           <a:prstGeom prst="rect">
             <a:avLst/>
@@ -3023,14 +3156,14 @@
       </p:pic>
       <p:sp>
         <p:nvSpPr>
-          <p:cNvPr id="19" name="Pipeline label 4"/>
+          <p:cNvPr id="22" name="Step label 4"/>
           <p:cNvSpPr txBox="1"/>
           <p:nvPr/>
         </p:nvSpPr>
         <p:spPr>
           <a:xfrm>
-            <a:off x="9692640" y="5029200"/>
-            <a:ext cx="2194560" cy="822960"/>
+            <a:off x="10012680" y="3886200"/>
+            <a:ext cx="1508760" cy="914400"/>
           </a:xfrm>
           <a:prstGeom prst="rect">
             <a:avLst/>
@@ -3039,7 +3172,7 @@
           <a:ln/>
         </p:spPr>
         <p:txBody>
-          <a:bodyPr wrap="square" lIns="0" tIns="0" rIns="0" bIns="0" rtlCol="0" anchor="ctr"/>
+          <a:bodyPr wrap="square" lIns="0" tIns="0" rIns="0" bIns="0" rtlCol="0" anchor="b"/>
           <a:lstStyle/>
           <a:p>
             <a:pPr indent="0" marL="0">
@@ -3048,7 +3181,7 @@
             <a:r>
               <a:rPr lang="en-US" sz="1500" b="1" dirty="0">
                 <a:solidFill>
-                  <a:schemeClr val="bg1"/>
+                  <a:schemeClr val="tx2"/>
                 </a:solidFill>
               </a:rPr>
               <a:t>Báo cáo và AI phân tích</a:t>
@@ -3092,8 +3225,8 @@
         </p:nvSpPr>
         <p:spPr>
           <a:xfrm>
-            <a:off x="548640" y="320040"/>
-            <a:ext cx="11091672" cy="777240"/>
+            <a:off x="1417320" y="320040"/>
+            <a:ext cx="10222992" cy="777240"/>
           </a:xfrm>
           <a:prstGeom prst="rect">
             <a:avLst/>
@@ -3113,9 +3246,9 @@
                 <a:solidFill>
                   <a:schemeClr val="bg1"/>
                 </a:solidFill>
-                <a:latin typeface="Cambria" pitchFamily="34" charset="0"/>
-                <a:ea typeface="Cambria" pitchFamily="34" charset="-122"/>
-                <a:cs typeface="Cambria" pitchFamily="34" charset="-120"/>
+                <a:latin typeface="Arial" pitchFamily="34" charset="0"/>
+                <a:ea typeface="Arial" pitchFamily="34" charset="-122"/>
+                <a:cs typeface="Arial" pitchFamily="34" charset="-120"/>
               </a:rPr>
               <a:t>Khó khăn, hướng cải thiện và tham khảo</a:t>
             </a:r>
@@ -3125,7 +3258,71 @@
       </p:sp>
       <p:sp>
         <p:nvSpPr>
-          <p:cNvPr id="3" name="Khó khăn card"/>
+          <p:cNvPr id="3" name="Slide tag"/>
+          <p:cNvSpPr/>
+          <p:nvPr/>
+        </p:nvSpPr>
+        <p:spPr>
+          <a:xfrm>
+            <a:off x="548640" y="457200"/>
+            <a:ext cx="685800" cy="502920"/>
+          </a:xfrm>
+          <a:prstGeom prst="rect">
+            <a:avLst/>
+          </a:prstGeom>
+          <a:solidFill>
+            <a:schemeClr val="accent2"/>
+          </a:solidFill>
+          <a:ln w="12700">
+            <a:solidFill>
+              <a:schemeClr val="accent2"/>
+            </a:solidFill>
+            <a:prstDash val="solid"/>
+          </a:ln>
+        </p:spPr>
+      </p:sp>
+      <p:sp>
+        <p:nvSpPr>
+          <p:cNvPr id="4" name="Slide tag number"/>
+          <p:cNvSpPr txBox="1"/>
+          <p:nvPr/>
+        </p:nvSpPr>
+        <p:spPr>
+          <a:xfrm>
+            <a:off x="548640" y="457200"/>
+            <a:ext cx="685800" cy="502920"/>
+          </a:xfrm>
+          <a:prstGeom prst="rect">
+            <a:avLst/>
+          </a:prstGeom>
+          <a:noFill/>
+          <a:ln/>
+        </p:spPr>
+        <p:txBody>
+          <a:bodyPr wrap="square" lIns="0" tIns="0" rIns="0" bIns="0" rtlCol="0" anchor="ctr"/>
+          <a:lstStyle/>
+          <a:p>
+            <a:pPr algn="ctr" indent="0" marL="0">
+              <a:buNone/>
+            </a:pPr>
+            <a:r>
+              <a:rPr lang="en-US" sz="2000" b="1" dirty="0">
+                <a:solidFill>
+                  <a:schemeClr val="tx2"/>
+                </a:solidFill>
+                <a:latin typeface="Arial" pitchFamily="34" charset="0"/>
+                <a:ea typeface="Arial" pitchFamily="34" charset="-122"/>
+                <a:cs typeface="Arial" pitchFamily="34" charset="-120"/>
+              </a:rPr>
+              <a:t>10</a:t>
+            </a:r>
+            <a:endParaRPr lang="en-US" sz="2000" dirty="0"/>
+          </a:p>
+        </p:txBody>
+      </p:sp>
+      <p:sp>
+        <p:nvSpPr>
+          <p:cNvPr id="5" name="Khó khăn card"/>
           <p:cNvSpPr/>
           <p:nvPr/>
         </p:nvSpPr>
@@ -3134,7 +3331,7 @@
             <a:off x="548640" y="1371600"/>
             <a:ext cx="3520440" cy="4343400"/>
           </a:xfrm>
-          <a:prstGeom prst="roundRect">
+          <a:prstGeom prst="rect">
             <a:avLst>
               <a:gd name="adj" fmla="val 3117"/>
             </a:avLst>
@@ -3156,7 +3353,7 @@
       </p:sp>
       <p:sp>
         <p:nvSpPr>
-          <p:cNvPr id="4" name="Khó khăn circle"/>
+          <p:cNvPr id="6" name="Khó khăn circle"/>
           <p:cNvSpPr/>
           <p:nvPr/>
         </p:nvSpPr>
@@ -3165,7 +3362,7 @@
             <a:off x="822960" y="1600200"/>
             <a:ext cx="594360" cy="594360"/>
           </a:xfrm>
-          <a:prstGeom prst="ellipse">
+          <a:prstGeom prst="rect">
             <a:avLst/>
           </a:prstGeom>
           <a:solidFill>
@@ -3181,7 +3378,7 @@
       </p:sp>
       <p:pic>
         <p:nvPicPr>
-          <p:cNvPr id="5" name="Khó khăn icon" descr="Khó khăn">    </p:cNvPr>
+          <p:cNvPr id="7" name="Khó khăn icon" descr="Khó khăn">    </p:cNvPr>
           <p:cNvPicPr>
             <a:picLocks noChangeAspect="1"/>
           </p:cNvPicPr>
@@ -3205,7 +3402,7 @@
       </p:pic>
       <p:sp>
         <p:nvSpPr>
-          <p:cNvPr id="6" name="Khó khăn header"/>
+          <p:cNvPr id="8" name="Khó khăn header"/>
           <p:cNvSpPr txBox="1"/>
           <p:nvPr/>
         </p:nvSpPr>
@@ -3241,7 +3438,7 @@
       </p:sp>
       <p:sp>
         <p:nvSpPr>
-          <p:cNvPr id="7" name="Khó khăn body"/>
+          <p:cNvPr id="9" name="Khó khăn body"/>
           <p:cNvSpPr txBox="1"/>
           <p:nvPr/>
         </p:nvSpPr>
@@ -3335,7 +3532,7 @@
       </p:sp>
       <p:sp>
         <p:nvSpPr>
-          <p:cNvPr id="8" name="Hướng cải thiện card"/>
+          <p:cNvPr id="10" name="Hướng cải thiện card"/>
           <p:cNvSpPr/>
           <p:nvPr/>
         </p:nvSpPr>
@@ -3344,7 +3541,7 @@
             <a:off x="4334256" y="1371600"/>
             <a:ext cx="3520440" cy="4343400"/>
           </a:xfrm>
-          <a:prstGeom prst="roundRect">
+          <a:prstGeom prst="rect">
             <a:avLst>
               <a:gd name="adj" fmla="val 3117"/>
             </a:avLst>
@@ -3366,7 +3563,7 @@
       </p:sp>
       <p:sp>
         <p:nvSpPr>
-          <p:cNvPr id="9" name="Hướng cải thiện circle"/>
+          <p:cNvPr id="11" name="Hướng cải thiện circle"/>
           <p:cNvSpPr/>
           <p:nvPr/>
         </p:nvSpPr>
@@ -3375,7 +3572,7 @@
             <a:off x="4608576" y="1600200"/>
             <a:ext cx="594360" cy="594360"/>
           </a:xfrm>
-          <a:prstGeom prst="ellipse">
+          <a:prstGeom prst="rect">
             <a:avLst/>
           </a:prstGeom>
           <a:solidFill>
@@ -3391,7 +3588,7 @@
       </p:sp>
       <p:pic>
         <p:nvPicPr>
-          <p:cNvPr id="10" name="Hướng cải thiện icon" descr="Hướng cải thiện">    </p:cNvPr>
+          <p:cNvPr id="12" name="Hướng cải thiện icon" descr="Hướng cải thiện">    </p:cNvPr>
           <p:cNvPicPr>
             <a:picLocks noChangeAspect="1"/>
           </p:cNvPicPr>
@@ -3415,7 +3612,7 @@
       </p:pic>
       <p:sp>
         <p:nvSpPr>
-          <p:cNvPr id="11" name="Hướng cải thiện header"/>
+          <p:cNvPr id="13" name="Hướng cải thiện header"/>
           <p:cNvSpPr txBox="1"/>
           <p:nvPr/>
         </p:nvSpPr>
@@ -3451,7 +3648,7 @@
       </p:sp>
       <p:sp>
         <p:nvSpPr>
-          <p:cNvPr id="12" name="Hướng cải thiện body"/>
+          <p:cNvPr id="14" name="Hướng cải thiện body"/>
           <p:cNvSpPr txBox="1"/>
           <p:nvPr/>
         </p:nvSpPr>
@@ -3545,7 +3742,7 @@
       </p:sp>
       <p:sp>
         <p:nvSpPr>
-          <p:cNvPr id="13" name="Nguồn tham khảo card"/>
+          <p:cNvPr id="15" name="Nguồn tham khảo card"/>
           <p:cNvSpPr/>
           <p:nvPr/>
         </p:nvSpPr>
@@ -3554,7 +3751,7 @@
             <a:off x="8119872" y="1371600"/>
             <a:ext cx="3520440" cy="4343400"/>
           </a:xfrm>
-          <a:prstGeom prst="roundRect">
+          <a:prstGeom prst="rect">
             <a:avLst>
               <a:gd name="adj" fmla="val 3117"/>
             </a:avLst>
@@ -3576,7 +3773,7 @@
       </p:sp>
       <p:sp>
         <p:nvSpPr>
-          <p:cNvPr id="14" name="Nguồn tham khảo circle"/>
+          <p:cNvPr id="16" name="Nguồn tham khảo circle"/>
           <p:cNvSpPr/>
           <p:nvPr/>
         </p:nvSpPr>
@@ -3585,7 +3782,7 @@
             <a:off x="8394192" y="1600200"/>
             <a:ext cx="594360" cy="594360"/>
           </a:xfrm>
-          <a:prstGeom prst="ellipse">
+          <a:prstGeom prst="rect">
             <a:avLst/>
           </a:prstGeom>
           <a:solidFill>
@@ -3601,7 +3798,7 @@
       </p:sp>
       <p:pic>
         <p:nvPicPr>
-          <p:cNvPr id="15" name="Nguồn tham khảo icon" descr="Nguồn tham khảo">    </p:cNvPr>
+          <p:cNvPr id="17" name="Nguồn tham khảo icon" descr="Nguồn tham khảo">    </p:cNvPr>
           <p:cNvPicPr>
             <a:picLocks noChangeAspect="1"/>
           </p:cNvPicPr>
@@ -3625,7 +3822,7 @@
       </p:pic>
       <p:sp>
         <p:nvSpPr>
-          <p:cNvPr id="16" name="Nguồn tham khảo header"/>
+          <p:cNvPr id="18" name="Nguồn tham khảo header"/>
           <p:cNvSpPr txBox="1"/>
           <p:nvPr/>
         </p:nvSpPr>
@@ -3661,7 +3858,7 @@
       </p:sp>
       <p:sp>
         <p:nvSpPr>
-          <p:cNvPr id="17" name="Nguồn tham khảo body"/>
+          <p:cNvPr id="19" name="Nguồn tham khảo body"/>
           <p:cNvSpPr txBox="1"/>
           <p:nvPr/>
         </p:nvSpPr>
@@ -3791,7 +3988,7 @@
       </p:sp>
       <p:sp>
         <p:nvSpPr>
-          <p:cNvPr id="18" name="Thanks"/>
+          <p:cNvPr id="20" name="Thanks"/>
           <p:cNvSpPr txBox="1"/>
           <p:nvPr/>
         </p:nvSpPr>
@@ -3905,8 +4102,8 @@
         </p:nvSpPr>
         <p:spPr>
           <a:xfrm>
-            <a:off x="548640" y="320040"/>
-            <a:ext cx="11091672" cy="777240"/>
+            <a:off x="1417320" y="320040"/>
+            <a:ext cx="10222992" cy="777240"/>
           </a:xfrm>
           <a:prstGeom prst="rect">
             <a:avLst/>
@@ -3926,9 +4123,9 @@
                 <a:solidFill>
                   <a:schemeClr val="tx2"/>
                 </a:solidFill>
-                <a:latin typeface="Cambria" pitchFamily="34" charset="0"/>
-                <a:ea typeface="Cambria" pitchFamily="34" charset="-122"/>
-                <a:cs typeface="Cambria" pitchFamily="34" charset="-120"/>
+                <a:latin typeface="Arial" pitchFamily="34" charset="0"/>
+                <a:ea typeface="Arial" pitchFamily="34" charset="-122"/>
+                <a:cs typeface="Arial" pitchFamily="34" charset="-120"/>
               </a:rPr>
               <a:t>Đặt vấn đề và mục tiêu</a:t>
             </a:r>
@@ -3938,7 +4135,71 @@
       </p:sp>
       <p:sp>
         <p:nvSpPr>
-          <p:cNvPr id="3" name="Vấn đề hiện tại card"/>
+          <p:cNvPr id="3" name="Slide tag"/>
+          <p:cNvSpPr/>
+          <p:nvPr/>
+        </p:nvSpPr>
+        <p:spPr>
+          <a:xfrm>
+            <a:off x="548640" y="457200"/>
+            <a:ext cx="685800" cy="502920"/>
+          </a:xfrm>
+          <a:prstGeom prst="rect">
+            <a:avLst/>
+          </a:prstGeom>
+          <a:solidFill>
+            <a:schemeClr val="accent2"/>
+          </a:solidFill>
+          <a:ln w="12700">
+            <a:solidFill>
+              <a:schemeClr val="accent2"/>
+            </a:solidFill>
+            <a:prstDash val="solid"/>
+          </a:ln>
+        </p:spPr>
+      </p:sp>
+      <p:sp>
+        <p:nvSpPr>
+          <p:cNvPr id="4" name="Slide tag number"/>
+          <p:cNvSpPr txBox="1"/>
+          <p:nvPr/>
+        </p:nvSpPr>
+        <p:spPr>
+          <a:xfrm>
+            <a:off x="548640" y="457200"/>
+            <a:ext cx="685800" cy="502920"/>
+          </a:xfrm>
+          <a:prstGeom prst="rect">
+            <a:avLst/>
+          </a:prstGeom>
+          <a:noFill/>
+          <a:ln/>
+        </p:spPr>
+        <p:txBody>
+          <a:bodyPr wrap="square" lIns="0" tIns="0" rIns="0" bIns="0" rtlCol="0" anchor="ctr"/>
+          <a:lstStyle/>
+          <a:p>
+            <a:pPr algn="ctr" indent="0" marL="0">
+              <a:buNone/>
+            </a:pPr>
+            <a:r>
+              <a:rPr lang="en-US" sz="2000" b="1" dirty="0">
+                <a:solidFill>
+                  <a:schemeClr val="tx2"/>
+                </a:solidFill>
+                <a:latin typeface="Arial" pitchFamily="34" charset="0"/>
+                <a:ea typeface="Arial" pitchFamily="34" charset="-122"/>
+                <a:cs typeface="Arial" pitchFamily="34" charset="-120"/>
+              </a:rPr>
+              <a:t>02</a:t>
+            </a:r>
+            <a:endParaRPr lang="en-US" sz="2000" dirty="0"/>
+          </a:p>
+        </p:txBody>
+      </p:sp>
+      <p:sp>
+        <p:nvSpPr>
+          <p:cNvPr id="5" name="Vấn đề hiện tại card"/>
           <p:cNvSpPr/>
           <p:nvPr/>
         </p:nvSpPr>
@@ -3947,7 +4208,7 @@
             <a:off x="548640" y="1371600"/>
             <a:ext cx="5349240" cy="4617720"/>
           </a:xfrm>
-          <a:prstGeom prst="roundRect">
+          <a:prstGeom prst="rect">
             <a:avLst>
               <a:gd name="adj" fmla="val 2970"/>
             </a:avLst>
@@ -3965,7 +4226,7 @@
       </p:sp>
       <p:sp>
         <p:nvSpPr>
-          <p:cNvPr id="4" name="Vấn đề hiện tại circle"/>
+          <p:cNvPr id="6" name="Vấn đề hiện tại circle"/>
           <p:cNvSpPr/>
           <p:nvPr/>
         </p:nvSpPr>
@@ -3974,7 +4235,7 @@
             <a:off x="914400" y="1691640"/>
             <a:ext cx="685800" cy="685800"/>
           </a:xfrm>
-          <a:prstGeom prst="ellipse">
+          <a:prstGeom prst="rect">
             <a:avLst/>
           </a:prstGeom>
           <a:solidFill>
@@ -3990,7 +4251,7 @@
       </p:sp>
       <p:pic>
         <p:nvPicPr>
-          <p:cNvPr id="5" name="Vấn đề hiện tại icon" descr="Vấn đề hiện tại">    </p:cNvPr>
+          <p:cNvPr id="7" name="Vấn đề hiện tại icon" descr="Vấn đề hiện tại">    </p:cNvPr>
           <p:cNvPicPr>
             <a:picLocks noChangeAspect="1"/>
           </p:cNvPicPr>
@@ -4014,7 +4275,7 @@
       </p:pic>
       <p:sp>
         <p:nvSpPr>
-          <p:cNvPr id="6" name="Vấn đề hiện tại header"/>
+          <p:cNvPr id="8" name="Vấn đề hiện tại header"/>
           <p:cNvSpPr txBox="1"/>
           <p:nvPr/>
         </p:nvSpPr>
@@ -4050,7 +4311,7 @@
       </p:sp>
       <p:sp>
         <p:nvSpPr>
-          <p:cNvPr id="7" name="Vấn đề hiện tại bullets"/>
+          <p:cNvPr id="9" name="Vấn đề hiện tại bullets"/>
           <p:cNvSpPr txBox="1"/>
           <p:nvPr/>
         </p:nvSpPr>
@@ -4144,7 +4405,7 @@
       </p:sp>
       <p:sp>
         <p:nvSpPr>
-          <p:cNvPr id="8" name="Mục tiêu của Task 1 card"/>
+          <p:cNvPr id="10" name="Mục tiêu của Task 1 card"/>
           <p:cNvSpPr/>
           <p:nvPr/>
         </p:nvSpPr>
@@ -4153,7 +4414,7 @@
             <a:off x="6291072" y="1371600"/>
             <a:ext cx="5349240" cy="4617720"/>
           </a:xfrm>
-          <a:prstGeom prst="roundRect">
+          <a:prstGeom prst="rect">
             <a:avLst>
               <a:gd name="adj" fmla="val 2970"/>
             </a:avLst>
@@ -4171,7 +4432,7 @@
       </p:sp>
       <p:sp>
         <p:nvSpPr>
-          <p:cNvPr id="9" name="Mục tiêu của Task 1 circle"/>
+          <p:cNvPr id="11" name="Mục tiêu của Task 1 circle"/>
           <p:cNvSpPr/>
           <p:nvPr/>
         </p:nvSpPr>
@@ -4180,7 +4441,7 @@
             <a:off x="6656832" y="1691640"/>
             <a:ext cx="685800" cy="685800"/>
           </a:xfrm>
-          <a:prstGeom prst="ellipse">
+          <a:prstGeom prst="rect">
             <a:avLst/>
           </a:prstGeom>
           <a:solidFill>
@@ -4196,7 +4457,7 @@
       </p:sp>
       <p:pic>
         <p:nvPicPr>
-          <p:cNvPr id="10" name="Mục tiêu của Task 1 icon" descr="Mục tiêu của Task 1">    </p:cNvPr>
+          <p:cNvPr id="12" name="Mục tiêu của Task 1 icon" descr="Mục tiêu của Task 1">    </p:cNvPr>
           <p:cNvPicPr>
             <a:picLocks noChangeAspect="1"/>
           </p:cNvPicPr>
@@ -4220,7 +4481,7 @@
       </p:pic>
       <p:sp>
         <p:nvSpPr>
-          <p:cNvPr id="11" name="Mục tiêu của Task 1 header"/>
+          <p:cNvPr id="13" name="Mục tiêu của Task 1 header"/>
           <p:cNvSpPr txBox="1"/>
           <p:nvPr/>
         </p:nvSpPr>
@@ -4256,7 +4517,7 @@
       </p:sp>
       <p:sp>
         <p:nvSpPr>
-          <p:cNvPr id="12" name="Mục tiêu của Task 1 bullets"/>
+          <p:cNvPr id="14" name="Mục tiêu của Task 1 bullets"/>
           <p:cNvSpPr txBox="1"/>
           <p:nvPr/>
         </p:nvSpPr>
@@ -4350,7 +4611,7 @@
       </p:sp>
       <p:sp>
         <p:nvSpPr>
-          <p:cNvPr id="13" name="Problem to goal circle"/>
+          <p:cNvPr id="15" name="Problem to goal circle"/>
           <p:cNvSpPr/>
           <p:nvPr/>
         </p:nvSpPr>
@@ -4359,7 +4620,7 @@
             <a:off x="5824728" y="3364992"/>
             <a:ext cx="548640" cy="548640"/>
           </a:xfrm>
-          <a:prstGeom prst="ellipse">
+          <a:prstGeom prst="rect">
             <a:avLst/>
           </a:prstGeom>
           <a:solidFill>
@@ -4375,7 +4636,7 @@
       </p:sp>
       <p:pic>
         <p:nvPicPr>
-          <p:cNvPr id="14" name="Problem to goal icon" descr="Problem to goal">    </p:cNvPr>
+          <p:cNvPr id="16" name="Problem to goal icon" descr="Problem to goal">    </p:cNvPr>
           <p:cNvPicPr>
             <a:picLocks noChangeAspect="1"/>
           </p:cNvPicPr>
@@ -4477,8 +4738,8 @@
         </p:nvSpPr>
         <p:spPr>
           <a:xfrm>
-            <a:off x="548640" y="320040"/>
-            <a:ext cx="11091672" cy="777240"/>
+            <a:off x="1417320" y="320040"/>
+            <a:ext cx="10222992" cy="777240"/>
           </a:xfrm>
           <a:prstGeom prst="rect">
             <a:avLst/>
@@ -4498,9 +4759,9 @@
                 <a:solidFill>
                   <a:schemeClr val="tx2"/>
                 </a:solidFill>
-                <a:latin typeface="Cambria" pitchFamily="34" charset="0"/>
-                <a:ea typeface="Cambria" pitchFamily="34" charset="-122"/>
-                <a:cs typeface="Cambria" pitchFamily="34" charset="-120"/>
+                <a:latin typeface="Arial" pitchFamily="34" charset="0"/>
+                <a:ea typeface="Arial" pitchFamily="34" charset="-122"/>
+                <a:cs typeface="Arial" pitchFamily="34" charset="-120"/>
               </a:rPr>
               <a:t>Phân tích bài toán tuyển dụng</a:t>
             </a:r>
@@ -4510,7 +4771,71 @@
       </p:sp>
       <p:sp>
         <p:nvSpPr>
-          <p:cNvPr id="3" name="Funnel 1"/>
+          <p:cNvPr id="3" name="Slide tag"/>
+          <p:cNvSpPr/>
+          <p:nvPr/>
+        </p:nvSpPr>
+        <p:spPr>
+          <a:xfrm>
+            <a:off x="548640" y="457200"/>
+            <a:ext cx="685800" cy="502920"/>
+          </a:xfrm>
+          <a:prstGeom prst="rect">
+            <a:avLst/>
+          </a:prstGeom>
+          <a:solidFill>
+            <a:schemeClr val="accent2"/>
+          </a:solidFill>
+          <a:ln w="12700">
+            <a:solidFill>
+              <a:schemeClr val="accent2"/>
+            </a:solidFill>
+            <a:prstDash val="solid"/>
+          </a:ln>
+        </p:spPr>
+      </p:sp>
+      <p:sp>
+        <p:nvSpPr>
+          <p:cNvPr id="4" name="Slide tag number"/>
+          <p:cNvSpPr txBox="1"/>
+          <p:nvPr/>
+        </p:nvSpPr>
+        <p:spPr>
+          <a:xfrm>
+            <a:off x="548640" y="457200"/>
+            <a:ext cx="685800" cy="502920"/>
+          </a:xfrm>
+          <a:prstGeom prst="rect">
+            <a:avLst/>
+          </a:prstGeom>
+          <a:noFill/>
+          <a:ln/>
+        </p:spPr>
+        <p:txBody>
+          <a:bodyPr wrap="square" lIns="0" tIns="0" rIns="0" bIns="0" rtlCol="0" anchor="ctr"/>
+          <a:lstStyle/>
+          <a:p>
+            <a:pPr algn="ctr" indent="0" marL="0">
+              <a:buNone/>
+            </a:pPr>
+            <a:r>
+              <a:rPr lang="en-US" sz="2000" b="1" dirty="0">
+                <a:solidFill>
+                  <a:schemeClr val="tx2"/>
+                </a:solidFill>
+                <a:latin typeface="Arial" pitchFamily="34" charset="0"/>
+                <a:ea typeface="Arial" pitchFamily="34" charset="-122"/>
+                <a:cs typeface="Arial" pitchFamily="34" charset="-120"/>
+              </a:rPr>
+              <a:t>03</a:t>
+            </a:r>
+            <a:endParaRPr lang="en-US" sz="2000" dirty="0"/>
+          </a:p>
+        </p:txBody>
+      </p:sp>
+      <p:sp>
+        <p:nvSpPr>
+          <p:cNvPr id="5" name="Funnel 1"/>
           <p:cNvSpPr/>
           <p:nvPr/>
         </p:nvSpPr>
@@ -4519,7 +4844,7 @@
             <a:off x="548640" y="1417320"/>
             <a:ext cx="5303520" cy="658368"/>
           </a:xfrm>
-          <a:prstGeom prst="roundRect">
+          <a:prstGeom prst="rect">
             <a:avLst>
               <a:gd name="adj" fmla="val 11111"/>
             </a:avLst>
@@ -4537,7 +4862,7 @@
       </p:sp>
       <p:sp>
         <p:nvSpPr>
-          <p:cNvPr id="4" name="Funnel label 1"/>
+          <p:cNvPr id="6" name="Funnel label 1"/>
           <p:cNvSpPr txBox="1"/>
           <p:nvPr/>
         </p:nvSpPr>
@@ -4573,7 +4898,7 @@
       </p:sp>
       <p:sp>
         <p:nvSpPr>
-          <p:cNvPr id="5" name="Funnel 2"/>
+          <p:cNvPr id="7" name="Funnel 2"/>
           <p:cNvSpPr/>
           <p:nvPr/>
         </p:nvSpPr>
@@ -4582,7 +4907,7 @@
             <a:off x="914400" y="2203704"/>
             <a:ext cx="4572000" cy="658368"/>
           </a:xfrm>
-          <a:prstGeom prst="roundRect">
+          <a:prstGeom prst="rect">
             <a:avLst>
               <a:gd name="adj" fmla="val 11111"/>
             </a:avLst>
@@ -4600,7 +4925,7 @@
       </p:sp>
       <p:sp>
         <p:nvSpPr>
-          <p:cNvPr id="6" name="Funnel label 2"/>
+          <p:cNvPr id="8" name="Funnel label 2"/>
           <p:cNvSpPr txBox="1"/>
           <p:nvPr/>
         </p:nvSpPr>
@@ -4636,7 +4961,7 @@
       </p:sp>
       <p:sp>
         <p:nvSpPr>
-          <p:cNvPr id="7" name="Funnel 3"/>
+          <p:cNvPr id="9" name="Funnel 3"/>
           <p:cNvSpPr/>
           <p:nvPr/>
         </p:nvSpPr>
@@ -4645,7 +4970,7 @@
             <a:off x="1280160" y="2990088"/>
             <a:ext cx="3840480" cy="658368"/>
           </a:xfrm>
-          <a:prstGeom prst="roundRect">
+          <a:prstGeom prst="rect">
             <a:avLst>
               <a:gd name="adj" fmla="val 11111"/>
             </a:avLst>
@@ -4663,7 +4988,7 @@
       </p:sp>
       <p:sp>
         <p:nvSpPr>
-          <p:cNvPr id="8" name="Funnel label 3"/>
+          <p:cNvPr id="10" name="Funnel label 3"/>
           <p:cNvSpPr txBox="1"/>
           <p:nvPr/>
         </p:nvSpPr>
@@ -4699,7 +5024,7 @@
       </p:sp>
       <p:sp>
         <p:nvSpPr>
-          <p:cNvPr id="9" name="Funnel 4"/>
+          <p:cNvPr id="11" name="Funnel 4"/>
           <p:cNvSpPr/>
           <p:nvPr/>
         </p:nvSpPr>
@@ -4708,7 +5033,7 @@
             <a:off x="1645920" y="3776472"/>
             <a:ext cx="3108960" cy="658368"/>
           </a:xfrm>
-          <a:prstGeom prst="roundRect">
+          <a:prstGeom prst="rect">
             <a:avLst>
               <a:gd name="adj" fmla="val 11111"/>
             </a:avLst>
@@ -4726,7 +5051,7 @@
       </p:sp>
       <p:sp>
         <p:nvSpPr>
-          <p:cNvPr id="10" name="Funnel label 4"/>
+          <p:cNvPr id="12" name="Funnel label 4"/>
           <p:cNvSpPr txBox="1"/>
           <p:nvPr/>
         </p:nvSpPr>
@@ -4762,7 +5087,7 @@
       </p:sp>
       <p:sp>
         <p:nvSpPr>
-          <p:cNvPr id="11" name="Funnel 5"/>
+          <p:cNvPr id="13" name="Funnel 5"/>
           <p:cNvSpPr/>
           <p:nvPr/>
         </p:nvSpPr>
@@ -4771,7 +5096,7 @@
             <a:off x="2011680" y="4562856"/>
             <a:ext cx="2377440" cy="658368"/>
           </a:xfrm>
-          <a:prstGeom prst="roundRect">
+          <a:prstGeom prst="rect">
             <a:avLst>
               <a:gd name="adj" fmla="val 11111"/>
             </a:avLst>
@@ -4789,7 +5114,7 @@
       </p:sp>
       <p:sp>
         <p:nvSpPr>
-          <p:cNvPr id="12" name="Funnel label 5"/>
+          <p:cNvPr id="14" name="Funnel label 5"/>
           <p:cNvSpPr txBox="1"/>
           <p:nvPr/>
         </p:nvSpPr>
@@ -4825,7 +5150,7 @@
       </p:sp>
       <p:sp>
         <p:nvSpPr>
-          <p:cNvPr id="13" name="Funnel caption"/>
+          <p:cNvPr id="15" name="Funnel caption"/>
           <p:cNvSpPr txBox="1"/>
           <p:nvPr/>
         </p:nvSpPr>
@@ -4861,7 +5186,7 @@
       </p:sp>
       <p:sp>
         <p:nvSpPr>
-          <p:cNvPr id="14" name="Roles header"/>
+          <p:cNvPr id="16" name="Roles header"/>
           <p:cNvSpPr txBox="1"/>
           <p:nvPr/>
         </p:nvSpPr>
@@ -4897,7 +5222,7 @@
       </p:sp>
       <p:sp>
         <p:nvSpPr>
-          <p:cNvPr id="15" name="Role Admin circle"/>
+          <p:cNvPr id="17" name="Role Admin circle"/>
           <p:cNvSpPr/>
           <p:nvPr/>
         </p:nvSpPr>
@@ -4906,7 +5231,7 @@
             <a:off x="6309360" y="1920240"/>
             <a:ext cx="475488" cy="475488"/>
           </a:xfrm>
-          <a:prstGeom prst="ellipse">
+          <a:prstGeom prst="rect">
             <a:avLst/>
           </a:prstGeom>
           <a:solidFill>
@@ -4922,7 +5247,7 @@
       </p:sp>
       <p:pic>
         <p:nvPicPr>
-          <p:cNvPr id="16" name="Role Admin icon" descr="Role Admin">    </p:cNvPr>
+          <p:cNvPr id="18" name="Role Admin icon" descr="Role Admin">    </p:cNvPr>
           <p:cNvPicPr>
             <a:picLocks noChangeAspect="1"/>
           </p:cNvPicPr>
@@ -4946,7 +5271,7 @@
       </p:pic>
       <p:sp>
         <p:nvSpPr>
-          <p:cNvPr id="17" name="Role text Admin"/>
+          <p:cNvPr id="19" name="Role text Admin"/>
           <p:cNvSpPr txBox="1"/>
           <p:nvPr/>
         </p:nvSpPr>
@@ -4990,7 +5315,7 @@
       </p:sp>
       <p:sp>
         <p:nvSpPr>
-          <p:cNvPr id="18" name="Role HR circle"/>
+          <p:cNvPr id="20" name="Role HR circle"/>
           <p:cNvSpPr/>
           <p:nvPr/>
         </p:nvSpPr>
@@ -4999,7 +5324,7 @@
             <a:off x="6309360" y="2542032"/>
             <a:ext cx="475488" cy="475488"/>
           </a:xfrm>
-          <a:prstGeom prst="ellipse">
+          <a:prstGeom prst="rect">
             <a:avLst/>
           </a:prstGeom>
           <a:solidFill>
@@ -5015,7 +5340,7 @@
       </p:sp>
       <p:pic>
         <p:nvPicPr>
-          <p:cNvPr id="19" name="Role HR icon" descr="Role HR">    </p:cNvPr>
+          <p:cNvPr id="21" name="Role HR icon" descr="Role HR">    </p:cNvPr>
           <p:cNvPicPr>
             <a:picLocks noChangeAspect="1"/>
           </p:cNvPicPr>
@@ -5039,7 +5364,7 @@
       </p:pic>
       <p:sp>
         <p:nvSpPr>
-          <p:cNvPr id="20" name="Role text HR"/>
+          <p:cNvPr id="22" name="Role text HR"/>
           <p:cNvSpPr txBox="1"/>
           <p:nvPr/>
         </p:nvSpPr>
@@ -5083,7 +5408,7 @@
       </p:sp>
       <p:sp>
         <p:nvSpPr>
-          <p:cNvPr id="21" name="Role Quản lý circle"/>
+          <p:cNvPr id="23" name="Role Quản lý circle"/>
           <p:cNvSpPr/>
           <p:nvPr/>
         </p:nvSpPr>
@@ -5092,7 +5417,7 @@
             <a:off x="6309360" y="3163824"/>
             <a:ext cx="475488" cy="475488"/>
           </a:xfrm>
-          <a:prstGeom prst="ellipse">
+          <a:prstGeom prst="rect">
             <a:avLst/>
           </a:prstGeom>
           <a:solidFill>
@@ -5108,7 +5433,7 @@
       </p:sp>
       <p:pic>
         <p:nvPicPr>
-          <p:cNvPr id="22" name="Role Quản lý icon" descr="Role Quản lý">    </p:cNvPr>
+          <p:cNvPr id="24" name="Role Quản lý icon" descr="Role Quản lý">    </p:cNvPr>
           <p:cNvPicPr>
             <a:picLocks noChangeAspect="1"/>
           </p:cNvPicPr>
@@ -5132,7 +5457,7 @@
       </p:pic>
       <p:sp>
         <p:nvSpPr>
-          <p:cNvPr id="23" name="Role text Quản lý"/>
+          <p:cNvPr id="25" name="Role text Quản lý"/>
           <p:cNvSpPr txBox="1"/>
           <p:nvPr/>
         </p:nvSpPr>
@@ -5176,7 +5501,7 @@
       </p:sp>
       <p:sp>
         <p:nvSpPr>
-          <p:cNvPr id="24" name="KPI header"/>
+          <p:cNvPr id="26" name="KPI header"/>
           <p:cNvSpPr txBox="1"/>
           <p:nvPr/>
         </p:nvSpPr>
@@ -5212,7 +5537,7 @@
       </p:sp>
       <p:sp>
         <p:nvSpPr>
-          <p:cNvPr id="25" name="KPI bullets"/>
+          <p:cNvPr id="27" name="KPI bullets"/>
           <p:cNvSpPr txBox="1"/>
           <p:nvPr/>
         </p:nvSpPr>
@@ -5366,8 +5691,8 @@
         </p:nvSpPr>
         <p:spPr>
           <a:xfrm>
-            <a:off x="548640" y="320040"/>
-            <a:ext cx="11091672" cy="777240"/>
+            <a:off x="1417320" y="320040"/>
+            <a:ext cx="10222992" cy="777240"/>
           </a:xfrm>
           <a:prstGeom prst="rect">
             <a:avLst/>
@@ -5387,13 +5712,77 @@
                 <a:solidFill>
                   <a:schemeClr val="tx2"/>
                 </a:solidFill>
-                <a:latin typeface="Cambria" pitchFamily="34" charset="0"/>
-                <a:ea typeface="Cambria" pitchFamily="34" charset="-122"/>
-                <a:cs typeface="Cambria" pitchFamily="34" charset="-120"/>
+                <a:latin typeface="Arial" pitchFamily="34" charset="0"/>
+                <a:ea typeface="Arial" pitchFamily="34" charset="-122"/>
+                <a:cs typeface="Arial" pitchFamily="34" charset="-120"/>
               </a:rPr>
               <a:t>Dữ liệu tuyển dụng đến từ đâu?</a:t>
             </a:r>
             <a:endParaRPr lang="en-US" sz="3200" dirty="0"/>
+          </a:p>
+        </p:txBody>
+      </p:sp>
+      <p:sp>
+        <p:nvSpPr>
+          <p:cNvPr id="3" name="Slide tag"/>
+          <p:cNvSpPr/>
+          <p:nvPr/>
+        </p:nvSpPr>
+        <p:spPr>
+          <a:xfrm>
+            <a:off x="548640" y="457200"/>
+            <a:ext cx="685800" cy="502920"/>
+          </a:xfrm>
+          <a:prstGeom prst="rect">
+            <a:avLst/>
+          </a:prstGeom>
+          <a:solidFill>
+            <a:schemeClr val="accent2"/>
+          </a:solidFill>
+          <a:ln w="12700">
+            <a:solidFill>
+              <a:schemeClr val="accent2"/>
+            </a:solidFill>
+            <a:prstDash val="solid"/>
+          </a:ln>
+        </p:spPr>
+      </p:sp>
+      <p:sp>
+        <p:nvSpPr>
+          <p:cNvPr id="4" name="Slide tag number"/>
+          <p:cNvSpPr txBox="1"/>
+          <p:nvPr/>
+        </p:nvSpPr>
+        <p:spPr>
+          <a:xfrm>
+            <a:off x="548640" y="457200"/>
+            <a:ext cx="685800" cy="502920"/>
+          </a:xfrm>
+          <a:prstGeom prst="rect">
+            <a:avLst/>
+          </a:prstGeom>
+          <a:noFill/>
+          <a:ln/>
+        </p:spPr>
+        <p:txBody>
+          <a:bodyPr wrap="square" lIns="0" tIns="0" rIns="0" bIns="0" rtlCol="0" anchor="ctr"/>
+          <a:lstStyle/>
+          <a:p>
+            <a:pPr algn="ctr" indent="0" marL="0">
+              <a:buNone/>
+            </a:pPr>
+            <a:r>
+              <a:rPr lang="en-US" sz="2000" b="1" dirty="0">
+                <a:solidFill>
+                  <a:schemeClr val="tx2"/>
+                </a:solidFill>
+                <a:latin typeface="Arial" pitchFamily="34" charset="0"/>
+                <a:ea typeface="Arial" pitchFamily="34" charset="-122"/>
+                <a:cs typeface="Arial" pitchFamily="34" charset="-120"/>
+              </a:rPr>
+              <a:t>04</a:t>
+            </a:r>
+            <a:endParaRPr lang="en-US" sz="2000" dirty="0"/>
           </a:p>
         </p:txBody>
       </p:sp>
@@ -5447,7 +5836,7 @@
                   <a:tcPr marL="109728" marR="109728" marT="54864" marB="54864" anchor="ctr">
                     <a:lnL w="9525" cap="flat" cmpd="sng" algn="ctr">
                       <a:solidFill>
-                        <a:srgbClr val="BFD8D8"/>
+                        <a:srgbClr val="D9DCE3"/>
                       </a:solidFill>
                       <a:prstDash val="solid"/>
                       <a:round/>
@@ -5456,7 +5845,7 @@
                     </a:lnL>
                     <a:lnR w="9525" cap="flat" cmpd="sng" algn="ctr">
                       <a:solidFill>
-                        <a:srgbClr val="BFD8D8"/>
+                        <a:srgbClr val="D9DCE3"/>
                       </a:solidFill>
                       <a:prstDash val="solid"/>
                       <a:round/>
@@ -5465,7 +5854,7 @@
                     </a:lnR>
                     <a:lnT w="9525" cap="flat" cmpd="sng" algn="ctr">
                       <a:solidFill>
-                        <a:srgbClr val="BFD8D8"/>
+                        <a:srgbClr val="D9DCE3"/>
                       </a:solidFill>
                       <a:prstDash val="solid"/>
                       <a:round/>
@@ -5474,7 +5863,7 @@
                     </a:lnT>
                     <a:lnB w="9525" cap="flat" cmpd="sng" algn="ctr">
                       <a:solidFill>
-                        <a:srgbClr val="BFD8D8"/>
+                        <a:srgbClr val="D9DCE3"/>
                       </a:solidFill>
                       <a:prstDash val="solid"/>
                       <a:round/>
@@ -5508,7 +5897,7 @@
                   <a:tcPr marL="109728" marR="109728" marT="54864" marB="54864" anchor="ctr">
                     <a:lnL w="9525" cap="flat" cmpd="sng" algn="ctr">
                       <a:solidFill>
-                        <a:srgbClr val="BFD8D8"/>
+                        <a:srgbClr val="D9DCE3"/>
                       </a:solidFill>
                       <a:prstDash val="solid"/>
                       <a:round/>
@@ -5517,7 +5906,7 @@
                     </a:lnL>
                     <a:lnR w="9525" cap="flat" cmpd="sng" algn="ctr">
                       <a:solidFill>
-                        <a:srgbClr val="BFD8D8"/>
+                        <a:srgbClr val="D9DCE3"/>
                       </a:solidFill>
                       <a:prstDash val="solid"/>
                       <a:round/>
@@ -5526,7 +5915,7 @@
                     </a:lnR>
                     <a:lnT w="9525" cap="flat" cmpd="sng" algn="ctr">
                       <a:solidFill>
-                        <a:srgbClr val="BFD8D8"/>
+                        <a:srgbClr val="D9DCE3"/>
                       </a:solidFill>
                       <a:prstDash val="solid"/>
                       <a:round/>
@@ -5535,7 +5924,7 @@
                     </a:lnT>
                     <a:lnB w="9525" cap="flat" cmpd="sng" algn="ctr">
                       <a:solidFill>
-                        <a:srgbClr val="BFD8D8"/>
+                        <a:srgbClr val="D9DCE3"/>
                       </a:solidFill>
                       <a:prstDash val="solid"/>
                       <a:round/>
@@ -5569,7 +5958,7 @@
                   <a:tcPr marL="109728" marR="109728" marT="54864" marB="54864" anchor="ctr">
                     <a:lnL w="9525" cap="flat" cmpd="sng" algn="ctr">
                       <a:solidFill>
-                        <a:srgbClr val="BFD8D8"/>
+                        <a:srgbClr val="D9DCE3"/>
                       </a:solidFill>
                       <a:prstDash val="solid"/>
                       <a:round/>
@@ -5578,7 +5967,7 @@
                     </a:lnL>
                     <a:lnR w="9525" cap="flat" cmpd="sng" algn="ctr">
                       <a:solidFill>
-                        <a:srgbClr val="BFD8D8"/>
+                        <a:srgbClr val="D9DCE3"/>
                       </a:solidFill>
                       <a:prstDash val="solid"/>
                       <a:round/>
@@ -5587,7 +5976,7 @@
                     </a:lnR>
                     <a:lnT w="9525" cap="flat" cmpd="sng" algn="ctr">
                       <a:solidFill>
-                        <a:srgbClr val="BFD8D8"/>
+                        <a:srgbClr val="D9DCE3"/>
                       </a:solidFill>
                       <a:prstDash val="solid"/>
                       <a:round/>
@@ -5596,7 +5985,7 @@
                     </a:lnT>
                     <a:lnB w="9525" cap="flat" cmpd="sng" algn="ctr">
                       <a:solidFill>
-                        <a:srgbClr val="BFD8D8"/>
+                        <a:srgbClr val="D9DCE3"/>
                       </a:solidFill>
                       <a:prstDash val="solid"/>
                       <a:round/>
@@ -5632,7 +6021,7 @@
                   <a:tcPr marL="109728" marR="109728" marT="54864" marB="54864" anchor="ctr">
                     <a:lnL w="9525" cap="flat" cmpd="sng" algn="ctr">
                       <a:solidFill>
-                        <a:srgbClr val="BFD8D8"/>
+                        <a:srgbClr val="D9DCE3"/>
                       </a:solidFill>
                       <a:prstDash val="solid"/>
                       <a:round/>
@@ -5641,7 +6030,7 @@
                     </a:lnL>
                     <a:lnR w="9525" cap="flat" cmpd="sng" algn="ctr">
                       <a:solidFill>
-                        <a:srgbClr val="BFD8D8"/>
+                        <a:srgbClr val="D9DCE3"/>
                       </a:solidFill>
                       <a:prstDash val="solid"/>
                       <a:round/>
@@ -5650,7 +6039,7 @@
                     </a:lnR>
                     <a:lnT w="9525" cap="flat" cmpd="sng" algn="ctr">
                       <a:solidFill>
-                        <a:srgbClr val="BFD8D8"/>
+                        <a:srgbClr val="D9DCE3"/>
                       </a:solidFill>
                       <a:prstDash val="solid"/>
                       <a:round/>
@@ -5659,7 +6048,7 @@
                     </a:lnT>
                     <a:lnB w="9525" cap="flat" cmpd="sng" algn="ctr">
                       <a:solidFill>
-                        <a:srgbClr val="BFD8D8"/>
+                        <a:srgbClr val="D9DCE3"/>
                       </a:solidFill>
                       <a:prstDash val="solid"/>
                       <a:round/>
@@ -5693,7 +6082,7 @@
                   <a:tcPr marL="109728" marR="109728" marT="54864" marB="54864" anchor="ctr">
                     <a:lnL w="9525" cap="flat" cmpd="sng" algn="ctr">
                       <a:solidFill>
-                        <a:srgbClr val="BFD8D8"/>
+                        <a:srgbClr val="D9DCE3"/>
                       </a:solidFill>
                       <a:prstDash val="solid"/>
                       <a:round/>
@@ -5702,7 +6091,7 @@
                     </a:lnL>
                     <a:lnR w="9525" cap="flat" cmpd="sng" algn="ctr">
                       <a:solidFill>
-                        <a:srgbClr val="BFD8D8"/>
+                        <a:srgbClr val="D9DCE3"/>
                       </a:solidFill>
                       <a:prstDash val="solid"/>
                       <a:round/>
@@ -5711,7 +6100,7 @@
                     </a:lnR>
                     <a:lnT w="9525" cap="flat" cmpd="sng" algn="ctr">
                       <a:solidFill>
-                        <a:srgbClr val="BFD8D8"/>
+                        <a:srgbClr val="D9DCE3"/>
                       </a:solidFill>
                       <a:prstDash val="solid"/>
                       <a:round/>
@@ -5720,7 +6109,7 @@
                     </a:lnT>
                     <a:lnB w="9525" cap="flat" cmpd="sng" algn="ctr">
                       <a:solidFill>
-                        <a:srgbClr val="BFD8D8"/>
+                        <a:srgbClr val="D9DCE3"/>
                       </a:solidFill>
                       <a:prstDash val="solid"/>
                       <a:round/>
@@ -5754,7 +6143,7 @@
                   <a:tcPr marL="109728" marR="109728" marT="54864" marB="54864" anchor="ctr">
                     <a:lnL w="9525" cap="flat" cmpd="sng" algn="ctr">
                       <a:solidFill>
-                        <a:srgbClr val="BFD8D8"/>
+                        <a:srgbClr val="D9DCE3"/>
                       </a:solidFill>
                       <a:prstDash val="solid"/>
                       <a:round/>
@@ -5763,7 +6152,7 @@
                     </a:lnL>
                     <a:lnR w="9525" cap="flat" cmpd="sng" algn="ctr">
                       <a:solidFill>
-                        <a:srgbClr val="BFD8D8"/>
+                        <a:srgbClr val="D9DCE3"/>
                       </a:solidFill>
                       <a:prstDash val="solid"/>
                       <a:round/>
@@ -5772,7 +6161,7 @@
                     </a:lnR>
                     <a:lnT w="9525" cap="flat" cmpd="sng" algn="ctr">
                       <a:solidFill>
-                        <a:srgbClr val="BFD8D8"/>
+                        <a:srgbClr val="D9DCE3"/>
                       </a:solidFill>
                       <a:prstDash val="solid"/>
                       <a:round/>
@@ -5781,7 +6170,7 @@
                     </a:lnT>
                     <a:lnB w="9525" cap="flat" cmpd="sng" algn="ctr">
                       <a:solidFill>
-                        <a:srgbClr val="BFD8D8"/>
+                        <a:srgbClr val="D9DCE3"/>
                       </a:solidFill>
                       <a:prstDash val="solid"/>
                       <a:round/>
@@ -5817,7 +6206,7 @@
                   <a:tcPr marL="109728" marR="109728" marT="54864" marB="54864" anchor="ctr">
                     <a:lnL w="9525" cap="flat" cmpd="sng" algn="ctr">
                       <a:solidFill>
-                        <a:srgbClr val="BFD8D8"/>
+                        <a:srgbClr val="D9DCE3"/>
                       </a:solidFill>
                       <a:prstDash val="solid"/>
                       <a:round/>
@@ -5826,7 +6215,7 @@
                     </a:lnL>
                     <a:lnR w="9525" cap="flat" cmpd="sng" algn="ctr">
                       <a:solidFill>
-                        <a:srgbClr val="BFD8D8"/>
+                        <a:srgbClr val="D9DCE3"/>
                       </a:solidFill>
                       <a:prstDash val="solid"/>
                       <a:round/>
@@ -5835,7 +6224,7 @@
                     </a:lnR>
                     <a:lnT w="9525" cap="flat" cmpd="sng" algn="ctr">
                       <a:solidFill>
-                        <a:srgbClr val="BFD8D8"/>
+                        <a:srgbClr val="D9DCE3"/>
                       </a:solidFill>
                       <a:prstDash val="solid"/>
                       <a:round/>
@@ -5844,7 +6233,7 @@
                     </a:lnT>
                     <a:lnB w="9525" cap="flat" cmpd="sng" algn="ctr">
                       <a:solidFill>
-                        <a:srgbClr val="BFD8D8"/>
+                        <a:srgbClr val="D9DCE3"/>
                       </a:solidFill>
                       <a:prstDash val="solid"/>
                       <a:round/>
@@ -5878,7 +6267,7 @@
                   <a:tcPr marL="109728" marR="109728" marT="54864" marB="54864" anchor="ctr">
                     <a:lnL w="9525" cap="flat" cmpd="sng" algn="ctr">
                       <a:solidFill>
-                        <a:srgbClr val="BFD8D8"/>
+                        <a:srgbClr val="D9DCE3"/>
                       </a:solidFill>
                       <a:prstDash val="solid"/>
                       <a:round/>
@@ -5887,7 +6276,7 @@
                     </a:lnL>
                     <a:lnR w="9525" cap="flat" cmpd="sng" algn="ctr">
                       <a:solidFill>
-                        <a:srgbClr val="BFD8D8"/>
+                        <a:srgbClr val="D9DCE3"/>
                       </a:solidFill>
                       <a:prstDash val="solid"/>
                       <a:round/>
@@ -5896,7 +6285,7 @@
                     </a:lnR>
                     <a:lnT w="9525" cap="flat" cmpd="sng" algn="ctr">
                       <a:solidFill>
-                        <a:srgbClr val="BFD8D8"/>
+                        <a:srgbClr val="D9DCE3"/>
                       </a:solidFill>
                       <a:prstDash val="solid"/>
                       <a:round/>
@@ -5905,7 +6294,7 @@
                     </a:lnT>
                     <a:lnB w="9525" cap="flat" cmpd="sng" algn="ctr">
                       <a:solidFill>
-                        <a:srgbClr val="BFD8D8"/>
+                        <a:srgbClr val="D9DCE3"/>
                       </a:solidFill>
                       <a:prstDash val="solid"/>
                       <a:round/>
@@ -5939,7 +6328,7 @@
                   <a:tcPr marL="109728" marR="109728" marT="54864" marB="54864" anchor="ctr">
                     <a:lnL w="9525" cap="flat" cmpd="sng" algn="ctr">
                       <a:solidFill>
-                        <a:srgbClr val="BFD8D8"/>
+                        <a:srgbClr val="D9DCE3"/>
                       </a:solidFill>
                       <a:prstDash val="solid"/>
                       <a:round/>
@@ -5948,7 +6337,7 @@
                     </a:lnL>
                     <a:lnR w="9525" cap="flat" cmpd="sng" algn="ctr">
                       <a:solidFill>
-                        <a:srgbClr val="BFD8D8"/>
+                        <a:srgbClr val="D9DCE3"/>
                       </a:solidFill>
                       <a:prstDash val="solid"/>
                       <a:round/>
@@ -5957,7 +6346,7 @@
                     </a:lnR>
                     <a:lnT w="9525" cap="flat" cmpd="sng" algn="ctr">
                       <a:solidFill>
-                        <a:srgbClr val="BFD8D8"/>
+                        <a:srgbClr val="D9DCE3"/>
                       </a:solidFill>
                       <a:prstDash val="solid"/>
                       <a:round/>
@@ -5966,7 +6355,7 @@
                     </a:lnT>
                     <a:lnB w="9525" cap="flat" cmpd="sng" algn="ctr">
                       <a:solidFill>
-                        <a:srgbClr val="BFD8D8"/>
+                        <a:srgbClr val="D9DCE3"/>
                       </a:solidFill>
                       <a:prstDash val="solid"/>
                       <a:round/>
@@ -6002,7 +6391,7 @@
                   <a:tcPr marL="109728" marR="109728" marT="54864" marB="54864" anchor="ctr">
                     <a:lnL w="9525" cap="flat" cmpd="sng" algn="ctr">
                       <a:solidFill>
-                        <a:srgbClr val="BFD8D8"/>
+                        <a:srgbClr val="D9DCE3"/>
                       </a:solidFill>
                       <a:prstDash val="solid"/>
                       <a:round/>
@@ -6011,7 +6400,7 @@
                     </a:lnL>
                     <a:lnR w="9525" cap="flat" cmpd="sng" algn="ctr">
                       <a:solidFill>
-                        <a:srgbClr val="BFD8D8"/>
+                        <a:srgbClr val="D9DCE3"/>
                       </a:solidFill>
                       <a:prstDash val="solid"/>
                       <a:round/>
@@ -6020,7 +6409,7 @@
                     </a:lnR>
                     <a:lnT w="9525" cap="flat" cmpd="sng" algn="ctr">
                       <a:solidFill>
-                        <a:srgbClr val="BFD8D8"/>
+                        <a:srgbClr val="D9DCE3"/>
                       </a:solidFill>
                       <a:prstDash val="solid"/>
                       <a:round/>
@@ -6029,7 +6418,7 @@
                     </a:lnT>
                     <a:lnB w="9525" cap="flat" cmpd="sng" algn="ctr">
                       <a:solidFill>
-                        <a:srgbClr val="BFD8D8"/>
+                        <a:srgbClr val="D9DCE3"/>
                       </a:solidFill>
                       <a:prstDash val="solid"/>
                       <a:round/>
@@ -6063,7 +6452,7 @@
                   <a:tcPr marL="109728" marR="109728" marT="54864" marB="54864" anchor="ctr">
                     <a:lnL w="9525" cap="flat" cmpd="sng" algn="ctr">
                       <a:solidFill>
-                        <a:srgbClr val="BFD8D8"/>
+                        <a:srgbClr val="D9DCE3"/>
                       </a:solidFill>
                       <a:prstDash val="solid"/>
                       <a:round/>
@@ -6072,7 +6461,7 @@
                     </a:lnL>
                     <a:lnR w="9525" cap="flat" cmpd="sng" algn="ctr">
                       <a:solidFill>
-                        <a:srgbClr val="BFD8D8"/>
+                        <a:srgbClr val="D9DCE3"/>
                       </a:solidFill>
                       <a:prstDash val="solid"/>
                       <a:round/>
@@ -6081,7 +6470,7 @@
                     </a:lnR>
                     <a:lnT w="9525" cap="flat" cmpd="sng" algn="ctr">
                       <a:solidFill>
-                        <a:srgbClr val="BFD8D8"/>
+                        <a:srgbClr val="D9DCE3"/>
                       </a:solidFill>
                       <a:prstDash val="solid"/>
                       <a:round/>
@@ -6090,7 +6479,7 @@
                     </a:lnT>
                     <a:lnB w="9525" cap="flat" cmpd="sng" algn="ctr">
                       <a:solidFill>
-                        <a:srgbClr val="BFD8D8"/>
+                        <a:srgbClr val="D9DCE3"/>
                       </a:solidFill>
                       <a:prstDash val="solid"/>
                       <a:round/>
@@ -6124,7 +6513,7 @@
                   <a:tcPr marL="109728" marR="109728" marT="54864" marB="54864" anchor="ctr">
                     <a:lnL w="9525" cap="flat" cmpd="sng" algn="ctr">
                       <a:solidFill>
-                        <a:srgbClr val="BFD8D8"/>
+                        <a:srgbClr val="D9DCE3"/>
                       </a:solidFill>
                       <a:prstDash val="solid"/>
                       <a:round/>
@@ -6133,7 +6522,7 @@
                     </a:lnL>
                     <a:lnR w="9525" cap="flat" cmpd="sng" algn="ctr">
                       <a:solidFill>
-                        <a:srgbClr val="BFD8D8"/>
+                        <a:srgbClr val="D9DCE3"/>
                       </a:solidFill>
                       <a:prstDash val="solid"/>
                       <a:round/>
@@ -6142,7 +6531,7 @@
                     </a:lnR>
                     <a:lnT w="9525" cap="flat" cmpd="sng" algn="ctr">
                       <a:solidFill>
-                        <a:srgbClr val="BFD8D8"/>
+                        <a:srgbClr val="D9DCE3"/>
                       </a:solidFill>
                       <a:prstDash val="solid"/>
                       <a:round/>
@@ -6151,7 +6540,7 @@
                     </a:lnT>
                     <a:lnB w="9525" cap="flat" cmpd="sng" algn="ctr">
                       <a:solidFill>
-                        <a:srgbClr val="BFD8D8"/>
+                        <a:srgbClr val="D9DCE3"/>
                       </a:solidFill>
                       <a:prstDash val="solid"/>
                       <a:round/>
@@ -6187,7 +6576,7 @@
                   <a:tcPr marL="109728" marR="109728" marT="54864" marB="54864" anchor="ctr">
                     <a:lnL w="9525" cap="flat" cmpd="sng" algn="ctr">
                       <a:solidFill>
-                        <a:srgbClr val="BFD8D8"/>
+                        <a:srgbClr val="D9DCE3"/>
                       </a:solidFill>
                       <a:prstDash val="solid"/>
                       <a:round/>
@@ -6196,7 +6585,7 @@
                     </a:lnL>
                     <a:lnR w="9525" cap="flat" cmpd="sng" algn="ctr">
                       <a:solidFill>
-                        <a:srgbClr val="BFD8D8"/>
+                        <a:srgbClr val="D9DCE3"/>
                       </a:solidFill>
                       <a:prstDash val="solid"/>
                       <a:round/>
@@ -6205,7 +6594,7 @@
                     </a:lnR>
                     <a:lnT w="9525" cap="flat" cmpd="sng" algn="ctr">
                       <a:solidFill>
-                        <a:srgbClr val="BFD8D8"/>
+                        <a:srgbClr val="D9DCE3"/>
                       </a:solidFill>
                       <a:prstDash val="solid"/>
                       <a:round/>
@@ -6214,7 +6603,7 @@
                     </a:lnT>
                     <a:lnB w="9525" cap="flat" cmpd="sng" algn="ctr">
                       <a:solidFill>
-                        <a:srgbClr val="BFD8D8"/>
+                        <a:srgbClr val="D9DCE3"/>
                       </a:solidFill>
                       <a:prstDash val="solid"/>
                       <a:round/>
@@ -6248,7 +6637,7 @@
                   <a:tcPr marL="109728" marR="109728" marT="54864" marB="54864" anchor="ctr">
                     <a:lnL w="9525" cap="flat" cmpd="sng" algn="ctr">
                       <a:solidFill>
-                        <a:srgbClr val="BFD8D8"/>
+                        <a:srgbClr val="D9DCE3"/>
                       </a:solidFill>
                       <a:prstDash val="solid"/>
                       <a:round/>
@@ -6257,7 +6646,7 @@
                     </a:lnL>
                     <a:lnR w="9525" cap="flat" cmpd="sng" algn="ctr">
                       <a:solidFill>
-                        <a:srgbClr val="BFD8D8"/>
+                        <a:srgbClr val="D9DCE3"/>
                       </a:solidFill>
                       <a:prstDash val="solid"/>
                       <a:round/>
@@ -6266,7 +6655,7 @@
                     </a:lnR>
                     <a:lnT w="9525" cap="flat" cmpd="sng" algn="ctr">
                       <a:solidFill>
-                        <a:srgbClr val="BFD8D8"/>
+                        <a:srgbClr val="D9DCE3"/>
                       </a:solidFill>
                       <a:prstDash val="solid"/>
                       <a:round/>
@@ -6275,7 +6664,7 @@
                     </a:lnT>
                     <a:lnB w="9525" cap="flat" cmpd="sng" algn="ctr">
                       <a:solidFill>
-                        <a:srgbClr val="BFD8D8"/>
+                        <a:srgbClr val="D9DCE3"/>
                       </a:solidFill>
                       <a:prstDash val="solid"/>
                       <a:round/>
@@ -6309,7 +6698,7 @@
                   <a:tcPr marL="109728" marR="109728" marT="54864" marB="54864" anchor="ctr">
                     <a:lnL w="9525" cap="flat" cmpd="sng" algn="ctr">
                       <a:solidFill>
-                        <a:srgbClr val="BFD8D8"/>
+                        <a:srgbClr val="D9DCE3"/>
                       </a:solidFill>
                       <a:prstDash val="solid"/>
                       <a:round/>
@@ -6318,7 +6707,7 @@
                     </a:lnL>
                     <a:lnR w="9525" cap="flat" cmpd="sng" algn="ctr">
                       <a:solidFill>
-                        <a:srgbClr val="BFD8D8"/>
+                        <a:srgbClr val="D9DCE3"/>
                       </a:solidFill>
                       <a:prstDash val="solid"/>
                       <a:round/>
@@ -6327,7 +6716,7 @@
                     </a:lnR>
                     <a:lnT w="9525" cap="flat" cmpd="sng" algn="ctr">
                       <a:solidFill>
-                        <a:srgbClr val="BFD8D8"/>
+                        <a:srgbClr val="D9DCE3"/>
                       </a:solidFill>
                       <a:prstDash val="solid"/>
                       <a:round/>
@@ -6336,7 +6725,7 @@
                     </a:lnT>
                     <a:lnB w="9525" cap="flat" cmpd="sng" algn="ctr">
                       <a:solidFill>
-                        <a:srgbClr val="BFD8D8"/>
+                        <a:srgbClr val="D9DCE3"/>
                       </a:solidFill>
                       <a:prstDash val="solid"/>
                       <a:round/>
@@ -6355,7 +6744,7 @@
       </p:graphicFrame>
       <p:sp>
         <p:nvSpPr>
-          <p:cNvPr id="4" name="Chip 1"/>
+          <p:cNvPr id="6" name="Chip 1"/>
           <p:cNvSpPr/>
           <p:nvPr/>
         </p:nvSpPr>
@@ -6364,7 +6753,7 @@
             <a:off x="548640" y="4709160"/>
             <a:ext cx="3447288" cy="1234440"/>
           </a:xfrm>
-          <a:prstGeom prst="roundRect">
+          <a:prstGeom prst="rect">
             <a:avLst>
               <a:gd name="adj" fmla="val 8889"/>
             </a:avLst>
@@ -6382,7 +6771,7 @@
       </p:sp>
       <p:sp>
         <p:nvSpPr>
-          <p:cNvPr id="5" name="Chip icon 1 circle"/>
+          <p:cNvPr id="7" name="Chip icon 1 circle"/>
           <p:cNvSpPr/>
           <p:nvPr/>
         </p:nvSpPr>
@@ -6391,7 +6780,7 @@
             <a:off x="777240" y="5001768"/>
             <a:ext cx="640080" cy="640080"/>
           </a:xfrm>
-          <a:prstGeom prst="ellipse">
+          <a:prstGeom prst="rect">
             <a:avLst/>
           </a:prstGeom>
           <a:solidFill>
@@ -6407,7 +6796,7 @@
       </p:sp>
       <p:pic>
         <p:nvPicPr>
-          <p:cNvPr id="6" name="Chip icon 1 icon" descr="Chip icon 1">    </p:cNvPr>
+          <p:cNvPr id="8" name="Chip icon 1 icon" descr="Chip icon 1">    </p:cNvPr>
           <p:cNvPicPr>
             <a:picLocks noChangeAspect="1"/>
           </p:cNvPicPr>
@@ -6431,7 +6820,7 @@
       </p:pic>
       <p:sp>
         <p:nvSpPr>
-          <p:cNvPr id="7" name="Chip text 1"/>
+          <p:cNvPr id="9" name="Chip text 1"/>
           <p:cNvSpPr txBox="1"/>
           <p:nvPr/>
         </p:nvSpPr>
@@ -6481,7 +6870,7 @@
       </p:sp>
       <p:sp>
         <p:nvSpPr>
-          <p:cNvPr id="8" name="Chip 2"/>
+          <p:cNvPr id="10" name="Chip 2"/>
           <p:cNvSpPr/>
           <p:nvPr/>
         </p:nvSpPr>
@@ -6490,7 +6879,7 @@
             <a:off x="4370832" y="4709160"/>
             <a:ext cx="3447288" cy="1234440"/>
           </a:xfrm>
-          <a:prstGeom prst="roundRect">
+          <a:prstGeom prst="rect">
             <a:avLst>
               <a:gd name="adj" fmla="val 8889"/>
             </a:avLst>
@@ -6508,7 +6897,7 @@
       </p:sp>
       <p:sp>
         <p:nvSpPr>
-          <p:cNvPr id="9" name="Chip icon 2 circle"/>
+          <p:cNvPr id="11" name="Chip icon 2 circle"/>
           <p:cNvSpPr/>
           <p:nvPr/>
         </p:nvSpPr>
@@ -6517,7 +6906,7 @@
             <a:off x="4599432" y="5001768"/>
             <a:ext cx="640080" cy="640080"/>
           </a:xfrm>
-          <a:prstGeom prst="ellipse">
+          <a:prstGeom prst="rect">
             <a:avLst/>
           </a:prstGeom>
           <a:solidFill>
@@ -6533,7 +6922,7 @@
       </p:sp>
       <p:pic>
         <p:nvPicPr>
-          <p:cNvPr id="10" name="Chip icon 2 icon" descr="Chip icon 2">    </p:cNvPr>
+          <p:cNvPr id="12" name="Chip icon 2 icon" descr="Chip icon 2">    </p:cNvPr>
           <p:cNvPicPr>
             <a:picLocks noChangeAspect="1"/>
           </p:cNvPicPr>
@@ -6557,7 +6946,7 @@
       </p:pic>
       <p:sp>
         <p:nvSpPr>
-          <p:cNvPr id="11" name="Chip text 2"/>
+          <p:cNvPr id="13" name="Chip text 2"/>
           <p:cNvSpPr txBox="1"/>
           <p:nvPr/>
         </p:nvSpPr>
@@ -6607,7 +6996,7 @@
       </p:sp>
       <p:sp>
         <p:nvSpPr>
-          <p:cNvPr id="12" name="Chip 3"/>
+          <p:cNvPr id="14" name="Chip 3"/>
           <p:cNvSpPr/>
           <p:nvPr/>
         </p:nvSpPr>
@@ -6616,7 +7005,7 @@
             <a:off x="8193024" y="4709160"/>
             <a:ext cx="3447288" cy="1234440"/>
           </a:xfrm>
-          <a:prstGeom prst="roundRect">
+          <a:prstGeom prst="rect">
             <a:avLst>
               <a:gd name="adj" fmla="val 8889"/>
             </a:avLst>
@@ -6634,7 +7023,7 @@
       </p:sp>
       <p:sp>
         <p:nvSpPr>
-          <p:cNvPr id="13" name="Chip icon 3 circle"/>
+          <p:cNvPr id="15" name="Chip icon 3 circle"/>
           <p:cNvSpPr/>
           <p:nvPr/>
         </p:nvSpPr>
@@ -6643,7 +7032,7 @@
             <a:off x="8421624" y="5001768"/>
             <a:ext cx="640080" cy="640080"/>
           </a:xfrm>
-          <a:prstGeom prst="ellipse">
+          <a:prstGeom prst="rect">
             <a:avLst/>
           </a:prstGeom>
           <a:solidFill>
@@ -6659,7 +7048,7 @@
       </p:sp>
       <p:pic>
         <p:nvPicPr>
-          <p:cNvPr id="14" name="Chip icon 3 icon" descr="Chip icon 3">    </p:cNvPr>
+          <p:cNvPr id="16" name="Chip icon 3 icon" descr="Chip icon 3">    </p:cNvPr>
           <p:cNvPicPr>
             <a:picLocks noChangeAspect="1"/>
           </p:cNvPicPr>
@@ -6683,7 +7072,7 @@
       </p:pic>
       <p:sp>
         <p:nvSpPr>
-          <p:cNvPr id="15" name="Chip text 3"/>
+          <p:cNvPr id="17" name="Chip text 3"/>
           <p:cNvSpPr txBox="1"/>
           <p:nvPr/>
         </p:nvSpPr>
@@ -6811,8 +7200,8 @@
         </p:nvSpPr>
         <p:spPr>
           <a:xfrm>
-            <a:off x="548640" y="320040"/>
-            <a:ext cx="11091672" cy="777240"/>
+            <a:off x="1417320" y="320040"/>
+            <a:ext cx="10222992" cy="777240"/>
           </a:xfrm>
           <a:prstGeom prst="rect">
             <a:avLst/>
@@ -6832,9 +7221,9 @@
                 <a:solidFill>
                   <a:schemeClr val="tx2"/>
                 </a:solidFill>
-                <a:latin typeface="Cambria" pitchFamily="34" charset="0"/>
-                <a:ea typeface="Cambria" pitchFamily="34" charset="-122"/>
-                <a:cs typeface="Cambria" pitchFamily="34" charset="-120"/>
+                <a:latin typeface="Arial" pitchFamily="34" charset="0"/>
+                <a:ea typeface="Arial" pitchFamily="34" charset="-122"/>
+                <a:cs typeface="Arial" pitchFamily="34" charset="-120"/>
               </a:rPr>
               <a:t>ETL: Lấy – Làm sạch – Lưu</a:t>
             </a:r>
@@ -6844,7 +7233,71 @@
       </p:sp>
       <p:sp>
         <p:nvSpPr>
-          <p:cNvPr id="3" name="Flow box 1"/>
+          <p:cNvPr id="3" name="Slide tag"/>
+          <p:cNvSpPr/>
+          <p:nvPr/>
+        </p:nvSpPr>
+        <p:spPr>
+          <a:xfrm>
+            <a:off x="548640" y="457200"/>
+            <a:ext cx="685800" cy="502920"/>
+          </a:xfrm>
+          <a:prstGeom prst="rect">
+            <a:avLst/>
+          </a:prstGeom>
+          <a:solidFill>
+            <a:schemeClr val="accent2"/>
+          </a:solidFill>
+          <a:ln w="12700">
+            <a:solidFill>
+              <a:schemeClr val="accent2"/>
+            </a:solidFill>
+            <a:prstDash val="solid"/>
+          </a:ln>
+        </p:spPr>
+      </p:sp>
+      <p:sp>
+        <p:nvSpPr>
+          <p:cNvPr id="4" name="Slide tag number"/>
+          <p:cNvSpPr txBox="1"/>
+          <p:nvPr/>
+        </p:nvSpPr>
+        <p:spPr>
+          <a:xfrm>
+            <a:off x="548640" y="457200"/>
+            <a:ext cx="685800" cy="502920"/>
+          </a:xfrm>
+          <a:prstGeom prst="rect">
+            <a:avLst/>
+          </a:prstGeom>
+          <a:noFill/>
+          <a:ln/>
+        </p:spPr>
+        <p:txBody>
+          <a:bodyPr wrap="square" lIns="0" tIns="0" rIns="0" bIns="0" rtlCol="0" anchor="ctr"/>
+          <a:lstStyle/>
+          <a:p>
+            <a:pPr algn="ctr" indent="0" marL="0">
+              <a:buNone/>
+            </a:pPr>
+            <a:r>
+              <a:rPr lang="en-US" sz="2000" b="1" dirty="0">
+                <a:solidFill>
+                  <a:schemeClr val="tx2"/>
+                </a:solidFill>
+                <a:latin typeface="Arial" pitchFamily="34" charset="0"/>
+                <a:ea typeface="Arial" pitchFamily="34" charset="-122"/>
+                <a:cs typeface="Arial" pitchFamily="34" charset="-120"/>
+              </a:rPr>
+              <a:t>05</a:t>
+            </a:r>
+            <a:endParaRPr lang="en-US" sz="2000" dirty="0"/>
+          </a:p>
+        </p:txBody>
+      </p:sp>
+      <p:sp>
+        <p:nvSpPr>
+          <p:cNvPr id="5" name="Flow box 1"/>
           <p:cNvSpPr/>
           <p:nvPr/>
         </p:nvSpPr>
@@ -6853,7 +7306,7 @@
             <a:off x="548640" y="1371600"/>
             <a:ext cx="3291840" cy="2468880"/>
           </a:xfrm>
-          <a:prstGeom prst="roundRect">
+          <a:prstGeom prst="rect">
             <a:avLst>
               <a:gd name="adj" fmla="val 4444"/>
             </a:avLst>
@@ -6871,7 +7324,7 @@
       </p:sp>
       <p:sp>
         <p:nvSpPr>
-          <p:cNvPr id="4" name="Flow icon 1 circle"/>
+          <p:cNvPr id="6" name="Flow icon 1 circle"/>
           <p:cNvSpPr/>
           <p:nvPr/>
         </p:nvSpPr>
@@ -6880,7 +7333,7 @@
             <a:off x="822960" y="1600200"/>
             <a:ext cx="777240" cy="777240"/>
           </a:xfrm>
-          <a:prstGeom prst="ellipse">
+          <a:prstGeom prst="rect">
             <a:avLst/>
           </a:prstGeom>
           <a:solidFill>
@@ -6896,7 +7349,7 @@
       </p:sp>
       <p:pic>
         <p:nvPicPr>
-          <p:cNvPr id="5" name="Flow icon 1 icon" descr="Flow icon 1">    </p:cNvPr>
+          <p:cNvPr id="7" name="Flow icon 1 icon" descr="Flow icon 1">    </p:cNvPr>
           <p:cNvPicPr>
             <a:picLocks noChangeAspect="1"/>
           </p:cNvPicPr>
@@ -6920,7 +7373,7 @@
       </p:pic>
       <p:sp>
         <p:nvSpPr>
-          <p:cNvPr id="6" name="Flow title 1"/>
+          <p:cNvPr id="8" name="Flow title 1"/>
           <p:cNvSpPr txBox="1"/>
           <p:nvPr/>
         </p:nvSpPr>
@@ -6970,7 +7423,7 @@
       </p:sp>
       <p:sp>
         <p:nvSpPr>
-          <p:cNvPr id="7" name="Flow desc 1"/>
+          <p:cNvPr id="9" name="Flow desc 1"/>
           <p:cNvSpPr txBox="1"/>
           <p:nvPr/>
         </p:nvSpPr>
@@ -7006,7 +7459,7 @@
       </p:sp>
       <p:sp>
         <p:nvSpPr>
-          <p:cNvPr id="8" name="Flow arrow 1"/>
+          <p:cNvPr id="10" name="Flow arrow 1"/>
           <p:cNvSpPr/>
           <p:nvPr/>
         </p:nvSpPr>
@@ -7031,7 +7484,7 @@
       </p:sp>
       <p:sp>
         <p:nvSpPr>
-          <p:cNvPr id="9" name="Flow box 2"/>
+          <p:cNvPr id="11" name="Flow box 2"/>
           <p:cNvSpPr/>
           <p:nvPr/>
         </p:nvSpPr>
@@ -7040,7 +7493,7 @@
             <a:off x="4448556" y="1371600"/>
             <a:ext cx="3291840" cy="2468880"/>
           </a:xfrm>
-          <a:prstGeom prst="roundRect">
+          <a:prstGeom prst="rect">
             <a:avLst>
               <a:gd name="adj" fmla="val 4444"/>
             </a:avLst>
@@ -7058,7 +7511,7 @@
       </p:sp>
       <p:sp>
         <p:nvSpPr>
-          <p:cNvPr id="10" name="Flow icon 2 circle"/>
+          <p:cNvPr id="12" name="Flow icon 2 circle"/>
           <p:cNvSpPr/>
           <p:nvPr/>
         </p:nvSpPr>
@@ -7067,7 +7520,7 @@
             <a:off x="4722876" y="1600200"/>
             <a:ext cx="777240" cy="777240"/>
           </a:xfrm>
-          <a:prstGeom prst="ellipse">
+          <a:prstGeom prst="rect">
             <a:avLst/>
           </a:prstGeom>
           <a:solidFill>
@@ -7083,7 +7536,7 @@
       </p:sp>
       <p:pic>
         <p:nvPicPr>
-          <p:cNvPr id="11" name="Flow icon 2 icon" descr="Flow icon 2">    </p:cNvPr>
+          <p:cNvPr id="13" name="Flow icon 2 icon" descr="Flow icon 2">    </p:cNvPr>
           <p:cNvPicPr>
             <a:picLocks noChangeAspect="1"/>
           </p:cNvPicPr>
@@ -7107,7 +7560,7 @@
       </p:pic>
       <p:sp>
         <p:nvSpPr>
-          <p:cNvPr id="12" name="Flow title 2"/>
+          <p:cNvPr id="14" name="Flow title 2"/>
           <p:cNvSpPr txBox="1"/>
           <p:nvPr/>
         </p:nvSpPr>
@@ -7157,7 +7610,7 @@
       </p:sp>
       <p:sp>
         <p:nvSpPr>
-          <p:cNvPr id="13" name="Flow desc 2"/>
+          <p:cNvPr id="15" name="Flow desc 2"/>
           <p:cNvSpPr txBox="1"/>
           <p:nvPr/>
         </p:nvSpPr>
@@ -7193,7 +7646,7 @@
       </p:sp>
       <p:sp>
         <p:nvSpPr>
-          <p:cNvPr id="14" name="Flow arrow 2"/>
+          <p:cNvPr id="16" name="Flow arrow 2"/>
           <p:cNvSpPr/>
           <p:nvPr/>
         </p:nvSpPr>
@@ -7218,7 +7671,7 @@
       </p:sp>
       <p:sp>
         <p:nvSpPr>
-          <p:cNvPr id="15" name="Flow box 3"/>
+          <p:cNvPr id="17" name="Flow box 3"/>
           <p:cNvSpPr/>
           <p:nvPr/>
         </p:nvSpPr>
@@ -7227,7 +7680,7 @@
             <a:off x="8348472" y="1371600"/>
             <a:ext cx="3291840" cy="2468880"/>
           </a:xfrm>
-          <a:prstGeom prst="roundRect">
+          <a:prstGeom prst="rect">
             <a:avLst>
               <a:gd name="adj" fmla="val 4444"/>
             </a:avLst>
@@ -7245,7 +7698,7 @@
       </p:sp>
       <p:sp>
         <p:nvSpPr>
-          <p:cNvPr id="16" name="Flow icon 3 circle"/>
+          <p:cNvPr id="18" name="Flow icon 3 circle"/>
           <p:cNvSpPr/>
           <p:nvPr/>
         </p:nvSpPr>
@@ -7254,7 +7707,7 @@
             <a:off x="8622792" y="1600200"/>
             <a:ext cx="777240" cy="777240"/>
           </a:xfrm>
-          <a:prstGeom prst="ellipse">
+          <a:prstGeom prst="rect">
             <a:avLst/>
           </a:prstGeom>
           <a:solidFill>
@@ -7270,7 +7723,7 @@
       </p:sp>
       <p:pic>
         <p:nvPicPr>
-          <p:cNvPr id="17" name="Flow icon 3 icon" descr="Flow icon 3">    </p:cNvPr>
+          <p:cNvPr id="19" name="Flow icon 3 icon" descr="Flow icon 3">    </p:cNvPr>
           <p:cNvPicPr>
             <a:picLocks noChangeAspect="1"/>
           </p:cNvPicPr>
@@ -7294,7 +7747,7 @@
       </p:pic>
       <p:sp>
         <p:nvSpPr>
-          <p:cNvPr id="18" name="Flow title 3"/>
+          <p:cNvPr id="20" name="Flow title 3"/>
           <p:cNvSpPr txBox="1"/>
           <p:nvPr/>
         </p:nvSpPr>
@@ -7344,7 +7797,7 @@
       </p:sp>
       <p:sp>
         <p:nvSpPr>
-          <p:cNvPr id="19" name="Flow desc 3"/>
+          <p:cNvPr id="21" name="Flow desc 3"/>
           <p:cNvSpPr txBox="1"/>
           <p:nvPr/>
         </p:nvSpPr>
@@ -7380,7 +7833,7 @@
       </p:sp>
       <p:sp>
         <p:nvSpPr>
-          <p:cNvPr id="20" name="ETL note card 1"/>
+          <p:cNvPr id="22" name="ETL note card 1"/>
           <p:cNvSpPr/>
           <p:nvPr/>
         </p:nvSpPr>
@@ -7389,7 +7842,7 @@
             <a:off x="548640" y="4206240"/>
             <a:ext cx="3447288" cy="1554480"/>
           </a:xfrm>
-          <a:prstGeom prst="roundRect">
+          <a:prstGeom prst="rect">
             <a:avLst>
               <a:gd name="adj" fmla="val 7059"/>
             </a:avLst>
@@ -7407,7 +7860,7 @@
       </p:sp>
       <p:sp>
         <p:nvSpPr>
-          <p:cNvPr id="21" name="ETL note 1 circle"/>
+          <p:cNvPr id="23" name="ETL note 1 circle"/>
           <p:cNvSpPr/>
           <p:nvPr/>
         </p:nvSpPr>
@@ -7416,7 +7869,7 @@
             <a:off x="777240" y="4686300"/>
             <a:ext cx="594360" cy="594360"/>
           </a:xfrm>
-          <a:prstGeom prst="ellipse">
+          <a:prstGeom prst="rect">
             <a:avLst/>
           </a:prstGeom>
           <a:solidFill>
@@ -7432,7 +7885,7 @@
       </p:sp>
       <p:pic>
         <p:nvPicPr>
-          <p:cNvPr id="22" name="ETL note 1 icon" descr="ETL note 1">    </p:cNvPr>
+          <p:cNvPr id="24" name="ETL note 1 icon" descr="ETL note 1">    </p:cNvPr>
           <p:cNvPicPr>
             <a:picLocks noChangeAspect="1"/>
           </p:cNvPicPr>
@@ -7456,7 +7909,7 @@
       </p:pic>
       <p:sp>
         <p:nvSpPr>
-          <p:cNvPr id="23" name="ETL note text 1"/>
+          <p:cNvPr id="25" name="ETL note text 1"/>
           <p:cNvSpPr txBox="1"/>
           <p:nvPr/>
         </p:nvSpPr>
@@ -7512,7 +7965,7 @@
       </p:sp>
       <p:sp>
         <p:nvSpPr>
-          <p:cNvPr id="24" name="ETL note card 2"/>
+          <p:cNvPr id="26" name="ETL note card 2"/>
           <p:cNvSpPr/>
           <p:nvPr/>
         </p:nvSpPr>
@@ -7521,7 +7974,7 @@
             <a:off x="4370832" y="4206240"/>
             <a:ext cx="3447288" cy="1554480"/>
           </a:xfrm>
-          <a:prstGeom prst="roundRect">
+          <a:prstGeom prst="rect">
             <a:avLst>
               <a:gd name="adj" fmla="val 7059"/>
             </a:avLst>
@@ -7539,7 +7992,7 @@
       </p:sp>
       <p:sp>
         <p:nvSpPr>
-          <p:cNvPr id="25" name="ETL note 2 circle"/>
+          <p:cNvPr id="27" name="ETL note 2 circle"/>
           <p:cNvSpPr/>
           <p:nvPr/>
         </p:nvSpPr>
@@ -7548,7 +8001,7 @@
             <a:off x="4599432" y="4686300"/>
             <a:ext cx="594360" cy="594360"/>
           </a:xfrm>
-          <a:prstGeom prst="ellipse">
+          <a:prstGeom prst="rect">
             <a:avLst/>
           </a:prstGeom>
           <a:solidFill>
@@ -7564,7 +8017,7 @@
       </p:sp>
       <p:pic>
         <p:nvPicPr>
-          <p:cNvPr id="26" name="ETL note 2 icon" descr="ETL note 2">    </p:cNvPr>
+          <p:cNvPr id="28" name="ETL note 2 icon" descr="ETL note 2">    </p:cNvPr>
           <p:cNvPicPr>
             <a:picLocks noChangeAspect="1"/>
           </p:cNvPicPr>
@@ -7588,7 +8041,7 @@
       </p:pic>
       <p:sp>
         <p:nvSpPr>
-          <p:cNvPr id="27" name="ETL note text 2"/>
+          <p:cNvPr id="29" name="ETL note text 2"/>
           <p:cNvSpPr txBox="1"/>
           <p:nvPr/>
         </p:nvSpPr>
@@ -7644,7 +8097,7 @@
       </p:sp>
       <p:sp>
         <p:nvSpPr>
-          <p:cNvPr id="28" name="ETL note card 3"/>
+          <p:cNvPr id="30" name="ETL note card 3"/>
           <p:cNvSpPr/>
           <p:nvPr/>
         </p:nvSpPr>
@@ -7653,7 +8106,7 @@
             <a:off x="8193024" y="4206240"/>
             <a:ext cx="3447288" cy="1554480"/>
           </a:xfrm>
-          <a:prstGeom prst="roundRect">
+          <a:prstGeom prst="rect">
             <a:avLst>
               <a:gd name="adj" fmla="val 7059"/>
             </a:avLst>
@@ -7671,7 +8124,7 @@
       </p:sp>
       <p:sp>
         <p:nvSpPr>
-          <p:cNvPr id="29" name="ETL note 3 circle"/>
+          <p:cNvPr id="31" name="ETL note 3 circle"/>
           <p:cNvSpPr/>
           <p:nvPr/>
         </p:nvSpPr>
@@ -7680,7 +8133,7 @@
             <a:off x="8421624" y="4686300"/>
             <a:ext cx="594360" cy="594360"/>
           </a:xfrm>
-          <a:prstGeom prst="ellipse">
+          <a:prstGeom prst="rect">
             <a:avLst/>
           </a:prstGeom>
           <a:solidFill>
@@ -7696,7 +8149,7 @@
       </p:sp>
       <p:pic>
         <p:nvPicPr>
-          <p:cNvPr id="30" name="ETL note 3 icon" descr="ETL note 3">    </p:cNvPr>
+          <p:cNvPr id="32" name="ETL note 3 icon" descr="ETL note 3">    </p:cNvPr>
           <p:cNvPicPr>
             <a:picLocks noChangeAspect="1"/>
           </p:cNvPicPr>
@@ -7720,7 +8173,7 @@
       </p:pic>
       <p:sp>
         <p:nvSpPr>
-          <p:cNvPr id="31" name="ETL note text 3"/>
+          <p:cNvPr id="33" name="ETL note text 3"/>
           <p:cNvSpPr txBox="1"/>
           <p:nvPr/>
         </p:nvSpPr>
@@ -7854,8 +8307,8 @@
         </p:nvSpPr>
         <p:spPr>
           <a:xfrm>
-            <a:off x="548640" y="320040"/>
-            <a:ext cx="11091672" cy="777240"/>
+            <a:off x="1417320" y="320040"/>
+            <a:ext cx="10222992" cy="777240"/>
           </a:xfrm>
           <a:prstGeom prst="rect">
             <a:avLst/>
@@ -7875,9 +8328,9 @@
                 <a:solidFill>
                   <a:schemeClr val="tx2"/>
                 </a:solidFill>
-                <a:latin typeface="Cambria" pitchFamily="34" charset="0"/>
-                <a:ea typeface="Cambria" pitchFamily="34" charset="-122"/>
-                <a:cs typeface="Cambria" pitchFamily="34" charset="-120"/>
+                <a:latin typeface="Arial" pitchFamily="34" charset="0"/>
+                <a:ea typeface="Arial" pitchFamily="34" charset="-122"/>
+                <a:cs typeface="Arial" pitchFamily="34" charset="-120"/>
               </a:rPr>
               <a:t>Làm sạch dữ liệu (Transform)</a:t>
             </a:r>
@@ -7887,7 +8340,71 @@
       </p:sp>
       <p:sp>
         <p:nvSpPr>
-          <p:cNvPr id="3" name="Transform bullets"/>
+          <p:cNvPr id="3" name="Slide tag"/>
+          <p:cNvSpPr/>
+          <p:nvPr/>
+        </p:nvSpPr>
+        <p:spPr>
+          <a:xfrm>
+            <a:off x="548640" y="457200"/>
+            <a:ext cx="685800" cy="502920"/>
+          </a:xfrm>
+          <a:prstGeom prst="rect">
+            <a:avLst/>
+          </a:prstGeom>
+          <a:solidFill>
+            <a:schemeClr val="accent2"/>
+          </a:solidFill>
+          <a:ln w="12700">
+            <a:solidFill>
+              <a:schemeClr val="accent2"/>
+            </a:solidFill>
+            <a:prstDash val="solid"/>
+          </a:ln>
+        </p:spPr>
+      </p:sp>
+      <p:sp>
+        <p:nvSpPr>
+          <p:cNvPr id="4" name="Slide tag number"/>
+          <p:cNvSpPr txBox="1"/>
+          <p:nvPr/>
+        </p:nvSpPr>
+        <p:spPr>
+          <a:xfrm>
+            <a:off x="548640" y="457200"/>
+            <a:ext cx="685800" cy="502920"/>
+          </a:xfrm>
+          <a:prstGeom prst="rect">
+            <a:avLst/>
+          </a:prstGeom>
+          <a:noFill/>
+          <a:ln/>
+        </p:spPr>
+        <p:txBody>
+          <a:bodyPr wrap="square" lIns="0" tIns="0" rIns="0" bIns="0" rtlCol="0" anchor="ctr"/>
+          <a:lstStyle/>
+          <a:p>
+            <a:pPr algn="ctr" indent="0" marL="0">
+              <a:buNone/>
+            </a:pPr>
+            <a:r>
+              <a:rPr lang="en-US" sz="2000" b="1" dirty="0">
+                <a:solidFill>
+                  <a:schemeClr val="tx2"/>
+                </a:solidFill>
+                <a:latin typeface="Arial" pitchFamily="34" charset="0"/>
+                <a:ea typeface="Arial" pitchFamily="34" charset="-122"/>
+                <a:cs typeface="Arial" pitchFamily="34" charset="-120"/>
+              </a:rPr>
+              <a:t>06</a:t>
+            </a:r>
+            <a:endParaRPr lang="en-US" sz="2000" dirty="0"/>
+          </a:p>
+        </p:txBody>
+      </p:sp>
+      <p:sp>
+        <p:nvSpPr>
+          <p:cNvPr id="5" name="Transform bullets"/>
           <p:cNvSpPr txBox="1"/>
           <p:nvPr/>
         </p:nvSpPr>
@@ -8061,7 +8578,7 @@
                   <a:tcPr marL="91440" marR="91440" marT="36576" marB="36576" anchor="ctr">
                     <a:lnL w="9525" cap="flat" cmpd="sng" algn="ctr">
                       <a:solidFill>
-                        <a:srgbClr val="BFD8D8"/>
+                        <a:srgbClr val="D9DCE3"/>
                       </a:solidFill>
                       <a:prstDash val="solid"/>
                       <a:round/>
@@ -8070,7 +8587,7 @@
                     </a:lnL>
                     <a:lnR w="9525" cap="flat" cmpd="sng" algn="ctr">
                       <a:solidFill>
-                        <a:srgbClr val="BFD8D8"/>
+                        <a:srgbClr val="D9DCE3"/>
                       </a:solidFill>
                       <a:prstDash val="solid"/>
                       <a:round/>
@@ -8079,7 +8596,7 @@
                     </a:lnR>
                     <a:lnT w="9525" cap="flat" cmpd="sng" algn="ctr">
                       <a:solidFill>
-                        <a:srgbClr val="BFD8D8"/>
+                        <a:srgbClr val="D9DCE3"/>
                       </a:solidFill>
                       <a:prstDash val="solid"/>
                       <a:round/>
@@ -8088,7 +8605,7 @@
                     </a:lnT>
                     <a:lnB w="9525" cap="flat" cmpd="sng" algn="ctr">
                       <a:solidFill>
-                        <a:srgbClr val="BFD8D8"/>
+                        <a:srgbClr val="D9DCE3"/>
                       </a:solidFill>
                       <a:prstDash val="solid"/>
                       <a:round/>
@@ -8122,7 +8639,7 @@
                   <a:tcPr marL="91440" marR="91440" marT="36576" marB="36576" anchor="ctr">
                     <a:lnL w="9525" cap="flat" cmpd="sng" algn="ctr">
                       <a:solidFill>
-                        <a:srgbClr val="BFD8D8"/>
+                        <a:srgbClr val="D9DCE3"/>
                       </a:solidFill>
                       <a:prstDash val="solid"/>
                       <a:round/>
@@ -8131,7 +8648,7 @@
                     </a:lnL>
                     <a:lnR w="9525" cap="flat" cmpd="sng" algn="ctr">
                       <a:solidFill>
-                        <a:srgbClr val="BFD8D8"/>
+                        <a:srgbClr val="D9DCE3"/>
                       </a:solidFill>
                       <a:prstDash val="solid"/>
                       <a:round/>
@@ -8140,7 +8657,7 @@
                     </a:lnR>
                     <a:lnT w="9525" cap="flat" cmpd="sng" algn="ctr">
                       <a:solidFill>
-                        <a:srgbClr val="BFD8D8"/>
+                        <a:srgbClr val="D9DCE3"/>
                       </a:solidFill>
                       <a:prstDash val="solid"/>
                       <a:round/>
@@ -8149,7 +8666,7 @@
                     </a:lnT>
                     <a:lnB w="9525" cap="flat" cmpd="sng" algn="ctr">
                       <a:solidFill>
-                        <a:srgbClr val="BFD8D8"/>
+                        <a:srgbClr val="D9DCE3"/>
                       </a:solidFill>
                       <a:prstDash val="solid"/>
                       <a:round/>
@@ -8183,7 +8700,7 @@
                   <a:tcPr marL="91440" marR="91440" marT="36576" marB="36576" anchor="ctr">
                     <a:lnL w="9525" cap="flat" cmpd="sng" algn="ctr">
                       <a:solidFill>
-                        <a:srgbClr val="BFD8D8"/>
+                        <a:srgbClr val="D9DCE3"/>
                       </a:solidFill>
                       <a:prstDash val="solid"/>
                       <a:round/>
@@ -8192,7 +8709,7 @@
                     </a:lnL>
                     <a:lnR w="9525" cap="flat" cmpd="sng" algn="ctr">
                       <a:solidFill>
-                        <a:srgbClr val="BFD8D8"/>
+                        <a:srgbClr val="D9DCE3"/>
                       </a:solidFill>
                       <a:prstDash val="solid"/>
                       <a:round/>
@@ -8201,7 +8718,7 @@
                     </a:lnR>
                     <a:lnT w="9525" cap="flat" cmpd="sng" algn="ctr">
                       <a:solidFill>
-                        <a:srgbClr val="BFD8D8"/>
+                        <a:srgbClr val="D9DCE3"/>
                       </a:solidFill>
                       <a:prstDash val="solid"/>
                       <a:round/>
@@ -8210,7 +8727,7 @@
                     </a:lnT>
                     <a:lnB w="9525" cap="flat" cmpd="sng" algn="ctr">
                       <a:solidFill>
-                        <a:srgbClr val="BFD8D8"/>
+                        <a:srgbClr val="D9DCE3"/>
                       </a:solidFill>
                       <a:prstDash val="solid"/>
                       <a:round/>
@@ -8246,7 +8763,7 @@
                   <a:tcPr marL="91440" marR="91440" marT="36576" marB="36576" anchor="ctr">
                     <a:lnL w="9525" cap="flat" cmpd="sng" algn="ctr">
                       <a:solidFill>
-                        <a:srgbClr val="BFD8D8"/>
+                        <a:srgbClr val="D9DCE3"/>
                       </a:solidFill>
                       <a:prstDash val="solid"/>
                       <a:round/>
@@ -8255,7 +8772,7 @@
                     </a:lnL>
                     <a:lnR w="9525" cap="flat" cmpd="sng" algn="ctr">
                       <a:solidFill>
-                        <a:srgbClr val="BFD8D8"/>
+                        <a:srgbClr val="D9DCE3"/>
                       </a:solidFill>
                       <a:prstDash val="solid"/>
                       <a:round/>
@@ -8264,7 +8781,7 @@
                     </a:lnR>
                     <a:lnT w="9525" cap="flat" cmpd="sng" algn="ctr">
                       <a:solidFill>
-                        <a:srgbClr val="BFD8D8"/>
+                        <a:srgbClr val="D9DCE3"/>
                       </a:solidFill>
                       <a:prstDash val="solid"/>
                       <a:round/>
@@ -8273,7 +8790,7 @@
                     </a:lnT>
                     <a:lnB w="9525" cap="flat" cmpd="sng" algn="ctr">
                       <a:solidFill>
-                        <a:srgbClr val="BFD8D8"/>
+                        <a:srgbClr val="D9DCE3"/>
                       </a:solidFill>
                       <a:prstDash val="solid"/>
                       <a:round/>
@@ -8307,7 +8824,7 @@
                   <a:tcPr marL="91440" marR="91440" marT="36576" marB="36576" anchor="ctr">
                     <a:lnL w="9525" cap="flat" cmpd="sng" algn="ctr">
                       <a:solidFill>
-                        <a:srgbClr val="BFD8D8"/>
+                        <a:srgbClr val="D9DCE3"/>
                       </a:solidFill>
                       <a:prstDash val="solid"/>
                       <a:round/>
@@ -8316,7 +8833,7 @@
                     </a:lnL>
                     <a:lnR w="9525" cap="flat" cmpd="sng" algn="ctr">
                       <a:solidFill>
-                        <a:srgbClr val="BFD8D8"/>
+                        <a:srgbClr val="D9DCE3"/>
                       </a:solidFill>
                       <a:prstDash val="solid"/>
                       <a:round/>
@@ -8325,7 +8842,7 @@
                     </a:lnR>
                     <a:lnT w="9525" cap="flat" cmpd="sng" algn="ctr">
                       <a:solidFill>
-                        <a:srgbClr val="BFD8D8"/>
+                        <a:srgbClr val="D9DCE3"/>
                       </a:solidFill>
                       <a:prstDash val="solid"/>
                       <a:round/>
@@ -8334,7 +8851,7 @@
                     </a:lnT>
                     <a:lnB w="9525" cap="flat" cmpd="sng" algn="ctr">
                       <a:solidFill>
-                        <a:srgbClr val="BFD8D8"/>
+                        <a:srgbClr val="D9DCE3"/>
                       </a:solidFill>
                       <a:prstDash val="solid"/>
                       <a:round/>
@@ -8368,7 +8885,7 @@
                   <a:tcPr marL="91440" marR="91440" marT="36576" marB="36576" anchor="ctr">
                     <a:lnL w="9525" cap="flat" cmpd="sng" algn="ctr">
                       <a:solidFill>
-                        <a:srgbClr val="BFD8D8"/>
+                        <a:srgbClr val="D9DCE3"/>
                       </a:solidFill>
                       <a:prstDash val="solid"/>
                       <a:round/>
@@ -8377,7 +8894,7 @@
                     </a:lnL>
                     <a:lnR w="9525" cap="flat" cmpd="sng" algn="ctr">
                       <a:solidFill>
-                        <a:srgbClr val="BFD8D8"/>
+                        <a:srgbClr val="D9DCE3"/>
                       </a:solidFill>
                       <a:prstDash val="solid"/>
                       <a:round/>
@@ -8386,7 +8903,7 @@
                     </a:lnR>
                     <a:lnT w="9525" cap="flat" cmpd="sng" algn="ctr">
                       <a:solidFill>
-                        <a:srgbClr val="BFD8D8"/>
+                        <a:srgbClr val="D9DCE3"/>
                       </a:solidFill>
                       <a:prstDash val="solid"/>
                       <a:round/>
@@ -8395,7 +8912,7 @@
                     </a:lnT>
                     <a:lnB w="9525" cap="flat" cmpd="sng" algn="ctr">
                       <a:solidFill>
-                        <a:srgbClr val="BFD8D8"/>
+                        <a:srgbClr val="D9DCE3"/>
                       </a:solidFill>
                       <a:prstDash val="solid"/>
                       <a:round/>
@@ -8431,7 +8948,7 @@
                   <a:tcPr marL="91440" marR="91440" marT="36576" marB="36576" anchor="ctr">
                     <a:lnL w="9525" cap="flat" cmpd="sng" algn="ctr">
                       <a:solidFill>
-                        <a:srgbClr val="BFD8D8"/>
+                        <a:srgbClr val="D9DCE3"/>
                       </a:solidFill>
                       <a:prstDash val="solid"/>
                       <a:round/>
@@ -8440,7 +8957,7 @@
                     </a:lnL>
                     <a:lnR w="9525" cap="flat" cmpd="sng" algn="ctr">
                       <a:solidFill>
-                        <a:srgbClr val="BFD8D8"/>
+                        <a:srgbClr val="D9DCE3"/>
                       </a:solidFill>
                       <a:prstDash val="solid"/>
                       <a:round/>
@@ -8449,7 +8966,7 @@
                     </a:lnR>
                     <a:lnT w="9525" cap="flat" cmpd="sng" algn="ctr">
                       <a:solidFill>
-                        <a:srgbClr val="BFD8D8"/>
+                        <a:srgbClr val="D9DCE3"/>
                       </a:solidFill>
                       <a:prstDash val="solid"/>
                       <a:round/>
@@ -8458,7 +8975,7 @@
                     </a:lnT>
                     <a:lnB w="9525" cap="flat" cmpd="sng" algn="ctr">
                       <a:solidFill>
-                        <a:srgbClr val="BFD8D8"/>
+                        <a:srgbClr val="D9DCE3"/>
                       </a:solidFill>
                       <a:prstDash val="solid"/>
                       <a:round/>
@@ -8492,7 +9009,7 @@
                   <a:tcPr marL="91440" marR="91440" marT="36576" marB="36576" anchor="ctr">
                     <a:lnL w="9525" cap="flat" cmpd="sng" algn="ctr">
                       <a:solidFill>
-                        <a:srgbClr val="BFD8D8"/>
+                        <a:srgbClr val="D9DCE3"/>
                       </a:solidFill>
                       <a:prstDash val="solid"/>
                       <a:round/>
@@ -8501,7 +9018,7 @@
                     </a:lnL>
                     <a:lnR w="9525" cap="flat" cmpd="sng" algn="ctr">
                       <a:solidFill>
-                        <a:srgbClr val="BFD8D8"/>
+                        <a:srgbClr val="D9DCE3"/>
                       </a:solidFill>
                       <a:prstDash val="solid"/>
                       <a:round/>
@@ -8510,7 +9027,7 @@
                     </a:lnR>
                     <a:lnT w="9525" cap="flat" cmpd="sng" algn="ctr">
                       <a:solidFill>
-                        <a:srgbClr val="BFD8D8"/>
+                        <a:srgbClr val="D9DCE3"/>
                       </a:solidFill>
                       <a:prstDash val="solid"/>
                       <a:round/>
@@ -8519,7 +9036,7 @@
                     </a:lnT>
                     <a:lnB w="9525" cap="flat" cmpd="sng" algn="ctr">
                       <a:solidFill>
-                        <a:srgbClr val="BFD8D8"/>
+                        <a:srgbClr val="D9DCE3"/>
                       </a:solidFill>
                       <a:prstDash val="solid"/>
                       <a:round/>
@@ -8553,7 +9070,7 @@
                   <a:tcPr marL="91440" marR="91440" marT="36576" marB="36576" anchor="ctr">
                     <a:lnL w="9525" cap="flat" cmpd="sng" algn="ctr">
                       <a:solidFill>
-                        <a:srgbClr val="BFD8D8"/>
+                        <a:srgbClr val="D9DCE3"/>
                       </a:solidFill>
                       <a:prstDash val="solid"/>
                       <a:round/>
@@ -8562,7 +9079,7 @@
                     </a:lnL>
                     <a:lnR w="9525" cap="flat" cmpd="sng" algn="ctr">
                       <a:solidFill>
-                        <a:srgbClr val="BFD8D8"/>
+                        <a:srgbClr val="D9DCE3"/>
                       </a:solidFill>
                       <a:prstDash val="solid"/>
                       <a:round/>
@@ -8571,7 +9088,7 @@
                     </a:lnR>
                     <a:lnT w="9525" cap="flat" cmpd="sng" algn="ctr">
                       <a:solidFill>
-                        <a:srgbClr val="BFD8D8"/>
+                        <a:srgbClr val="D9DCE3"/>
                       </a:solidFill>
                       <a:prstDash val="solid"/>
                       <a:round/>
@@ -8580,7 +9097,7 @@
                     </a:lnT>
                     <a:lnB w="9525" cap="flat" cmpd="sng" algn="ctr">
                       <a:solidFill>
-                        <a:srgbClr val="BFD8D8"/>
+                        <a:srgbClr val="D9DCE3"/>
                       </a:solidFill>
                       <a:prstDash val="solid"/>
                       <a:round/>
@@ -8616,7 +9133,7 @@
                   <a:tcPr marL="91440" marR="91440" marT="36576" marB="36576" anchor="ctr">
                     <a:lnL w="9525" cap="flat" cmpd="sng" algn="ctr">
                       <a:solidFill>
-                        <a:srgbClr val="BFD8D8"/>
+                        <a:srgbClr val="D9DCE3"/>
                       </a:solidFill>
                       <a:prstDash val="solid"/>
                       <a:round/>
@@ -8625,7 +9142,7 @@
                     </a:lnL>
                     <a:lnR w="9525" cap="flat" cmpd="sng" algn="ctr">
                       <a:solidFill>
-                        <a:srgbClr val="BFD8D8"/>
+                        <a:srgbClr val="D9DCE3"/>
                       </a:solidFill>
                       <a:prstDash val="solid"/>
                       <a:round/>
@@ -8634,7 +9151,7 @@
                     </a:lnR>
                     <a:lnT w="9525" cap="flat" cmpd="sng" algn="ctr">
                       <a:solidFill>
-                        <a:srgbClr val="BFD8D8"/>
+                        <a:srgbClr val="D9DCE3"/>
                       </a:solidFill>
                       <a:prstDash val="solid"/>
                       <a:round/>
@@ -8643,7 +9160,7 @@
                     </a:lnT>
                     <a:lnB w="9525" cap="flat" cmpd="sng" algn="ctr">
                       <a:solidFill>
-                        <a:srgbClr val="BFD8D8"/>
+                        <a:srgbClr val="D9DCE3"/>
                       </a:solidFill>
                       <a:prstDash val="solid"/>
                       <a:round/>
@@ -8677,7 +9194,7 @@
                   <a:tcPr marL="91440" marR="91440" marT="36576" marB="36576" anchor="ctr">
                     <a:lnL w="9525" cap="flat" cmpd="sng" algn="ctr">
                       <a:solidFill>
-                        <a:srgbClr val="BFD8D8"/>
+                        <a:srgbClr val="D9DCE3"/>
                       </a:solidFill>
                       <a:prstDash val="solid"/>
                       <a:round/>
@@ -8686,7 +9203,7 @@
                     </a:lnL>
                     <a:lnR w="9525" cap="flat" cmpd="sng" algn="ctr">
                       <a:solidFill>
-                        <a:srgbClr val="BFD8D8"/>
+                        <a:srgbClr val="D9DCE3"/>
                       </a:solidFill>
                       <a:prstDash val="solid"/>
                       <a:round/>
@@ -8695,7 +9212,7 @@
                     </a:lnR>
                     <a:lnT w="9525" cap="flat" cmpd="sng" algn="ctr">
                       <a:solidFill>
-                        <a:srgbClr val="BFD8D8"/>
+                        <a:srgbClr val="D9DCE3"/>
                       </a:solidFill>
                       <a:prstDash val="solid"/>
                       <a:round/>
@@ -8704,7 +9221,7 @@
                     </a:lnT>
                     <a:lnB w="9525" cap="flat" cmpd="sng" algn="ctr">
                       <a:solidFill>
-                        <a:srgbClr val="BFD8D8"/>
+                        <a:srgbClr val="D9DCE3"/>
                       </a:solidFill>
                       <a:prstDash val="solid"/>
                       <a:round/>
@@ -8738,7 +9255,7 @@
                   <a:tcPr marL="91440" marR="91440" marT="36576" marB="36576" anchor="ctr">
                     <a:lnL w="9525" cap="flat" cmpd="sng" algn="ctr">
                       <a:solidFill>
-                        <a:srgbClr val="BFD8D8"/>
+                        <a:srgbClr val="D9DCE3"/>
                       </a:solidFill>
                       <a:prstDash val="solid"/>
                       <a:round/>
@@ -8747,7 +9264,7 @@
                     </a:lnL>
                     <a:lnR w="9525" cap="flat" cmpd="sng" algn="ctr">
                       <a:solidFill>
-                        <a:srgbClr val="BFD8D8"/>
+                        <a:srgbClr val="D9DCE3"/>
                       </a:solidFill>
                       <a:prstDash val="solid"/>
                       <a:round/>
@@ -8756,7 +9273,7 @@
                     </a:lnR>
                     <a:lnT w="9525" cap="flat" cmpd="sng" algn="ctr">
                       <a:solidFill>
-                        <a:srgbClr val="BFD8D8"/>
+                        <a:srgbClr val="D9DCE3"/>
                       </a:solidFill>
                       <a:prstDash val="solid"/>
                       <a:round/>
@@ -8765,7 +9282,7 @@
                     </a:lnT>
                     <a:lnB w="9525" cap="flat" cmpd="sng" algn="ctr">
                       <a:solidFill>
-                        <a:srgbClr val="BFD8D8"/>
+                        <a:srgbClr val="D9DCE3"/>
                       </a:solidFill>
                       <a:prstDash val="solid"/>
                       <a:round/>
@@ -8801,7 +9318,7 @@
                   <a:tcPr marL="91440" marR="91440" marT="36576" marB="36576" anchor="ctr">
                     <a:lnL w="9525" cap="flat" cmpd="sng" algn="ctr">
                       <a:solidFill>
-                        <a:srgbClr val="BFD8D8"/>
+                        <a:srgbClr val="D9DCE3"/>
                       </a:solidFill>
                       <a:prstDash val="solid"/>
                       <a:round/>
@@ -8810,7 +9327,7 @@
                     </a:lnL>
                     <a:lnR w="9525" cap="flat" cmpd="sng" algn="ctr">
                       <a:solidFill>
-                        <a:srgbClr val="BFD8D8"/>
+                        <a:srgbClr val="D9DCE3"/>
                       </a:solidFill>
                       <a:prstDash val="solid"/>
                       <a:round/>
@@ -8819,7 +9336,7 @@
                     </a:lnR>
                     <a:lnT w="9525" cap="flat" cmpd="sng" algn="ctr">
                       <a:solidFill>
-                        <a:srgbClr val="BFD8D8"/>
+                        <a:srgbClr val="D9DCE3"/>
                       </a:solidFill>
                       <a:prstDash val="solid"/>
                       <a:round/>
@@ -8828,7 +9345,7 @@
                     </a:lnT>
                     <a:lnB w="9525" cap="flat" cmpd="sng" algn="ctr">
                       <a:solidFill>
-                        <a:srgbClr val="BFD8D8"/>
+                        <a:srgbClr val="D9DCE3"/>
                       </a:solidFill>
                       <a:prstDash val="solid"/>
                       <a:round/>
@@ -8862,7 +9379,7 @@
                   <a:tcPr marL="91440" marR="91440" marT="36576" marB="36576" anchor="ctr">
                     <a:lnL w="9525" cap="flat" cmpd="sng" algn="ctr">
                       <a:solidFill>
-                        <a:srgbClr val="BFD8D8"/>
+                        <a:srgbClr val="D9DCE3"/>
                       </a:solidFill>
                       <a:prstDash val="solid"/>
                       <a:round/>
@@ -8871,7 +9388,7 @@
                     </a:lnL>
                     <a:lnR w="9525" cap="flat" cmpd="sng" algn="ctr">
                       <a:solidFill>
-                        <a:srgbClr val="BFD8D8"/>
+                        <a:srgbClr val="D9DCE3"/>
                       </a:solidFill>
                       <a:prstDash val="solid"/>
                       <a:round/>
@@ -8880,7 +9397,7 @@
                     </a:lnR>
                     <a:lnT w="9525" cap="flat" cmpd="sng" algn="ctr">
                       <a:solidFill>
-                        <a:srgbClr val="BFD8D8"/>
+                        <a:srgbClr val="D9DCE3"/>
                       </a:solidFill>
                       <a:prstDash val="solid"/>
                       <a:round/>
@@ -8889,7 +9406,7 @@
                     </a:lnT>
                     <a:lnB w="9525" cap="flat" cmpd="sng" algn="ctr">
                       <a:solidFill>
-                        <a:srgbClr val="BFD8D8"/>
+                        <a:srgbClr val="D9DCE3"/>
                       </a:solidFill>
                       <a:prstDash val="solid"/>
                       <a:round/>
@@ -8923,7 +9440,7 @@
                   <a:tcPr marL="91440" marR="91440" marT="36576" marB="36576" anchor="ctr">
                     <a:lnL w="9525" cap="flat" cmpd="sng" algn="ctr">
                       <a:solidFill>
-                        <a:srgbClr val="BFD8D8"/>
+                        <a:srgbClr val="D9DCE3"/>
                       </a:solidFill>
                       <a:prstDash val="solid"/>
                       <a:round/>
@@ -8932,7 +9449,7 @@
                     </a:lnL>
                     <a:lnR w="9525" cap="flat" cmpd="sng" algn="ctr">
                       <a:solidFill>
-                        <a:srgbClr val="BFD8D8"/>
+                        <a:srgbClr val="D9DCE3"/>
                       </a:solidFill>
                       <a:prstDash val="solid"/>
                       <a:round/>
@@ -8941,7 +9458,7 @@
                     </a:lnR>
                     <a:lnT w="9525" cap="flat" cmpd="sng" algn="ctr">
                       <a:solidFill>
-                        <a:srgbClr val="BFD8D8"/>
+                        <a:srgbClr val="D9DCE3"/>
                       </a:solidFill>
                       <a:prstDash val="solid"/>
                       <a:round/>
@@ -8950,7 +9467,7 @@
                     </a:lnT>
                     <a:lnB w="9525" cap="flat" cmpd="sng" algn="ctr">
                       <a:solidFill>
-                        <a:srgbClr val="BFD8D8"/>
+                        <a:srgbClr val="D9DCE3"/>
                       </a:solidFill>
                       <a:prstDash val="solid"/>
                       <a:round/>
@@ -8969,7 +9486,7 @@
       </p:graphicFrame>
       <p:sp>
         <p:nvSpPr>
-          <p:cNvPr id="5" name="Code card"/>
+          <p:cNvPr id="7" name="Code card"/>
           <p:cNvSpPr/>
           <p:nvPr/>
         </p:nvSpPr>
@@ -8978,7 +9495,7 @@
             <a:off x="5715000" y="1371600"/>
             <a:ext cx="5925312" cy="4206240"/>
           </a:xfrm>
-          <a:prstGeom prst="roundRect">
+          <a:prstGeom prst="rect">
             <a:avLst>
               <a:gd name="adj" fmla="val 2609"/>
             </a:avLst>
@@ -8996,7 +9513,7 @@
       </p:sp>
       <p:sp>
         <p:nvSpPr>
-          <p:cNvPr id="6" name="Code snippet"/>
+          <p:cNvPr id="8" name="Code snippet"/>
           <p:cNvSpPr txBox="1"/>
           <p:nvPr/>
         </p:nvSpPr>
@@ -9237,7 +9754,7 @@
       </p:sp>
       <p:sp>
         <p:nvSpPr>
-          <p:cNvPr id="7" name="Code caption"/>
+          <p:cNvPr id="9" name="Code caption"/>
           <p:cNvSpPr txBox="1"/>
           <p:nvPr/>
         </p:nvSpPr>
@@ -9351,8 +9868,8 @@
         </p:nvSpPr>
         <p:spPr>
           <a:xfrm>
-            <a:off x="548640" y="320040"/>
-            <a:ext cx="11091672" cy="777240"/>
+            <a:off x="1417320" y="320040"/>
+            <a:ext cx="10222992" cy="777240"/>
           </a:xfrm>
           <a:prstGeom prst="rect">
             <a:avLst/>
@@ -9372,9 +9889,9 @@
                 <a:solidFill>
                   <a:schemeClr val="tx2"/>
                 </a:solidFill>
-                <a:latin typeface="Cambria" pitchFamily="34" charset="0"/>
-                <a:ea typeface="Cambria" pitchFamily="34" charset="-122"/>
-                <a:cs typeface="Cambria" pitchFamily="34" charset="-120"/>
+                <a:latin typeface="Arial" pitchFamily="34" charset="0"/>
+                <a:ea typeface="Arial" pitchFamily="34" charset="-122"/>
+                <a:cs typeface="Arial" pitchFamily="34" charset="-120"/>
               </a:rPr>
               <a:t>Sơ đồ ERD của cơ sở dữ liệu (mức khái niệm)</a:t>
             </a:r>
@@ -9384,7 +9901,71 @@
       </p:sp>
       <p:sp>
         <p:nvSpPr>
-          <p:cNvPr id="3" name="Relationship line nộp"/>
+          <p:cNvPr id="3" name="Slide tag"/>
+          <p:cNvSpPr/>
+          <p:nvPr/>
+        </p:nvSpPr>
+        <p:spPr>
+          <a:xfrm>
+            <a:off x="548640" y="457200"/>
+            <a:ext cx="685800" cy="502920"/>
+          </a:xfrm>
+          <a:prstGeom prst="rect">
+            <a:avLst/>
+          </a:prstGeom>
+          <a:solidFill>
+            <a:schemeClr val="accent2"/>
+          </a:solidFill>
+          <a:ln w="12700">
+            <a:solidFill>
+              <a:schemeClr val="accent2"/>
+            </a:solidFill>
+            <a:prstDash val="solid"/>
+          </a:ln>
+        </p:spPr>
+      </p:sp>
+      <p:sp>
+        <p:nvSpPr>
+          <p:cNvPr id="4" name="Slide tag number"/>
+          <p:cNvSpPr txBox="1"/>
+          <p:nvPr/>
+        </p:nvSpPr>
+        <p:spPr>
+          <a:xfrm>
+            <a:off x="548640" y="457200"/>
+            <a:ext cx="685800" cy="502920"/>
+          </a:xfrm>
+          <a:prstGeom prst="rect">
+            <a:avLst/>
+          </a:prstGeom>
+          <a:noFill/>
+          <a:ln/>
+        </p:spPr>
+        <p:txBody>
+          <a:bodyPr wrap="square" lIns="0" tIns="0" rIns="0" bIns="0" rtlCol="0" anchor="ctr"/>
+          <a:lstStyle/>
+          <a:p>
+            <a:pPr algn="ctr" indent="0" marL="0">
+              <a:buNone/>
+            </a:pPr>
+            <a:r>
+              <a:rPr lang="en-US" sz="2000" b="1" dirty="0">
+                <a:solidFill>
+                  <a:schemeClr val="tx2"/>
+                </a:solidFill>
+                <a:latin typeface="Arial" pitchFamily="34" charset="0"/>
+                <a:ea typeface="Arial" pitchFamily="34" charset="-122"/>
+                <a:cs typeface="Arial" pitchFamily="34" charset="-120"/>
+              </a:rPr>
+              <a:t>07</a:t>
+            </a:r>
+            <a:endParaRPr lang="en-US" sz="2000" dirty="0"/>
+          </a:p>
+        </p:txBody>
+      </p:sp>
+      <p:sp>
+        <p:nvSpPr>
+          <p:cNvPr id="5" name="Relationship line nộp"/>
           <p:cNvSpPr/>
           <p:nvPr/>
         </p:nvSpPr>
@@ -9407,7 +9988,7 @@
       </p:sp>
       <p:sp>
         <p:nvSpPr>
-          <p:cNvPr id="4" name="Relationship nộp"/>
+          <p:cNvPr id="6" name="Relationship nộp"/>
           <p:cNvSpPr/>
           <p:nvPr/>
         </p:nvSpPr>
@@ -9432,7 +10013,7 @@
       </p:sp>
       <p:sp>
         <p:nvSpPr>
-          <p:cNvPr id="5" name="Relationship label nộp"/>
+          <p:cNvPr id="7" name="Relationship label nộp"/>
           <p:cNvSpPr txBox="1"/>
           <p:nvPr/>
         </p:nvSpPr>
@@ -9468,7 +10049,7 @@
       </p:sp>
       <p:sp>
         <p:nvSpPr>
-          <p:cNvPr id="6" name="Cardinality 1"/>
+          <p:cNvPr id="8" name="Cardinality 1"/>
           <p:cNvSpPr txBox="1"/>
           <p:nvPr/>
         </p:nvSpPr>
@@ -9504,7 +10085,7 @@
       </p:sp>
       <p:sp>
         <p:nvSpPr>
-          <p:cNvPr id="7" name="Cardinality n"/>
+          <p:cNvPr id="9" name="Cardinality n"/>
           <p:cNvSpPr txBox="1"/>
           <p:nvPr/>
         </p:nvSpPr>
@@ -9540,7 +10121,7 @@
       </p:sp>
       <p:sp>
         <p:nvSpPr>
-          <p:cNvPr id="8" name="Relationship line mang về"/>
+          <p:cNvPr id="10" name="Relationship line mang về"/>
           <p:cNvSpPr/>
           <p:nvPr/>
         </p:nvSpPr>
@@ -9563,7 +10144,7 @@
       </p:sp>
       <p:sp>
         <p:nvSpPr>
-          <p:cNvPr id="9" name="Relationship mang về"/>
+          <p:cNvPr id="11" name="Relationship mang về"/>
           <p:cNvSpPr/>
           <p:nvPr/>
         </p:nvSpPr>
@@ -9588,7 +10169,7 @@
       </p:sp>
       <p:sp>
         <p:nvSpPr>
-          <p:cNvPr id="10" name="Relationship label mang về"/>
+          <p:cNvPr id="12" name="Relationship label mang về"/>
           <p:cNvSpPr txBox="1"/>
           <p:nvPr/>
         </p:nvSpPr>
@@ -9624,7 +10205,7 @@
       </p:sp>
       <p:sp>
         <p:nvSpPr>
-          <p:cNvPr id="11" name="Cardinality 1"/>
+          <p:cNvPr id="13" name="Cardinality 1"/>
           <p:cNvSpPr txBox="1"/>
           <p:nvPr/>
         </p:nvSpPr>
@@ -9660,7 +10241,7 @@
       </p:sp>
       <p:sp>
         <p:nvSpPr>
-          <p:cNvPr id="12" name="Cardinality n"/>
+          <p:cNvPr id="14" name="Cardinality n"/>
           <p:cNvSpPr txBox="1"/>
           <p:nvPr/>
         </p:nvSpPr>
@@ -9696,7 +10277,7 @@
       </p:sp>
       <p:sp>
         <p:nvSpPr>
-          <p:cNvPr id="13" name="Relationship line nhận"/>
+          <p:cNvPr id="15" name="Relationship line nhận"/>
           <p:cNvSpPr/>
           <p:nvPr/>
         </p:nvSpPr>
@@ -9719,7 +10300,7 @@
       </p:sp>
       <p:sp>
         <p:nvSpPr>
-          <p:cNvPr id="14" name="Relationship nhận"/>
+          <p:cNvPr id="16" name="Relationship nhận"/>
           <p:cNvSpPr/>
           <p:nvPr/>
         </p:nvSpPr>
@@ -9744,7 +10325,7 @@
       </p:sp>
       <p:sp>
         <p:nvSpPr>
-          <p:cNvPr id="15" name="Relationship label nhận"/>
+          <p:cNvPr id="17" name="Relationship label nhận"/>
           <p:cNvSpPr txBox="1"/>
           <p:nvPr/>
         </p:nvSpPr>
@@ -9780,7 +10361,7 @@
       </p:sp>
       <p:sp>
         <p:nvSpPr>
-          <p:cNvPr id="16" name="Cardinality 1"/>
+          <p:cNvPr id="18" name="Cardinality 1"/>
           <p:cNvSpPr txBox="1"/>
           <p:nvPr/>
         </p:nvSpPr>
@@ -9816,7 +10397,7 @@
       </p:sp>
       <p:sp>
         <p:nvSpPr>
-          <p:cNvPr id="17" name="Cardinality n"/>
+          <p:cNvPr id="19" name="Cardinality n"/>
           <p:cNvSpPr txBox="1"/>
           <p:nvPr/>
         </p:nvSpPr>
@@ -9852,7 +10433,7 @@
       </p:sp>
       <p:sp>
         <p:nvSpPr>
-          <p:cNvPr id="18" name="Relationship line có"/>
+          <p:cNvPr id="20" name="Relationship line có"/>
           <p:cNvSpPr/>
           <p:nvPr/>
         </p:nvSpPr>
@@ -9875,7 +10456,7 @@
       </p:sp>
       <p:sp>
         <p:nvSpPr>
-          <p:cNvPr id="19" name="Relationship có"/>
+          <p:cNvPr id="21" name="Relationship có"/>
           <p:cNvSpPr/>
           <p:nvPr/>
         </p:nvSpPr>
@@ -9900,7 +10481,7 @@
       </p:sp>
       <p:sp>
         <p:nvSpPr>
-          <p:cNvPr id="20" name="Relationship label có"/>
+          <p:cNvPr id="22" name="Relationship label có"/>
           <p:cNvSpPr txBox="1"/>
           <p:nvPr/>
         </p:nvSpPr>
@@ -9936,7 +10517,7 @@
       </p:sp>
       <p:sp>
         <p:nvSpPr>
-          <p:cNvPr id="21" name="Cardinality 1"/>
+          <p:cNvPr id="23" name="Cardinality 1"/>
           <p:cNvSpPr txBox="1"/>
           <p:nvPr/>
         </p:nvSpPr>
@@ -9972,7 +10553,7 @@
       </p:sp>
       <p:sp>
         <p:nvSpPr>
-          <p:cNvPr id="22" name="Cardinality n"/>
+          <p:cNvPr id="24" name="Cardinality n"/>
           <p:cNvSpPr txBox="1"/>
           <p:nvPr/>
         </p:nvSpPr>
@@ -10008,7 +10589,7 @@
       </p:sp>
       <p:sp>
         <p:nvSpPr>
-          <p:cNvPr id="23" name="Ứng viên entity"/>
+          <p:cNvPr id="25" name="Ứng viên entity"/>
           <p:cNvSpPr/>
           <p:nvPr/>
         </p:nvSpPr>
@@ -10033,7 +10614,7 @@
       </p:sp>
       <p:sp>
         <p:nvSpPr>
-          <p:cNvPr id="24" name="Ứng viên header"/>
+          <p:cNvPr id="26" name="Ứng viên header"/>
           <p:cNvSpPr txBox="1"/>
           <p:nvPr/>
         </p:nvSpPr>
@@ -10071,7 +10652,7 @@
       </p:sp>
       <p:sp>
         <p:nvSpPr>
-          <p:cNvPr id="25" name="Ứng viên attr 1"/>
+          <p:cNvPr id="27" name="Ứng viên attr 1"/>
           <p:cNvSpPr txBox="1"/>
           <p:nvPr/>
         </p:nvSpPr>
@@ -10115,7 +10696,7 @@
       </p:sp>
       <p:sp>
         <p:nvSpPr>
-          <p:cNvPr id="26" name="Ứng viên attr 2"/>
+          <p:cNvPr id="28" name="Ứng viên attr 2"/>
           <p:cNvSpPr txBox="1"/>
           <p:nvPr/>
         </p:nvSpPr>
@@ -10151,7 +10732,7 @@
       </p:sp>
       <p:sp>
         <p:nvSpPr>
-          <p:cNvPr id="27" name="Ứng viên attr 3"/>
+          <p:cNvPr id="29" name="Ứng viên attr 3"/>
           <p:cNvSpPr txBox="1"/>
           <p:nvPr/>
         </p:nvSpPr>
@@ -10187,7 +10768,7 @@
       </p:sp>
       <p:sp>
         <p:nvSpPr>
-          <p:cNvPr id="28" name="Nguồn hồ sơ entity"/>
+          <p:cNvPr id="30" name="Nguồn hồ sơ entity"/>
           <p:cNvSpPr/>
           <p:nvPr/>
         </p:nvSpPr>
@@ -10212,7 +10793,7 @@
       </p:sp>
       <p:sp>
         <p:nvSpPr>
-          <p:cNvPr id="29" name="Nguồn hồ sơ header"/>
+          <p:cNvPr id="31" name="Nguồn hồ sơ header"/>
           <p:cNvSpPr txBox="1"/>
           <p:nvPr/>
         </p:nvSpPr>
@@ -10250,7 +10831,7 @@
       </p:sp>
       <p:sp>
         <p:nvSpPr>
-          <p:cNvPr id="30" name="Nguồn hồ sơ attr 1"/>
+          <p:cNvPr id="32" name="Nguồn hồ sơ attr 1"/>
           <p:cNvSpPr txBox="1"/>
           <p:nvPr/>
         </p:nvSpPr>
@@ -10294,7 +10875,7 @@
       </p:sp>
       <p:sp>
         <p:nvSpPr>
-          <p:cNvPr id="31" name="Nguồn hồ sơ attr 2"/>
+          <p:cNvPr id="33" name="Nguồn hồ sơ attr 2"/>
           <p:cNvSpPr txBox="1"/>
           <p:nvPr/>
         </p:nvSpPr>
@@ -10330,7 +10911,7 @@
       </p:sp>
       <p:sp>
         <p:nvSpPr>
-          <p:cNvPr id="32" name="Vị trí tuyển entity"/>
+          <p:cNvPr id="34" name="Vị trí tuyển entity"/>
           <p:cNvSpPr/>
           <p:nvPr/>
         </p:nvSpPr>
@@ -10355,7 +10936,7 @@
       </p:sp>
       <p:sp>
         <p:nvSpPr>
-          <p:cNvPr id="33" name="Vị trí tuyển header"/>
+          <p:cNvPr id="35" name="Vị trí tuyển header"/>
           <p:cNvSpPr txBox="1"/>
           <p:nvPr/>
         </p:nvSpPr>
@@ -10393,7 +10974,7 @@
       </p:sp>
       <p:sp>
         <p:nvSpPr>
-          <p:cNvPr id="34" name="Vị trí tuyển attr 1"/>
+          <p:cNvPr id="36" name="Vị trí tuyển attr 1"/>
           <p:cNvSpPr txBox="1"/>
           <p:nvPr/>
         </p:nvSpPr>
@@ -10437,7 +11018,7 @@
       </p:sp>
       <p:sp>
         <p:nvSpPr>
-          <p:cNvPr id="35" name="Vị trí tuyển attr 2"/>
+          <p:cNvPr id="37" name="Vị trí tuyển attr 2"/>
           <p:cNvSpPr txBox="1"/>
           <p:nvPr/>
         </p:nvSpPr>
@@ -10473,7 +11054,7 @@
       </p:sp>
       <p:sp>
         <p:nvSpPr>
-          <p:cNvPr id="36" name="Vị trí tuyển attr 3"/>
+          <p:cNvPr id="38" name="Vị trí tuyển attr 3"/>
           <p:cNvSpPr txBox="1"/>
           <p:nvPr/>
         </p:nvSpPr>
@@ -10509,7 +11090,7 @@
       </p:sp>
       <p:sp>
         <p:nvSpPr>
-          <p:cNvPr id="37" name="Vòng tuyển entity"/>
+          <p:cNvPr id="39" name="Vòng tuyển entity"/>
           <p:cNvSpPr/>
           <p:nvPr/>
         </p:nvSpPr>
@@ -10534,7 +11115,7 @@
       </p:sp>
       <p:sp>
         <p:nvSpPr>
-          <p:cNvPr id="38" name="Vòng tuyển header"/>
+          <p:cNvPr id="40" name="Vòng tuyển header"/>
           <p:cNvSpPr txBox="1"/>
           <p:nvPr/>
         </p:nvSpPr>
@@ -10572,7 +11153,7 @@
       </p:sp>
       <p:sp>
         <p:nvSpPr>
-          <p:cNvPr id="39" name="Vòng tuyển attr 1"/>
+          <p:cNvPr id="41" name="Vòng tuyển attr 1"/>
           <p:cNvSpPr txBox="1"/>
           <p:nvPr/>
         </p:nvSpPr>
@@ -10616,7 +11197,7 @@
       </p:sp>
       <p:sp>
         <p:nvSpPr>
-          <p:cNvPr id="40" name="Vòng tuyển attr 2"/>
+          <p:cNvPr id="42" name="Vòng tuyển attr 2"/>
           <p:cNvSpPr txBox="1"/>
           <p:nvPr/>
         </p:nvSpPr>
@@ -10652,7 +11233,7 @@
       </p:sp>
       <p:sp>
         <p:nvSpPr>
-          <p:cNvPr id="41" name="Vòng tuyển attr 3"/>
+          <p:cNvPr id="43" name="Vòng tuyển attr 3"/>
           <p:cNvSpPr txBox="1"/>
           <p:nvPr/>
         </p:nvSpPr>
@@ -10688,7 +11269,7 @@
       </p:sp>
       <p:sp>
         <p:nvSpPr>
-          <p:cNvPr id="42" name="Hồ sơ ứng tuyển entity"/>
+          <p:cNvPr id="44" name="Hồ sơ ứng tuyển entity"/>
           <p:cNvSpPr/>
           <p:nvPr/>
         </p:nvSpPr>
@@ -10713,7 +11294,7 @@
       </p:sp>
       <p:sp>
         <p:nvSpPr>
-          <p:cNvPr id="43" name="Hồ sơ ứng tuyển header"/>
+          <p:cNvPr id="45" name="Hồ sơ ứng tuyển header"/>
           <p:cNvSpPr txBox="1"/>
           <p:nvPr/>
         </p:nvSpPr>
@@ -10751,7 +11332,7 @@
       </p:sp>
       <p:sp>
         <p:nvSpPr>
-          <p:cNvPr id="44" name="Hồ sơ ứng tuyển attr 1"/>
+          <p:cNvPr id="46" name="Hồ sơ ứng tuyển attr 1"/>
           <p:cNvSpPr txBox="1"/>
           <p:nvPr/>
         </p:nvSpPr>
@@ -10795,7 +11376,7 @@
       </p:sp>
       <p:sp>
         <p:nvSpPr>
-          <p:cNvPr id="45" name="Hồ sơ ứng tuyển attr 2"/>
+          <p:cNvPr id="47" name="Hồ sơ ứng tuyển attr 2"/>
           <p:cNvSpPr txBox="1"/>
           <p:nvPr/>
         </p:nvSpPr>
@@ -10831,7 +11412,7 @@
       </p:sp>
       <p:sp>
         <p:nvSpPr>
-          <p:cNvPr id="46" name="Hồ sơ ứng tuyển attr 3"/>
+          <p:cNvPr id="48" name="Hồ sơ ứng tuyển attr 3"/>
           <p:cNvSpPr txBox="1"/>
           <p:nvPr/>
         </p:nvSpPr>
@@ -10867,7 +11448,7 @@
       </p:sp>
       <p:sp>
         <p:nvSpPr>
-          <p:cNvPr id="47" name="Legend card"/>
+          <p:cNvPr id="49" name="Legend card"/>
           <p:cNvSpPr/>
           <p:nvPr/>
         </p:nvSpPr>
@@ -10876,7 +11457,7 @@
             <a:off x="548640" y="5440680"/>
             <a:ext cx="11091672" cy="658368"/>
           </a:xfrm>
-          <a:prstGeom prst="roundRect">
+          <a:prstGeom prst="rect">
             <a:avLst>
               <a:gd name="adj" fmla="val 13889"/>
             </a:avLst>
@@ -10894,7 +11475,7 @@
       </p:sp>
       <p:sp>
         <p:nvSpPr>
-          <p:cNvPr id="48" name="Legend text"/>
+          <p:cNvPr id="50" name="Legend text"/>
           <p:cNvSpPr txBox="1"/>
           <p:nvPr/>
         </p:nvSpPr>
@@ -11030,8 +11611,8 @@
         </p:nvSpPr>
         <p:spPr>
           <a:xfrm>
-            <a:off x="548640" y="320040"/>
-            <a:ext cx="11091672" cy="777240"/>
+            <a:off x="1417320" y="320040"/>
+            <a:ext cx="10222992" cy="777240"/>
           </a:xfrm>
           <a:prstGeom prst="rect">
             <a:avLst/>
@@ -11051,9 +11632,9 @@
                 <a:solidFill>
                   <a:schemeClr val="tx2"/>
                 </a:solidFill>
-                <a:latin typeface="Cambria" pitchFamily="34" charset="0"/>
-                <a:ea typeface="Cambria" pitchFamily="34" charset="-122"/>
-                <a:cs typeface="Cambria" pitchFamily="34" charset="-120"/>
+                <a:latin typeface="Arial" pitchFamily="34" charset="0"/>
+                <a:ea typeface="Arial" pitchFamily="34" charset="-122"/>
+                <a:cs typeface="Arial" pitchFamily="34" charset="-120"/>
               </a:rPr>
               <a:t>Kiến trúc công nghệ của hệ thống</a:t>
             </a:r>
@@ -11063,7 +11644,71 @@
       </p:sp>
       <p:sp>
         <p:nvSpPr>
-          <p:cNvPr id="3" name="Arch box 1"/>
+          <p:cNvPr id="3" name="Slide tag"/>
+          <p:cNvSpPr/>
+          <p:nvPr/>
+        </p:nvSpPr>
+        <p:spPr>
+          <a:xfrm>
+            <a:off x="548640" y="457200"/>
+            <a:ext cx="685800" cy="502920"/>
+          </a:xfrm>
+          <a:prstGeom prst="rect">
+            <a:avLst/>
+          </a:prstGeom>
+          <a:solidFill>
+            <a:schemeClr val="accent2"/>
+          </a:solidFill>
+          <a:ln w="12700">
+            <a:solidFill>
+              <a:schemeClr val="accent2"/>
+            </a:solidFill>
+            <a:prstDash val="solid"/>
+          </a:ln>
+        </p:spPr>
+      </p:sp>
+      <p:sp>
+        <p:nvSpPr>
+          <p:cNvPr id="4" name="Slide tag number"/>
+          <p:cNvSpPr txBox="1"/>
+          <p:nvPr/>
+        </p:nvSpPr>
+        <p:spPr>
+          <a:xfrm>
+            <a:off x="548640" y="457200"/>
+            <a:ext cx="685800" cy="502920"/>
+          </a:xfrm>
+          <a:prstGeom prst="rect">
+            <a:avLst/>
+          </a:prstGeom>
+          <a:noFill/>
+          <a:ln/>
+        </p:spPr>
+        <p:txBody>
+          <a:bodyPr wrap="square" lIns="0" tIns="0" rIns="0" bIns="0" rtlCol="0" anchor="ctr"/>
+          <a:lstStyle/>
+          <a:p>
+            <a:pPr algn="ctr" indent="0" marL="0">
+              <a:buNone/>
+            </a:pPr>
+            <a:r>
+              <a:rPr lang="en-US" sz="2000" b="1" dirty="0">
+                <a:solidFill>
+                  <a:schemeClr val="tx2"/>
+                </a:solidFill>
+                <a:latin typeface="Arial" pitchFamily="34" charset="0"/>
+                <a:ea typeface="Arial" pitchFamily="34" charset="-122"/>
+                <a:cs typeface="Arial" pitchFamily="34" charset="-120"/>
+              </a:rPr>
+              <a:t>08</a:t>
+            </a:r>
+            <a:endParaRPr lang="en-US" sz="2000" dirty="0"/>
+          </a:p>
+        </p:txBody>
+      </p:sp>
+      <p:sp>
+        <p:nvSpPr>
+          <p:cNvPr id="5" name="Arch box 1"/>
           <p:cNvSpPr/>
           <p:nvPr/>
         </p:nvSpPr>
@@ -11072,7 +11717,7 @@
             <a:off x="548640" y="1371600"/>
             <a:ext cx="1889150" cy="1828800"/>
           </a:xfrm>
-          <a:prstGeom prst="roundRect">
+          <a:prstGeom prst="rect">
             <a:avLst>
               <a:gd name="adj" fmla="val 6000"/>
             </a:avLst>
@@ -11090,7 +11735,7 @@
       </p:sp>
       <p:sp>
         <p:nvSpPr>
-          <p:cNvPr id="4" name="Arch icon 1 circle"/>
+          <p:cNvPr id="6" name="Arch icon 1 circle"/>
           <p:cNvSpPr/>
           <p:nvPr/>
         </p:nvSpPr>
@@ -11099,7 +11744,7 @@
             <a:off x="1218895" y="1481328"/>
             <a:ext cx="548640" cy="548640"/>
           </a:xfrm>
-          <a:prstGeom prst="ellipse">
+          <a:prstGeom prst="rect">
             <a:avLst/>
           </a:prstGeom>
           <a:solidFill>
@@ -11115,7 +11760,7 @@
       </p:sp>
       <p:pic>
         <p:nvPicPr>
-          <p:cNvPr id="5" name="Arch icon 1 icon" descr="Arch icon 1">    </p:cNvPr>
+          <p:cNvPr id="7" name="Arch icon 1 icon" descr="Arch icon 1">    </p:cNvPr>
           <p:cNvPicPr>
             <a:picLocks noChangeAspect="1"/>
           </p:cNvPicPr>
@@ -11139,7 +11784,7 @@
       </p:pic>
       <p:sp>
         <p:nvSpPr>
-          <p:cNvPr id="6" name="Arch name 1"/>
+          <p:cNvPr id="8" name="Arch name 1"/>
           <p:cNvSpPr txBox="1"/>
           <p:nvPr/>
         </p:nvSpPr>
@@ -11175,7 +11820,7 @@
       </p:sp>
       <p:sp>
         <p:nvSpPr>
-          <p:cNvPr id="7" name="Arch role 1"/>
+          <p:cNvPr id="9" name="Arch role 1"/>
           <p:cNvSpPr txBox="1"/>
           <p:nvPr/>
         </p:nvSpPr>
@@ -11225,7 +11870,7 @@
       </p:sp>
       <p:sp>
         <p:nvSpPr>
-          <p:cNvPr id="8" name="Arch arrow 1"/>
+          <p:cNvPr id="10" name="Arch arrow 1"/>
           <p:cNvSpPr/>
           <p:nvPr/>
         </p:nvSpPr>
@@ -11250,7 +11895,7 @@
       </p:sp>
       <p:sp>
         <p:nvSpPr>
-          <p:cNvPr id="9" name="Arch box 2"/>
+          <p:cNvPr id="11" name="Arch box 2"/>
           <p:cNvSpPr/>
           <p:nvPr/>
         </p:nvSpPr>
@@ -11259,7 +11904,7 @@
             <a:off x="2849270" y="1371600"/>
             <a:ext cx="1889150" cy="1828800"/>
           </a:xfrm>
-          <a:prstGeom prst="roundRect">
+          <a:prstGeom prst="rect">
             <a:avLst>
               <a:gd name="adj" fmla="val 6000"/>
             </a:avLst>
@@ -11277,7 +11922,7 @@
       </p:sp>
       <p:sp>
         <p:nvSpPr>
-          <p:cNvPr id="10" name="Arch icon 2 circle"/>
+          <p:cNvPr id="12" name="Arch icon 2 circle"/>
           <p:cNvSpPr/>
           <p:nvPr/>
         </p:nvSpPr>
@@ -11286,7 +11931,7 @@
             <a:off x="3519526" y="1481328"/>
             <a:ext cx="548640" cy="548640"/>
           </a:xfrm>
-          <a:prstGeom prst="ellipse">
+          <a:prstGeom prst="rect">
             <a:avLst/>
           </a:prstGeom>
           <a:solidFill>
@@ -11302,7 +11947,7 @@
       </p:sp>
       <p:pic>
         <p:nvPicPr>
-          <p:cNvPr id="11" name="Arch icon 2 icon" descr="Arch icon 2">    </p:cNvPr>
+          <p:cNvPr id="13" name="Arch icon 2 icon" descr="Arch icon 2">    </p:cNvPr>
           <p:cNvPicPr>
             <a:picLocks noChangeAspect="1"/>
           </p:cNvPicPr>
@@ -11326,7 +11971,7 @@
       </p:pic>
       <p:sp>
         <p:nvSpPr>
-          <p:cNvPr id="12" name="Arch name 2"/>
+          <p:cNvPr id="14" name="Arch name 2"/>
           <p:cNvSpPr txBox="1"/>
           <p:nvPr/>
         </p:nvSpPr>
@@ -11362,7 +12007,7 @@
       </p:sp>
       <p:sp>
         <p:nvSpPr>
-          <p:cNvPr id="13" name="Arch role 2"/>
+          <p:cNvPr id="15" name="Arch role 2"/>
           <p:cNvSpPr txBox="1"/>
           <p:nvPr/>
         </p:nvSpPr>
@@ -11412,7 +12057,7 @@
       </p:sp>
       <p:sp>
         <p:nvSpPr>
-          <p:cNvPr id="14" name="Arch arrow 2"/>
+          <p:cNvPr id="16" name="Arch arrow 2"/>
           <p:cNvSpPr/>
           <p:nvPr/>
         </p:nvSpPr>
@@ -11437,7 +12082,7 @@
       </p:sp>
       <p:sp>
         <p:nvSpPr>
-          <p:cNvPr id="15" name="Arch box 3"/>
+          <p:cNvPr id="17" name="Arch box 3"/>
           <p:cNvSpPr/>
           <p:nvPr/>
         </p:nvSpPr>
@@ -11446,7 +12091,7 @@
             <a:off x="5149901" y="1371600"/>
             <a:ext cx="1889150" cy="1828800"/>
           </a:xfrm>
-          <a:prstGeom prst="roundRect">
+          <a:prstGeom prst="rect">
             <a:avLst>
               <a:gd name="adj" fmla="val 6000"/>
             </a:avLst>
@@ -11464,7 +12109,7 @@
       </p:sp>
       <p:sp>
         <p:nvSpPr>
-          <p:cNvPr id="16" name="Arch icon 3 circle"/>
+          <p:cNvPr id="18" name="Arch icon 3 circle"/>
           <p:cNvSpPr/>
           <p:nvPr/>
         </p:nvSpPr>
@@ -11473,7 +12118,7 @@
             <a:off x="5820156" y="1481328"/>
             <a:ext cx="548640" cy="548640"/>
           </a:xfrm>
-          <a:prstGeom prst="ellipse">
+          <a:prstGeom prst="rect">
             <a:avLst/>
           </a:prstGeom>
           <a:solidFill>
@@ -11489,7 +12134,7 @@
       </p:sp>
       <p:pic>
         <p:nvPicPr>
-          <p:cNvPr id="17" name="Arch icon 3 icon" descr="Arch icon 3">    </p:cNvPr>
+          <p:cNvPr id="19" name="Arch icon 3 icon" descr="Arch icon 3">    </p:cNvPr>
           <p:cNvPicPr>
             <a:picLocks noChangeAspect="1"/>
           </p:cNvPicPr>
@@ -11513,7 +12158,7 @@
       </p:pic>
       <p:sp>
         <p:nvSpPr>
-          <p:cNvPr id="18" name="Arch name 3"/>
+          <p:cNvPr id="20" name="Arch name 3"/>
           <p:cNvSpPr txBox="1"/>
           <p:nvPr/>
         </p:nvSpPr>
@@ -11549,7 +12194,7 @@
       </p:sp>
       <p:sp>
         <p:nvSpPr>
-          <p:cNvPr id="19" name="Arch role 3"/>
+          <p:cNvPr id="21" name="Arch role 3"/>
           <p:cNvSpPr txBox="1"/>
           <p:nvPr/>
         </p:nvSpPr>
@@ -11599,7 +12244,7 @@
       </p:sp>
       <p:sp>
         <p:nvSpPr>
-          <p:cNvPr id="20" name="Arch arrow 3"/>
+          <p:cNvPr id="22" name="Arch arrow 3"/>
           <p:cNvSpPr/>
           <p:nvPr/>
         </p:nvSpPr>
@@ -11624,7 +12269,7 @@
       </p:sp>
       <p:sp>
         <p:nvSpPr>
-          <p:cNvPr id="21" name="Arch box 4"/>
+          <p:cNvPr id="23" name="Arch box 4"/>
           <p:cNvSpPr/>
           <p:nvPr/>
         </p:nvSpPr>
@@ -11633,7 +12278,7 @@
             <a:off x="7450531" y="1371600"/>
             <a:ext cx="1889150" cy="1828800"/>
           </a:xfrm>
-          <a:prstGeom prst="roundRect">
+          <a:prstGeom prst="rect">
             <a:avLst>
               <a:gd name="adj" fmla="val 6000"/>
             </a:avLst>
@@ -11651,7 +12296,7 @@
       </p:sp>
       <p:sp>
         <p:nvSpPr>
-          <p:cNvPr id="22" name="Arch icon 4 circle"/>
+          <p:cNvPr id="24" name="Arch icon 4 circle"/>
           <p:cNvSpPr/>
           <p:nvPr/>
         </p:nvSpPr>
@@ -11660,7 +12305,7 @@
             <a:off x="8120786" y="1481328"/>
             <a:ext cx="548640" cy="548640"/>
           </a:xfrm>
-          <a:prstGeom prst="ellipse">
+          <a:prstGeom prst="rect">
             <a:avLst/>
           </a:prstGeom>
           <a:solidFill>
@@ -11676,7 +12321,7 @@
       </p:sp>
       <p:pic>
         <p:nvPicPr>
-          <p:cNvPr id="23" name="Arch icon 4 icon" descr="Arch icon 4">    </p:cNvPr>
+          <p:cNvPr id="25" name="Arch icon 4 icon" descr="Arch icon 4">    </p:cNvPr>
           <p:cNvPicPr>
             <a:picLocks noChangeAspect="1"/>
           </p:cNvPicPr>
@@ -11700,7 +12345,7 @@
       </p:pic>
       <p:sp>
         <p:nvSpPr>
-          <p:cNvPr id="24" name="Arch name 4"/>
+          <p:cNvPr id="26" name="Arch name 4"/>
           <p:cNvSpPr txBox="1"/>
           <p:nvPr/>
         </p:nvSpPr>
@@ -11736,7 +12381,7 @@
       </p:sp>
       <p:sp>
         <p:nvSpPr>
-          <p:cNvPr id="25" name="Arch role 4"/>
+          <p:cNvPr id="27" name="Arch role 4"/>
           <p:cNvSpPr txBox="1"/>
           <p:nvPr/>
         </p:nvSpPr>
@@ -11786,7 +12431,7 @@
       </p:sp>
       <p:sp>
         <p:nvSpPr>
-          <p:cNvPr id="26" name="Arch arrow 4"/>
+          <p:cNvPr id="28" name="Arch arrow 4"/>
           <p:cNvSpPr/>
           <p:nvPr/>
         </p:nvSpPr>
@@ -11811,7 +12456,7 @@
       </p:sp>
       <p:sp>
         <p:nvSpPr>
-          <p:cNvPr id="27" name="Arch box 5"/>
+          <p:cNvPr id="29" name="Arch box 5"/>
           <p:cNvSpPr/>
           <p:nvPr/>
         </p:nvSpPr>
@@ -11820,7 +12465,7 @@
             <a:off x="9751162" y="1371600"/>
             <a:ext cx="1889150" cy="1828800"/>
           </a:xfrm>
-          <a:prstGeom prst="roundRect">
+          <a:prstGeom prst="rect">
             <a:avLst>
               <a:gd name="adj" fmla="val 6000"/>
             </a:avLst>
@@ -11838,7 +12483,7 @@
       </p:sp>
       <p:sp>
         <p:nvSpPr>
-          <p:cNvPr id="28" name="Arch icon 5 circle"/>
+          <p:cNvPr id="30" name="Arch icon 5 circle"/>
           <p:cNvSpPr/>
           <p:nvPr/>
         </p:nvSpPr>
@@ -11847,7 +12492,7 @@
             <a:off x="10421417" y="1481328"/>
             <a:ext cx="548640" cy="548640"/>
           </a:xfrm>
-          <a:prstGeom prst="ellipse">
+          <a:prstGeom prst="rect">
             <a:avLst/>
           </a:prstGeom>
           <a:solidFill>
@@ -11863,7 +12508,7 @@
       </p:sp>
       <p:pic>
         <p:nvPicPr>
-          <p:cNvPr id="29" name="Arch icon 5 icon" descr="Arch icon 5">    </p:cNvPr>
+          <p:cNvPr id="31" name="Arch icon 5 icon" descr="Arch icon 5">    </p:cNvPr>
           <p:cNvPicPr>
             <a:picLocks noChangeAspect="1"/>
           </p:cNvPicPr>
@@ -11887,7 +12532,7 @@
       </p:pic>
       <p:sp>
         <p:nvSpPr>
-          <p:cNvPr id="30" name="Arch name 5"/>
+          <p:cNvPr id="32" name="Arch name 5"/>
           <p:cNvSpPr txBox="1"/>
           <p:nvPr/>
         </p:nvSpPr>
@@ -11923,7 +12568,7 @@
       </p:sp>
       <p:sp>
         <p:nvSpPr>
-          <p:cNvPr id="31" name="Arch role 5"/>
+          <p:cNvPr id="33" name="Arch role 5"/>
           <p:cNvSpPr txBox="1"/>
           <p:nvPr/>
         </p:nvSpPr>
@@ -11973,7 +12618,7 @@
       </p:sp>
       <p:sp>
         <p:nvSpPr>
-          <p:cNvPr id="32" name="AI link db"/>
+          <p:cNvPr id="34" name="AI link db"/>
           <p:cNvSpPr/>
           <p:nvPr/>
         </p:nvSpPr>
@@ -11996,7 +12641,7 @@
       </p:sp>
       <p:sp>
         <p:nvSpPr>
-          <p:cNvPr id="33" name="AI link api"/>
+          <p:cNvPr id="35" name="AI link api"/>
           <p:cNvSpPr/>
           <p:nvPr/>
         </p:nvSpPr>
@@ -12019,7 +12664,7 @@
       </p:sp>
       <p:sp>
         <p:nvSpPr>
-          <p:cNvPr id="34" name="AI module"/>
+          <p:cNvPr id="36" name="AI module"/>
           <p:cNvSpPr/>
           <p:nvPr/>
         </p:nvSpPr>
@@ -12028,7 +12673,7 @@
             <a:off x="5180076" y="3520440"/>
             <a:ext cx="4129430" cy="566928"/>
           </a:xfrm>
-          <a:prstGeom prst="roundRect">
+          <a:prstGeom prst="rect">
             <a:avLst>
               <a:gd name="adj" fmla="val 16129"/>
             </a:avLst>
@@ -12046,7 +12691,7 @@
       </p:sp>
       <p:sp>
         <p:nvSpPr>
-          <p:cNvPr id="35" name="AI module text"/>
+          <p:cNvPr id="37" name="AI module text"/>
           <p:cNvSpPr txBox="1"/>
           <p:nvPr/>
         </p:nvSpPr>
@@ -12090,7 +12735,7 @@
       </p:sp>
       <p:sp>
         <p:nvSpPr>
-          <p:cNvPr id="36" name="Why header"/>
+          <p:cNvPr id="38" name="Why header"/>
           <p:cNvSpPr txBox="1"/>
           <p:nvPr/>
         </p:nvSpPr>
@@ -12126,7 +12771,7 @@
       </p:sp>
       <p:sp>
         <p:nvSpPr>
-          <p:cNvPr id="37" name="Why card 1"/>
+          <p:cNvPr id="39" name="Why card 1"/>
           <p:cNvSpPr/>
           <p:nvPr/>
         </p:nvSpPr>
@@ -12135,7 +12780,7 @@
             <a:off x="548640" y="4773168"/>
             <a:ext cx="2606040" cy="1261872"/>
           </a:xfrm>
-          <a:prstGeom prst="roundRect">
+          <a:prstGeom prst="rect">
             <a:avLst>
               <a:gd name="adj" fmla="val 7246"/>
             </a:avLst>
@@ -12153,7 +12798,7 @@
       </p:sp>
       <p:sp>
         <p:nvSpPr>
-          <p:cNvPr id="38" name="Why text 1"/>
+          <p:cNvPr id="40" name="Why text 1"/>
           <p:cNvSpPr txBox="1"/>
           <p:nvPr/>
         </p:nvSpPr>
@@ -12209,7 +12854,7 @@
       </p:sp>
       <p:sp>
         <p:nvSpPr>
-          <p:cNvPr id="39" name="Why card 2"/>
+          <p:cNvPr id="41" name="Why card 2"/>
           <p:cNvSpPr/>
           <p:nvPr/>
         </p:nvSpPr>
@@ -12218,7 +12863,7 @@
             <a:off x="3376879" y="4773168"/>
             <a:ext cx="2606040" cy="1261872"/>
           </a:xfrm>
-          <a:prstGeom prst="roundRect">
+          <a:prstGeom prst="rect">
             <a:avLst>
               <a:gd name="adj" fmla="val 7246"/>
             </a:avLst>
@@ -12236,7 +12881,7 @@
       </p:sp>
       <p:sp>
         <p:nvSpPr>
-          <p:cNvPr id="40" name="Why text 2"/>
+          <p:cNvPr id="42" name="Why text 2"/>
           <p:cNvSpPr txBox="1"/>
           <p:nvPr/>
         </p:nvSpPr>
@@ -12292,7 +12937,7 @@
       </p:sp>
       <p:sp>
         <p:nvSpPr>
-          <p:cNvPr id="41" name="Why card 3"/>
+          <p:cNvPr id="43" name="Why card 3"/>
           <p:cNvSpPr/>
           <p:nvPr/>
         </p:nvSpPr>
@@ -12301,7 +12946,7 @@
             <a:off x="6205118" y="4773168"/>
             <a:ext cx="2606040" cy="1261872"/>
           </a:xfrm>
-          <a:prstGeom prst="roundRect">
+          <a:prstGeom prst="rect">
             <a:avLst>
               <a:gd name="adj" fmla="val 7246"/>
             </a:avLst>
@@ -12319,7 +12964,7 @@
       </p:sp>
       <p:sp>
         <p:nvSpPr>
-          <p:cNvPr id="42" name="Why text 3"/>
+          <p:cNvPr id="44" name="Why text 3"/>
           <p:cNvSpPr txBox="1"/>
           <p:nvPr/>
         </p:nvSpPr>
@@ -12375,7 +13020,7 @@
       </p:sp>
       <p:sp>
         <p:nvSpPr>
-          <p:cNvPr id="43" name="Why card 4"/>
+          <p:cNvPr id="45" name="Why card 4"/>
           <p:cNvSpPr/>
           <p:nvPr/>
         </p:nvSpPr>
@@ -12384,7 +13029,7 @@
             <a:off x="9033358" y="4773168"/>
             <a:ext cx="2606040" cy="1261872"/>
           </a:xfrm>
-          <a:prstGeom prst="roundRect">
+          <a:prstGeom prst="rect">
             <a:avLst>
               <a:gd name="adj" fmla="val 7246"/>
             </a:avLst>
@@ -12402,7 +13047,7 @@
       </p:sp>
       <p:sp>
         <p:nvSpPr>
-          <p:cNvPr id="44" name="Why text 4"/>
+          <p:cNvPr id="46" name="Why text 4"/>
           <p:cNvSpPr txBox="1"/>
           <p:nvPr/>
         </p:nvSpPr>
@@ -12536,8 +13181,8 @@
         </p:nvSpPr>
         <p:spPr>
           <a:xfrm>
-            <a:off x="548640" y="320040"/>
-            <a:ext cx="11091672" cy="777240"/>
+            <a:off x="1417320" y="320040"/>
+            <a:ext cx="10222992" cy="777240"/>
           </a:xfrm>
           <a:prstGeom prst="rect">
             <a:avLst/>
@@ -12557,19 +13202,83 @@
                 <a:solidFill>
                   <a:schemeClr val="tx2"/>
                 </a:solidFill>
-                <a:latin typeface="Cambria" pitchFamily="34" charset="0"/>
-                <a:ea typeface="Cambria" pitchFamily="34" charset="-122"/>
-                <a:cs typeface="Cambria" pitchFamily="34" charset="-120"/>
+                <a:latin typeface="Arial" pitchFamily="34" charset="0"/>
+                <a:ea typeface="Arial" pitchFamily="34" charset="-122"/>
+                <a:cs typeface="Arial" pitchFamily="34" charset="-120"/>
               </a:rPr>
               <a:t>Kết quả chạy thử và liên kết với sản phẩm</a:t>
             </a:r>
             <a:endParaRPr lang="en-US" sz="3200" dirty="0"/>
+          </a:p>
+        </p:txBody>
+      </p:sp>
+      <p:sp>
+        <p:nvSpPr>
+          <p:cNvPr id="3" name="Slide tag"/>
+          <p:cNvSpPr/>
+          <p:nvPr/>
+        </p:nvSpPr>
+        <p:spPr>
+          <a:xfrm>
+            <a:off x="548640" y="457200"/>
+            <a:ext cx="685800" cy="502920"/>
+          </a:xfrm>
+          <a:prstGeom prst="rect">
+            <a:avLst/>
+          </a:prstGeom>
+          <a:solidFill>
+            <a:schemeClr val="accent2"/>
+          </a:solidFill>
+          <a:ln w="12700">
+            <a:solidFill>
+              <a:schemeClr val="accent2"/>
+            </a:solidFill>
+            <a:prstDash val="solid"/>
+          </a:ln>
+        </p:spPr>
+      </p:sp>
+      <p:sp>
+        <p:nvSpPr>
+          <p:cNvPr id="4" name="Slide tag number"/>
+          <p:cNvSpPr txBox="1"/>
+          <p:nvPr/>
+        </p:nvSpPr>
+        <p:spPr>
+          <a:xfrm>
+            <a:off x="548640" y="457200"/>
+            <a:ext cx="685800" cy="502920"/>
+          </a:xfrm>
+          <a:prstGeom prst="rect">
+            <a:avLst/>
+          </a:prstGeom>
+          <a:noFill/>
+          <a:ln/>
+        </p:spPr>
+        <p:txBody>
+          <a:bodyPr wrap="square" lIns="0" tIns="0" rIns="0" bIns="0" rtlCol="0" anchor="ctr"/>
+          <a:lstStyle/>
+          <a:p>
+            <a:pPr algn="ctr" indent="0" marL="0">
+              <a:buNone/>
+            </a:pPr>
+            <a:r>
+              <a:rPr lang="en-US" sz="2000" b="1" dirty="0">
+                <a:solidFill>
+                  <a:schemeClr val="tx2"/>
+                </a:solidFill>
+                <a:latin typeface="Arial" pitchFamily="34" charset="0"/>
+                <a:ea typeface="Arial" pitchFamily="34" charset="-122"/>
+                <a:cs typeface="Arial" pitchFamily="34" charset="-120"/>
+              </a:rPr>
+              <a:t>09</a:t>
+            </a:r>
+            <a:endParaRPr lang="en-US" sz="2000" dirty="0"/>
           </a:p>
         </p:txBody>
       </p:sp>
       <p:graphicFrame>
         <p:nvGraphicFramePr>
-          <p:cNvPr id="3" name="Funnel chart" descr=""/>
+          <p:cNvPr id="5" name="Funnel chart" descr=""/>
           <p:cNvGraphicFramePr/>
           <p:nvPr/>
         </p:nvGraphicFramePr>
@@ -12585,7 +13294,7 @@
       </p:graphicFrame>
       <p:sp>
         <p:nvSpPr>
-          <p:cNvPr id="4" name="Stat tile 1"/>
+          <p:cNvPr id="6" name="Stat tile 1"/>
           <p:cNvSpPr/>
           <p:nvPr/>
         </p:nvSpPr>
@@ -12594,7 +13303,7 @@
             <a:off x="6675120" y="1371600"/>
             <a:ext cx="2414016" cy="1161288"/>
           </a:xfrm>
-          <a:prstGeom prst="roundRect">
+          <a:prstGeom prst="rect">
             <a:avLst>
               <a:gd name="adj" fmla="val 7874"/>
             </a:avLst>
@@ -12612,7 +13321,7 @@
       </p:sp>
       <p:sp>
         <p:nvSpPr>
-          <p:cNvPr id="5" name="Stat text 1"/>
+          <p:cNvPr id="7" name="Stat text 1"/>
           <p:cNvSpPr txBox="1"/>
           <p:nvPr/>
         </p:nvSpPr>
@@ -12662,7 +13371,7 @@
       </p:sp>
       <p:sp>
         <p:nvSpPr>
-          <p:cNvPr id="6" name="Stat tile 2"/>
+          <p:cNvPr id="8" name="Stat tile 2"/>
           <p:cNvSpPr/>
           <p:nvPr/>
         </p:nvSpPr>
@@ -12671,7 +13380,7 @@
             <a:off x="9226296" y="1371600"/>
             <a:ext cx="2414016" cy="1161288"/>
           </a:xfrm>
-          <a:prstGeom prst="roundRect">
+          <a:prstGeom prst="rect">
             <a:avLst>
               <a:gd name="adj" fmla="val 7874"/>
             </a:avLst>
@@ -12689,7 +13398,7 @@
       </p:sp>
       <p:sp>
         <p:nvSpPr>
-          <p:cNvPr id="7" name="Stat text 2"/>
+          <p:cNvPr id="9" name="Stat text 2"/>
           <p:cNvSpPr txBox="1"/>
           <p:nvPr/>
         </p:nvSpPr>
@@ -12739,7 +13448,7 @@
       </p:sp>
       <p:sp>
         <p:nvSpPr>
-          <p:cNvPr id="8" name="Stat tile 3"/>
+          <p:cNvPr id="10" name="Stat tile 3"/>
           <p:cNvSpPr/>
           <p:nvPr/>
         </p:nvSpPr>
@@ -12748,7 +13457,7 @@
             <a:off x="6675120" y="2670048"/>
             <a:ext cx="2414016" cy="1161288"/>
           </a:xfrm>
-          <a:prstGeom prst="roundRect">
+          <a:prstGeom prst="rect">
             <a:avLst>
               <a:gd name="adj" fmla="val 7874"/>
             </a:avLst>
@@ -12766,7 +13475,7 @@
       </p:sp>
       <p:sp>
         <p:nvSpPr>
-          <p:cNvPr id="9" name="Stat text 3"/>
+          <p:cNvPr id="11" name="Stat text 3"/>
           <p:cNvSpPr txBox="1"/>
           <p:nvPr/>
         </p:nvSpPr>
@@ -12816,7 +13525,7 @@
       </p:sp>
       <p:sp>
         <p:nvSpPr>
-          <p:cNvPr id="10" name="Stat tile 4"/>
+          <p:cNvPr id="12" name="Stat tile 4"/>
           <p:cNvSpPr/>
           <p:nvPr/>
         </p:nvSpPr>
@@ -12825,7 +13534,7 @@
             <a:off x="9226296" y="2670048"/>
             <a:ext cx="2414016" cy="1161288"/>
           </a:xfrm>
-          <a:prstGeom prst="roundRect">
+          <a:prstGeom prst="rect">
             <a:avLst>
               <a:gd name="adj" fmla="val 7874"/>
             </a:avLst>
@@ -12843,7 +13552,7 @@
       </p:sp>
       <p:sp>
         <p:nvSpPr>
-          <p:cNvPr id="11" name="Stat text 4"/>
+          <p:cNvPr id="13" name="Stat text 4"/>
           <p:cNvSpPr txBox="1"/>
           <p:nvPr/>
         </p:nvSpPr>
@@ -12893,7 +13602,7 @@
       </p:sp>
       <p:sp>
         <p:nvSpPr>
-          <p:cNvPr id="12" name="Link card"/>
+          <p:cNvPr id="14" name="Link card"/>
           <p:cNvSpPr/>
           <p:nvPr/>
         </p:nvSpPr>
@@ -12902,7 +13611,7 @@
             <a:off x="6675120" y="4041648"/>
             <a:ext cx="4965192" cy="1993392"/>
           </a:xfrm>
-          <a:prstGeom prst="roundRect">
+          <a:prstGeom prst="rect">
             <a:avLst>
               <a:gd name="adj" fmla="val 4587"/>
             </a:avLst>
@@ -12920,7 +13629,7 @@
       </p:sp>
       <p:sp>
         <p:nvSpPr>
-          <p:cNvPr id="13" name="Run command"/>
+          <p:cNvPr id="15" name="Run command"/>
           <p:cNvSpPr txBox="1"/>
           <p:nvPr/>
         </p:nvSpPr>
@@ -12959,7 +13668,7 @@
       </p:sp>
       <p:sp>
         <p:nvSpPr>
-          <p:cNvPr id="14" name="Link bullets"/>
+          <p:cNvPr id="16" name="Link bullets"/>
           <p:cNvSpPr txBox="1"/>
           <p:nvPr/>
         </p:nvSpPr>
@@ -13087,49 +13796,49 @@
 </file>
 
 <file path=ppt/theme/theme1.xml><?xml version="1.0" encoding="utf-8"?>
-<a:theme xmlns:a="http://schemas.openxmlformats.org/drawingml/2006/main" name="Recruitment Teal">
+<a:theme xmlns:a="http://schemas.openxmlformats.org/drawingml/2006/main" name="Recruitment Charcoal">
   <a:themeElements>
-    <a:clrScheme name="Recruitment Teal">
+    <a:clrScheme name="Recruitment Charcoal">
       <a:dk1>
-        <a:srgbClr val="1B2A2F"/>
+        <a:srgbClr val="22252E"/>
       </a:dk1>
       <a:lt1>
         <a:srgbClr val="FFFFFF"/>
       </a:lt1>
       <a:dk2>
-        <a:srgbClr val="0B3C49"/>
+        <a:srgbClr val="2D3142"/>
       </a:dk2>
       <a:lt2>
-        <a:srgbClr val="EAF2F2"/>
+        <a:srgbClr val="F4F4F6"/>
       </a:lt2>
       <a:accent1>
-        <a:srgbClr val="1F7A7A"/>
+        <a:srgbClr val="4F5D75"/>
       </a:accent1>
       <a:accent2>
-        <a:srgbClr val="F2A541"/>
+        <a:srgbClr val="EF8354"/>
       </a:accent2>
       <a:accent3>
-        <a:srgbClr val="D9534F"/>
+        <a:srgbClr val="C0392B"/>
       </a:accent3>
       <a:accent4>
-        <a:srgbClr val="5E6B70"/>
+        <a:srgbClr val="6B7280"/>
       </a:accent4>
       <a:accent5>
-        <a:srgbClr val="3E8E63"/>
+        <a:srgbClr val="237A4B"/>
       </a:accent5>
       <a:accent6>
-        <a:srgbClr val="BFD8D8"/>
+        <a:srgbClr val="D9DCE3"/>
       </a:accent6>
       <a:hlink>
-        <a:srgbClr val="1F7A7A"/>
+        <a:srgbClr val="4F5D75"/>
       </a:hlink>
       <a:folHlink>
-        <a:srgbClr val="5E6B70"/>
+        <a:srgbClr val="6B7280"/>
       </a:folHlink>
     </a:clrScheme>
-    <a:fontScheme name="Recruitment Teal">
+    <a:fontScheme name="Recruitment Charcoal">
       <a:majorFont>
-        <a:latin typeface="Cambria"/>
+        <a:latin typeface="Arial"/>
         <a:ea typeface=""/>
         <a:cs typeface=""/>
         <a:font script="Jpan" typeface="游ゴシック Light"/>

</xml_diff>